<commit_message>
Refine guide deck: generic Confluence LADR requirements and latest report matrix.
Adds MSC-205625, MSC-204417, MSC-195138 8-card metrics slide; removes ESS-specific wording.

Co-authored-by: Cursor <cursoragent@cursor.com>
</commit_message>
<xml_diff>
--- a/docs/MSC-Dev-Code-and-QA-Test-Coverage-Validator-Guide.pptx
+++ b/docs/MSC-Dev-Code-and-QA-Test-Coverage-Validator-Guide.pptx
@@ -28,6 +28,7 @@
     <p:sldId id="276" r:id="rId27"/>
     <p:sldId id="277" r:id="rId28"/>
     <p:sldId id="278" r:id="rId29"/>
+    <p:sldId id="279" r:id="rId30"/>
   </p:sldIdLst>
   <p:sldSz cx="12191695" cy="6858000" type="screen4x3"/>
   <p:notesSz cx="6858000" cy="9144000"/>
@@ -9700,7 +9701,7 @@
               </a:defRPr>
             </a:pPr>
             <a:r>
-              <a:t>MSC-205625 · Domino Test Plan.xlsx · Inc as Fulll · 5/5 Given/When/Then · PR #161 pick-genie · MERGED · CI Passed</a:t>
+              <a:t>MSC-205625 · Domino · Inc as Fulll · 5/5 GWT · 3/4 AC · PR #161 pick-genie · MERGED · CI Passed</a:t>
             </a:r>
           </a:p>
         </p:txBody>
@@ -11437,7 +11438,7 @@
               </a:defRPr>
             </a:pPr>
             <a:r>
-              <a:t>Confluence LADR — supplemental requirements from Jira</a:t>
+              <a:t>Confluence LADR requirements from Jira</a:t>
             </a:r>
           </a:p>
         </p:txBody>
@@ -11473,7 +11474,7 @@
               </a:defRPr>
             </a:pPr>
             <a:r>
-              <a:t>When a LADR doc is linked on the story, the agent fetches Confluence and merges ESS milestones with Jira acceptance criteria</a:t>
+              <a:t>When a LADR doc is linked on the story, the agent fetches Confluence and merges LADR requirements with Jira acceptance criteria</a:t>
             </a:r>
           </a:p>
         </p:txBody>
@@ -11636,7 +11637,7 @@
               </a:defRPr>
             </a:pPr>
             <a:r>
-              <a:t>• Dev note with ESS status codes (8000 / 9000)</a:t>
+              <a:t>• Linked design doc referenced in dev/QA comments</a:t>
             </a:r>
           </a:p>
         </p:txBody>
@@ -11672,7 +11673,7 @@
               </a:defRPr>
             </a:pPr>
             <a:r>
-              <a:t>• Test plan scenarios aligned to LADR milestones</a:t>
+              <a:t>• Test plan scenarios trace to LADR scope</a:t>
             </a:r>
           </a:p>
         </p:txBody>
@@ -11835,7 +11836,7 @@
               </a:defRPr>
             </a:pPr>
             <a:r>
-              <a:t>3. Parse ESS table: demandAcknowledgment, orderStatus, …</a:t>
+              <a:t>3. Parse LADR requirement items from page body</a:t>
             </a:r>
           </a:p>
         </p:txBody>
@@ -11998,7 +11999,7 @@
               </a:defRPr>
             </a:pPr>
             <a:r>
-              <a:t>→ LADR ESS → L1…Ln (task + status)</a:t>
+              <a:t>→ Confluence LADR → L1…Ln</a:t>
             </a:r>
           </a:p>
         </p:txBody>
@@ -12034,7 +12035,7 @@
               </a:defRPr>
             </a:pPr>
             <a:r>
-              <a:t>→ Test cases map to both via semantic match</a:t>
+              <a:t>→ Test cases map to both (semantic match)</a:t>
             </a:r>
           </a:p>
         </p:txBody>
@@ -12070,7 +12071,7 @@
               </a:defRPr>
             </a:pPr>
             <a:r>
-              <a:t>→ Coverage %: Jira AC + LADR scenarios</a:t>
+              <a:t>→ Test plan AC coverage % uses combined set</a:t>
             </a:r>
           </a:p>
         </p:txBody>
@@ -12151,7 +12152,7 @@
               </a:defRPr>
             </a:pPr>
             <a:r>
-              <a:t>Example — MSC-204417 (Caption Monitoring): Jira comment references LADR status codes; Promo Caption Monitoring.xlsx has 12 ESS scenarios (demandAcknowledgment Completed, orderStatus Failure, …). Agent infers LADR ESS requirements and maps test cases → 3/3 Jira AC + 13/14 LADR (gap: STATUS_ERROR 9000 / L14). Without Confluence merge, keyword-only mapping showed 0% — semantic LADR alignment fixes test plan coverage %.</a:t>
+              <a:t>Example — MSC-204417: Jira references a LADR doc; agent fetches Confluence LADR requirements and merges with Promo Caption Monitoring test plan (12 scenarios, Caption Monitoring · 12/12 GWT). Report MSC-204417-05-31-2026-10-19-28-IST.html: 100% dev code · 94.1% test plan AC · 16/17 AC mapped · Pass with gaps. Generic LADR parsing — not limited to one domain.</a:t>
             </a:r>
           </a:p>
         </p:txBody>
@@ -12206,7 +12207,7 @@
               </a:defRPr>
             </a:pPr>
             <a:r>
-              <a:t>LADR ESS milestones parsed into requirements</a:t>
+              <a:t>Any LADR-linked story — design requirements become testable L* items for coverage scoring</a:t>
             </a:r>
           </a:p>
         </p:txBody>
@@ -12261,7 +12262,7 @@
               </a:defRPr>
             </a:pPr>
             <a:r>
-              <a:t>demandAcknowledgment · Completed / Failure</a:t>
+              <a:t>Wiki URL or LADR comment on Jira</a:t>
             </a:r>
           </a:p>
         </p:txBody>
@@ -12316,7 +12317,7 @@
               </a:defRPr>
             </a:pPr>
             <a:r>
-              <a:t>manifestationAvailability · Pending / Completed</a:t>
+              <a:t>Confluence page body → requirement list</a:t>
             </a:r>
           </a:p>
         </p:txBody>
@@ -12371,7 +12372,7 @@
               </a:defRPr>
             </a:pPr>
             <a:r>
-              <a:t>orderStatus · Pending / Processing / Completed / Failure</a:t>
+              <a:t>Merged with Jira AC + Excel test plan</a:t>
             </a:r>
           </a:p>
         </p:txBody>
@@ -12426,7 +12427,7 @@
               </a:defRPr>
             </a:pPr>
             <a:r>
-              <a:t>registrationStatus · Pending / Completed / Failure</a:t>
+              <a:t>Gap list for unmapped L* / R* items</a:t>
             </a:r>
           </a:p>
         </p:txBody>
@@ -12682,7 +12683,7 @@
               </a:defRPr>
             </a:pPr>
             <a:r>
-              <a:t>Confluence ESS requirements when LADR is linked · Excel attachment · Given/When/Then · Mascot</a:t>
+              <a:t>Confluence LADR requirements when linked · Excel attachment · Given/When/Then · Mascot</a:t>
             </a:r>
           </a:p>
         </p:txBody>
@@ -12763,7 +12764,7 @@
               </a:defRPr>
             </a:pPr>
             <a:r>
-              <a:t>Confluence / LADR (from Jira)</a:t>
+              <a:t>Confluence LADR (from Jira)</a:t>
             </a:r>
           </a:p>
         </p:txBody>
@@ -12852,7 +12853,7 @@
               </a:defRPr>
             </a:pPr>
             <a:r>
-              <a:t>ESS milestones L1…Ln · cache {KEY}-confluence.json</a:t>
+              <a:t>LADR requirements L1…Ln · cache {KEY}-confluence.json</a:t>
             </a:r>
           </a:p>
         </p:txBody>
@@ -13192,7 +13193,7 @@
               </a:defRPr>
             </a:pPr>
             <a:r>
-              <a:t>12/12 full Given When Then (MSC-204417)</a:t>
+              <a:t>12/12 GWT · MSC-204417</a:t>
             </a:r>
           </a:p>
         </p:txBody>
@@ -13309,7 +13310,7 @@
               </a:defRPr>
             </a:pPr>
             <a:r>
-              <a:t>Semantic match: task + status (e.g. orderStatus Failure) → L* and R1…R3</a:t>
+              <a:t>Semantic match of test cases to Jira AC and Confluence LADR requirements</a:t>
             </a:r>
           </a:p>
         </p:txBody>
@@ -13362,7 +13363,7 @@
               </a:defRPr>
             </a:pPr>
             <a:r>
-              <a:t>94.1% combined coverage example</a:t>
+              <a:t>94.1% · MSC-204417</a:t>
             </a:r>
           </a:p>
         </p:txBody>
@@ -13642,7 +13643,7 @@
               </a:defRPr>
             </a:pPr>
             <a:r>
-              <a:t>MSC-204417 · Caption Monitoring · 13/14 LADR · 3/3 Jira AC</a:t>
+              <a:t>MSC-204417 · LADR requirements · 94.1% test plan AC</a:t>
             </a:r>
           </a:p>
         </p:txBody>
@@ -13697,7 +13698,62 @@
               </a:defRPr>
             </a:pPr>
             <a:r>
-              <a:t>MSC-205625 · Inc as Fulll · 5/5 Given/When/Then</a:t>
+              <a:t>MSC-205625 · Inc as Fulll · 75% test plan AC</a:t>
+            </a:r>
+          </a:p>
+        </p:txBody>
+      </p:sp>
+      <p:sp>
+        <p:nvSpPr>
+          <p:cNvPr id="31" name="Rectangle 30"/>
+          <p:cNvSpPr/>
+          <p:nvPr/>
+        </p:nvSpPr>
+        <p:spPr>
+          <a:xfrm>
+            <a:off x="6217920" y="6437376"/>
+            <a:ext cx="5440680" cy="320040"/>
+          </a:xfrm>
+          <a:prstGeom prst="rect">
+            <a:avLst/>
+          </a:prstGeom>
+          <a:solidFill>
+            <a:srgbClr val="F2F2F2"/>
+          </a:solidFill>
+          <a:ln w="6350">
+            <a:solidFill>
+              <a:srgbClr val="E2E8F0"/>
+            </a:solidFill>
+          </a:ln>
+        </p:spPr>
+        <p:style>
+          <a:lnRef idx="1">
+            <a:schemeClr val="accent1"/>
+          </a:lnRef>
+          <a:fillRef idx="3">
+            <a:schemeClr val="accent1"/>
+          </a:fillRef>
+          <a:effectRef idx="2">
+            <a:schemeClr val="accent1"/>
+          </a:effectRef>
+          <a:fontRef idx="minor">
+            <a:schemeClr val="lt1"/>
+          </a:fontRef>
+        </p:style>
+        <p:txBody>
+          <a:bodyPr rtlCol="0" anchor="ctr" wrap="square"/>
+          <a:lstStyle/>
+          <a:p>
+            <a:pPr algn="ctr">
+              <a:defRPr sz="900" b="0">
+                <a:solidFill>
+                  <a:srgbClr val="334155"/>
+                </a:solidFill>
+                <a:latin typeface="Calibri"/>
+              </a:defRPr>
+            </a:pPr>
+            <a:r>
+              <a:t>MSC-195138 · FF Race · 66.7% test plan AC</a:t>
             </a:r>
           </a:p>
         </p:txBody>
@@ -16140,7 +16196,7 @@
               </a:defRPr>
             </a:pPr>
             <a:r>
-              <a:t>Confluence ESS requirements (when LADR present)</a:t>
+              <a:t>Confluence LADR requirements (when linked)</a:t>
             </a:r>
           </a:p>
         </p:txBody>
@@ -17991,7 +18047,7 @@
               </a:defRPr>
             </a:pPr>
             <a:r>
-              <a:t>MSC case studies with real coverage metrics</a:t>
+              <a:t>MSC case studies · latest report matrix · real coverage metrics</a:t>
             </a:r>
           </a:p>
         </p:txBody>
@@ -18326,7 +18382,7 @@
               </a:defRPr>
             </a:pPr>
             <a:r>
-              <a:t>Proven MSC outcomes</a:t>
+              <a:t>Latest report matrix — 8-card coverage summary</a:t>
             </a:r>
           </a:p>
         </p:txBody>
@@ -18362,7 +18418,7 @@
               </a:defRPr>
             </a:pPr>
             <a:r>
-              <a:t>Real validator runs — Pegasus MSC project</a:t>
+              <a:t>From generated HTML reports · MSC-205625 · MSC-204417 · MSC-195138</a:t>
             </a:r>
           </a:p>
         </p:txBody>
@@ -18375,8 +18431,8 @@
         </p:nvSpPr>
         <p:spPr>
           <a:xfrm>
-            <a:off x="502920" y="1234440"/>
-            <a:ext cx="1508760" cy="384048"/>
+            <a:off x="502920" y="1207008"/>
+            <a:ext cx="1212088" cy="365760"/>
           </a:xfrm>
           <a:prstGeom prst="rect">
             <a:avLst/>
@@ -18409,7 +18465,7 @@
           <a:lstStyle/>
           <a:p>
             <a:pPr algn="ctr">
-              <a:defRPr sz="900" b="1">
+              <a:defRPr sz="800" b="1">
                 <a:solidFill>
                   <a:srgbClr val="FFFFFF"/>
                 </a:solidFill>
@@ -18430,8 +18486,8 @@
         </p:nvSpPr>
         <p:spPr>
           <a:xfrm>
-            <a:off x="2103120" y="1234440"/>
-            <a:ext cx="1508760" cy="384048"/>
+            <a:off x="1742440" y="1207008"/>
+            <a:ext cx="1212088" cy="365760"/>
           </a:xfrm>
           <a:prstGeom prst="rect">
             <a:avLst/>
@@ -18464,7 +18520,7 @@
           <a:lstStyle/>
           <a:p>
             <a:pPr algn="ctr">
-              <a:defRPr sz="900" b="1">
+              <a:defRPr sz="800" b="1">
                 <a:solidFill>
                   <a:srgbClr val="FFFFFF"/>
                 </a:solidFill>
@@ -18472,7 +18528,7 @@
               </a:defRPr>
             </a:pPr>
             <a:r>
-              <a:t>Type</a:t>
+              <a:t>Dev code</a:t>
             </a:r>
           </a:p>
         </p:txBody>
@@ -18485,8 +18541,8 @@
         </p:nvSpPr>
         <p:spPr>
           <a:xfrm>
-            <a:off x="3703320" y="1234440"/>
-            <a:ext cx="1508760" cy="384048"/>
+            <a:off x="2981960" y="1207008"/>
+            <a:ext cx="1212088" cy="365760"/>
           </a:xfrm>
           <a:prstGeom prst="rect">
             <a:avLst/>
@@ -18519,7 +18575,7 @@
           <a:lstStyle/>
           <a:p>
             <a:pPr algn="ctr">
-              <a:defRPr sz="900" b="1">
+              <a:defRPr sz="800" b="1">
                 <a:solidFill>
                   <a:srgbClr val="FFFFFF"/>
                 </a:solidFill>
@@ -18527,7 +18583,7 @@
               </a:defRPr>
             </a:pPr>
             <a:r>
-              <a:t>Code</a:t>
+              <a:t>Dev tests</a:t>
             </a:r>
           </a:p>
         </p:txBody>
@@ -18540,8 +18596,8 @@
         </p:nvSpPr>
         <p:spPr>
           <a:xfrm>
-            <a:off x="5303520" y="1234440"/>
-            <a:ext cx="1508760" cy="384048"/>
+            <a:off x="4221480" y="1207008"/>
+            <a:ext cx="1212088" cy="365760"/>
           </a:xfrm>
           <a:prstGeom prst="rect">
             <a:avLst/>
@@ -18574,7 +18630,7 @@
           <a:lstStyle/>
           <a:p>
             <a:pPr algn="ctr">
-              <a:defRPr sz="900" b="1">
+              <a:defRPr sz="800" b="1">
                 <a:solidFill>
                   <a:srgbClr val="FFFFFF"/>
                 </a:solidFill>
@@ -18582,7 +18638,7 @@
               </a:defRPr>
             </a:pPr>
             <a:r>
-              <a:t>Dev tests</a:t>
+              <a:t>Req mapped</a:t>
             </a:r>
           </a:p>
         </p:txBody>
@@ -18595,8 +18651,8 @@
         </p:nvSpPr>
         <p:spPr>
           <a:xfrm>
-            <a:off x="6903720" y="1234440"/>
-            <a:ext cx="1508760" cy="384048"/>
+            <a:off x="5461000" y="1207008"/>
+            <a:ext cx="1212088" cy="365760"/>
           </a:xfrm>
           <a:prstGeom prst="rect">
             <a:avLst/>
@@ -18629,7 +18685,7 @@
           <a:lstStyle/>
           <a:p>
             <a:pPr algn="ctr">
-              <a:defRPr sz="900" b="1">
+              <a:defRPr sz="800" b="1">
                 <a:solidFill>
                   <a:srgbClr val="FFFFFF"/>
                 </a:solidFill>
@@ -18637,7 +18693,7 @@
               </a:defRPr>
             </a:pPr>
             <a:r>
-              <a:t>Plan AC</a:t>
+              <a:t>Test plan AC</a:t>
             </a:r>
           </a:p>
         </p:txBody>
@@ -18650,8 +18706,8 @@
         </p:nvSpPr>
         <p:spPr>
           <a:xfrm>
-            <a:off x="8503920" y="1234440"/>
-            <a:ext cx="1508760" cy="384048"/>
+            <a:off x="6700520" y="1207008"/>
+            <a:ext cx="1212088" cy="365760"/>
           </a:xfrm>
           <a:prstGeom prst="rect">
             <a:avLst/>
@@ -18684,7 +18740,7 @@
           <a:lstStyle/>
           <a:p>
             <a:pPr algn="ctr">
-              <a:defRPr sz="900" b="1">
+              <a:defRPr sz="800" b="1">
                 <a:solidFill>
                   <a:srgbClr val="FFFFFF"/>
                 </a:solidFill>
@@ -18692,7 +18748,7 @@
               </a:defRPr>
             </a:pPr>
             <a:r>
-              <a:t>Verdict</a:t>
+              <a:t>QA scope</a:t>
             </a:r>
           </a:p>
         </p:txBody>
@@ -18705,8 +18761,8 @@
         </p:nvSpPr>
         <p:spPr>
           <a:xfrm>
-            <a:off x="10104120" y="1234440"/>
-            <a:ext cx="1508760" cy="384048"/>
+            <a:off x="7940040" y="1207008"/>
+            <a:ext cx="1212088" cy="365760"/>
           </a:xfrm>
           <a:prstGeom prst="rect">
             <a:avLst/>
@@ -18739,7 +18795,7 @@
           <a:lstStyle/>
           <a:p>
             <a:pPr algn="ctr">
-              <a:defRPr sz="900" b="1">
+              <a:defRPr sz="800" b="1">
                 <a:solidFill>
                   <a:srgbClr val="FFFFFF"/>
                 </a:solidFill>
@@ -18747,7 +18803,7 @@
               </a:defRPr>
             </a:pPr>
             <a:r>
-              <a:t>Notes</a:t>
+              <a:t>Open gaps</a:t>
             </a:r>
           </a:p>
         </p:txBody>
@@ -18760,14 +18816,14 @@
         </p:nvSpPr>
         <p:spPr>
           <a:xfrm>
-            <a:off x="502920" y="1691640"/>
-            <a:ext cx="1508760" cy="438912"/>
-          </a:xfrm>
-          <a:prstGeom prst="rect">
-            <a:avLst/>
-          </a:prstGeom>
-          <a:solidFill>
-            <a:srgbClr val="FFFFFF"/>
+            <a:off x="9179560" y="1207008"/>
+            <a:ext cx="1212088" cy="365760"/>
+          </a:xfrm>
+          <a:prstGeom prst="rect">
+            <a:avLst/>
+          </a:prstGeom>
+          <a:solidFill>
+            <a:srgbClr val="04066C"/>
           </a:solidFill>
           <a:ln w="6350">
             <a:solidFill>
@@ -18796,13 +18852,13 @@
             <a:pPr algn="ctr">
               <a:defRPr sz="800" b="1">
                 <a:solidFill>
-                  <a:srgbClr val="1A1A1A"/>
-                </a:solidFill>
-                <a:latin typeface="Calibri"/>
-              </a:defRPr>
-            </a:pPr>
-            <a:r>
-              <a:t>MSC-205625</a:t>
+                  <a:srgbClr val="FFFFFF"/>
+                </a:solidFill>
+                <a:latin typeface="Calibri"/>
+              </a:defRPr>
+            </a:pPr>
+            <a:r>
+              <a:t>CI line</a:t>
             </a:r>
           </a:p>
         </p:txBody>
@@ -18815,14 +18871,14 @@
         </p:nvSpPr>
         <p:spPr>
           <a:xfrm>
-            <a:off x="2103120" y="1691640"/>
-            <a:ext cx="1508760" cy="438912"/>
-          </a:xfrm>
-          <a:prstGeom prst="rect">
-            <a:avLst/>
-          </a:prstGeom>
-          <a:solidFill>
-            <a:srgbClr val="FFFFFF"/>
+            <a:off x="10419080" y="1207008"/>
+            <a:ext cx="1212088" cy="365760"/>
+          </a:xfrm>
+          <a:prstGeom prst="rect">
+            <a:avLst/>
+          </a:prstGeom>
+          <a:solidFill>
+            <a:srgbClr val="04066C"/>
           </a:solidFill>
           <a:ln w="6350">
             <a:solidFill>
@@ -18849,15 +18905,15 @@
           <a:lstStyle/>
           <a:p>
             <a:pPr algn="ctr">
-              <a:defRPr sz="800" b="0">
-                <a:solidFill>
-                  <a:srgbClr val="1A1A1A"/>
-                </a:solidFill>
-                <a:latin typeface="Calibri"/>
-              </a:defRPr>
-            </a:pPr>
-            <a:r>
-              <a:t>Bug · Ready for Release</a:t>
+              <a:defRPr sz="800" b="1">
+                <a:solidFill>
+                  <a:srgbClr val="FFFFFF"/>
+                </a:solidFill>
+                <a:latin typeface="Calibri"/>
+              </a:defRPr>
+            </a:pPr>
+            <a:r>
+              <a:t>Verdict</a:t>
             </a:r>
           </a:p>
         </p:txBody>
@@ -18870,8 +18926,8 @@
         </p:nvSpPr>
         <p:spPr>
           <a:xfrm>
-            <a:off x="3703320" y="1691640"/>
-            <a:ext cx="1508760" cy="438912"/>
+            <a:off x="502920" y="1627632"/>
+            <a:ext cx="1212088" cy="365760"/>
           </a:xfrm>
           <a:prstGeom prst="rect">
             <a:avLst/>
@@ -18904,15 +18960,15 @@
           <a:lstStyle/>
           <a:p>
             <a:pPr algn="ctr">
-              <a:defRPr sz="800" b="0">
-                <a:solidFill>
-                  <a:srgbClr val="16A34A"/>
-                </a:solidFill>
-                <a:latin typeface="Calibri"/>
-              </a:defRPr>
-            </a:pPr>
-            <a:r>
-              <a:t>100%</a:t>
+              <a:defRPr sz="700" b="1">
+                <a:solidFill>
+                  <a:srgbClr val="1A1A1A"/>
+                </a:solidFill>
+                <a:latin typeface="Calibri"/>
+              </a:defRPr>
+            </a:pPr>
+            <a:r>
+              <a:t>MSC-205625</a:t>
             </a:r>
           </a:p>
         </p:txBody>
@@ -18925,8 +18981,8 @@
         </p:nvSpPr>
         <p:spPr>
           <a:xfrm>
-            <a:off x="5303520" y="1691640"/>
-            <a:ext cx="1508760" cy="438912"/>
+            <a:off x="1742440" y="1627632"/>
+            <a:ext cx="1212088" cy="365760"/>
           </a:xfrm>
           <a:prstGeom prst="rect">
             <a:avLst/>
@@ -18959,15 +19015,15 @@
           <a:lstStyle/>
           <a:p>
             <a:pPr algn="ctr">
-              <a:defRPr sz="800" b="0">
-                <a:solidFill>
-                  <a:srgbClr val="D97706"/>
-                </a:solidFill>
-                <a:latin typeface="Calibri"/>
-              </a:defRPr>
-            </a:pPr>
-            <a:r>
-              <a:t>75%</a:t>
+              <a:defRPr sz="700" b="0">
+                <a:solidFill>
+                  <a:srgbClr val="16A34A"/>
+                </a:solidFill>
+                <a:latin typeface="Calibri"/>
+              </a:defRPr>
+            </a:pPr>
+            <a:r>
+              <a:t>100%</a:t>
             </a:r>
           </a:p>
         </p:txBody>
@@ -18980,8 +19036,8 @@
         </p:nvSpPr>
         <p:spPr>
           <a:xfrm>
-            <a:off x="6903720" y="1691640"/>
-            <a:ext cx="1508760" cy="438912"/>
+            <a:off x="2981960" y="1627632"/>
+            <a:ext cx="1212088" cy="365760"/>
           </a:xfrm>
           <a:prstGeom prst="rect">
             <a:avLst/>
@@ -19014,7 +19070,7 @@
           <a:lstStyle/>
           <a:p>
             <a:pPr algn="ctr">
-              <a:defRPr sz="800" b="0">
+              <a:defRPr sz="700" b="0">
                 <a:solidFill>
                   <a:srgbClr val="D97706"/>
                 </a:solidFill>
@@ -19035,8 +19091,8 @@
         </p:nvSpPr>
         <p:spPr>
           <a:xfrm>
-            <a:off x="8503920" y="1691640"/>
-            <a:ext cx="1508760" cy="438912"/>
+            <a:off x="4221480" y="1627632"/>
+            <a:ext cx="1212088" cy="365760"/>
           </a:xfrm>
           <a:prstGeom prst="rect">
             <a:avLst/>
@@ -19069,15 +19125,15 @@
           <a:lstStyle/>
           <a:p>
             <a:pPr algn="ctr">
-              <a:defRPr sz="800" b="0">
-                <a:solidFill>
-                  <a:srgbClr val="D97706"/>
-                </a:solidFill>
-                <a:latin typeface="Calibri"/>
-              </a:defRPr>
-            </a:pPr>
-            <a:r>
-              <a:t>Pass with gaps</a:t>
+              <a:defRPr sz="700" b="0">
+                <a:solidFill>
+                  <a:srgbClr val="334155"/>
+                </a:solidFill>
+                <a:latin typeface="Calibri"/>
+              </a:defRPr>
+            </a:pPr>
+            <a:r>
+              <a:t>4/4 AC</a:t>
             </a:r>
           </a:p>
         </p:txBody>
@@ -19090,8 +19146,8 @@
         </p:nvSpPr>
         <p:spPr>
           <a:xfrm>
-            <a:off x="10104120" y="1691640"/>
-            <a:ext cx="1508760" cy="438912"/>
+            <a:off x="5461000" y="1627632"/>
+            <a:ext cx="1212088" cy="365760"/>
           </a:xfrm>
           <a:prstGeom prst="rect">
             <a:avLst/>
@@ -19124,15 +19180,15 @@
           <a:lstStyle/>
           <a:p>
             <a:pPr algn="ctr">
-              <a:defRPr sz="800" b="0">
-                <a:solidFill>
-                  <a:srgbClr val="16A34A"/>
-                </a:solidFill>
-                <a:latin typeface="Calibri"/>
-              </a:defRPr>
-            </a:pPr>
-            <a:r>
-              <a:t>PR #161 · CI Passed · 5/5 GWT · R4 gap</a:t>
+              <a:defRPr sz="700" b="0">
+                <a:solidFill>
+                  <a:srgbClr val="D97706"/>
+                </a:solidFill>
+                <a:latin typeface="Calibri"/>
+              </a:defRPr>
+            </a:pPr>
+            <a:r>
+              <a:t>75%</a:t>
             </a:r>
           </a:p>
         </p:txBody>
@@ -19145,14 +19201,14 @@
         </p:nvSpPr>
         <p:spPr>
           <a:xfrm>
-            <a:off x="502920" y="2167128"/>
-            <a:ext cx="1508760" cy="438912"/>
-          </a:xfrm>
-          <a:prstGeom prst="rect">
-            <a:avLst/>
-          </a:prstGeom>
-          <a:solidFill>
-            <a:srgbClr val="F2F2F2"/>
+            <a:off x="6700520" y="1627632"/>
+            <a:ext cx="1212088" cy="365760"/>
+          </a:xfrm>
+          <a:prstGeom prst="rect">
+            <a:avLst/>
+          </a:prstGeom>
+          <a:solidFill>
+            <a:srgbClr val="FFFFFF"/>
           </a:solidFill>
           <a:ln w="6350">
             <a:solidFill>
@@ -19179,15 +19235,15 @@
           <a:lstStyle/>
           <a:p>
             <a:pPr algn="ctr">
-              <a:defRPr sz="800" b="1">
-                <a:solidFill>
-                  <a:srgbClr val="1A1A1A"/>
-                </a:solidFill>
-                <a:latin typeface="Calibri"/>
-              </a:defRPr>
-            </a:pPr>
-            <a:r>
-              <a:t>MSC-204417</a:t>
+              <a:defRPr sz="700" b="0">
+                <a:solidFill>
+                  <a:srgbClr val="334155"/>
+                </a:solidFill>
+                <a:latin typeface="Calibri"/>
+              </a:defRPr>
+            </a:pPr>
+            <a:r>
+              <a:t>1 item</a:t>
             </a:r>
           </a:p>
         </p:txBody>
@@ -19200,14 +19256,14 @@
         </p:nvSpPr>
         <p:spPr>
           <a:xfrm>
-            <a:off x="2103120" y="2167128"/>
-            <a:ext cx="1508760" cy="438912"/>
-          </a:xfrm>
-          <a:prstGeom prst="rect">
-            <a:avLst/>
-          </a:prstGeom>
-          <a:solidFill>
-            <a:srgbClr val="F2F2F2"/>
+            <a:off x="7940040" y="1627632"/>
+            <a:ext cx="1212088" cy="365760"/>
+          </a:xfrm>
+          <a:prstGeom prst="rect">
+            <a:avLst/>
+          </a:prstGeom>
+          <a:solidFill>
+            <a:srgbClr val="FFFFFF"/>
           </a:solidFill>
           <a:ln w="6350">
             <a:solidFill>
@@ -19234,15 +19290,15 @@
           <a:lstStyle/>
           <a:p>
             <a:pPr algn="ctr">
-              <a:defRPr sz="800" b="0">
-                <a:solidFill>
-                  <a:srgbClr val="1A1A1A"/>
-                </a:solidFill>
-                <a:latin typeface="Calibri"/>
-              </a:defRPr>
-            </a:pPr>
-            <a:r>
-              <a:t>Story · In QA</a:t>
+              <a:defRPr sz="700" b="0">
+                <a:solidFill>
+                  <a:srgbClr val="334155"/>
+                </a:solidFill>
+                <a:latin typeface="Calibri"/>
+              </a:defRPr>
+            </a:pPr>
+            <a:r>
+              <a:t>2 Med</a:t>
             </a:r>
           </a:p>
         </p:txBody>
@@ -19255,14 +19311,14 @@
         </p:nvSpPr>
         <p:spPr>
           <a:xfrm>
-            <a:off x="3703320" y="2167128"/>
-            <a:ext cx="1508760" cy="438912"/>
-          </a:xfrm>
-          <a:prstGeom prst="rect">
-            <a:avLst/>
-          </a:prstGeom>
-          <a:solidFill>
-            <a:srgbClr val="F2F2F2"/>
+            <a:off x="9179560" y="1627632"/>
+            <a:ext cx="1212088" cy="365760"/>
+          </a:xfrm>
+          <a:prstGeom prst="rect">
+            <a:avLst/>
+          </a:prstGeom>
+          <a:solidFill>
+            <a:srgbClr val="FFFFFF"/>
           </a:solidFill>
           <a:ln w="6350">
             <a:solidFill>
@@ -19289,15 +19345,15 @@
           <a:lstStyle/>
           <a:p>
             <a:pPr algn="ctr">
-              <a:defRPr sz="800" b="0">
-                <a:solidFill>
-                  <a:srgbClr val="16A34A"/>
-                </a:solidFill>
-                <a:latin typeface="Calibri"/>
-              </a:defRPr>
-            </a:pPr>
-            <a:r>
-              <a:t>100%</a:t>
+              <a:defRPr sz="700" b="0">
+                <a:solidFill>
+                  <a:srgbClr val="334155"/>
+                </a:solidFill>
+                <a:latin typeface="Calibri"/>
+              </a:defRPr>
+            </a:pPr>
+            <a:r>
+              <a:t>95.3%</a:t>
             </a:r>
           </a:p>
         </p:txBody>
@@ -19310,14 +19366,14 @@
         </p:nvSpPr>
         <p:spPr>
           <a:xfrm>
-            <a:off x="5303520" y="2167128"/>
-            <a:ext cx="1508760" cy="438912"/>
-          </a:xfrm>
-          <a:prstGeom prst="rect">
-            <a:avLst/>
-          </a:prstGeom>
-          <a:solidFill>
-            <a:srgbClr val="F2F2F2"/>
+            <a:off x="10419080" y="1627632"/>
+            <a:ext cx="1212088" cy="365760"/>
+          </a:xfrm>
+          <a:prstGeom prst="rect">
+            <a:avLst/>
+          </a:prstGeom>
+          <a:solidFill>
+            <a:srgbClr val="FFFFFF"/>
           </a:solidFill>
           <a:ln w="6350">
             <a:solidFill>
@@ -19344,7 +19400,7 @@
           <a:lstStyle/>
           <a:p>
             <a:pPr algn="ctr">
-              <a:defRPr sz="800" b="0">
+              <a:defRPr sz="700" b="0">
                 <a:solidFill>
                   <a:srgbClr val="D97706"/>
                 </a:solidFill>
@@ -19352,7 +19408,7 @@
               </a:defRPr>
             </a:pPr>
             <a:r>
-              <a:t>83%</a:t>
+              <a:t>Pass w/ gaps</a:t>
             </a:r>
           </a:p>
         </p:txBody>
@@ -19365,8 +19421,8 @@
         </p:nvSpPr>
         <p:spPr>
           <a:xfrm>
-            <a:off x="6903720" y="2167128"/>
-            <a:ext cx="1508760" cy="438912"/>
+            <a:off x="502920" y="2029968"/>
+            <a:ext cx="1212088" cy="365760"/>
           </a:xfrm>
           <a:prstGeom prst="rect">
             <a:avLst/>
@@ -19399,15 +19455,15 @@
           <a:lstStyle/>
           <a:p>
             <a:pPr algn="ctr">
-              <a:defRPr sz="800" b="0">
-                <a:solidFill>
-                  <a:srgbClr val="D97706"/>
-                </a:solidFill>
-                <a:latin typeface="Calibri"/>
-              </a:defRPr>
-            </a:pPr>
-            <a:r>
-              <a:t>94.1%</a:t>
+              <a:defRPr sz="700" b="1">
+                <a:solidFill>
+                  <a:srgbClr val="1A1A1A"/>
+                </a:solidFill>
+                <a:latin typeface="Calibri"/>
+              </a:defRPr>
+            </a:pPr>
+            <a:r>
+              <a:t>MSC-204417</a:t>
             </a:r>
           </a:p>
         </p:txBody>
@@ -19420,8 +19476,8 @@
         </p:nvSpPr>
         <p:spPr>
           <a:xfrm>
-            <a:off x="8503920" y="2167128"/>
-            <a:ext cx="1508760" cy="438912"/>
+            <a:off x="1742440" y="2029968"/>
+            <a:ext cx="1212088" cy="365760"/>
           </a:xfrm>
           <a:prstGeom prst="rect">
             <a:avLst/>
@@ -19454,15 +19510,15 @@
           <a:lstStyle/>
           <a:p>
             <a:pPr algn="ctr">
-              <a:defRPr sz="800" b="0">
-                <a:solidFill>
-                  <a:srgbClr val="D97706"/>
-                </a:solidFill>
-                <a:latin typeface="Calibri"/>
-              </a:defRPr>
-            </a:pPr>
-            <a:r>
-              <a:t>Pass with gaps</a:t>
+              <a:defRPr sz="700" b="0">
+                <a:solidFill>
+                  <a:srgbClr val="16A34A"/>
+                </a:solidFill>
+                <a:latin typeface="Calibri"/>
+              </a:defRPr>
+            </a:pPr>
+            <a:r>
+              <a:t>100%</a:t>
             </a:r>
           </a:p>
         </p:txBody>
@@ -19475,8 +19531,8 @@
         </p:nvSpPr>
         <p:spPr>
           <a:xfrm>
-            <a:off x="10104120" y="2167128"/>
-            <a:ext cx="1508760" cy="438912"/>
+            <a:off x="2981960" y="2029968"/>
+            <a:ext cx="1212088" cy="365760"/>
           </a:xfrm>
           <a:prstGeom prst="rect">
             <a:avLst/>
@@ -19509,15 +19565,15 @@
           <a:lstStyle/>
           <a:p>
             <a:pPr algn="ctr">
-              <a:defRPr sz="800" b="0">
-                <a:solidFill>
-                  <a:srgbClr val="334155"/>
-                </a:solidFill>
-                <a:latin typeface="Calibri"/>
-              </a:defRPr>
-            </a:pPr>
-            <a:r>
-              <a:t>LADR ESS · 12 TC · develop</a:t>
+              <a:defRPr sz="700" b="0">
+                <a:solidFill>
+                  <a:srgbClr val="D97706"/>
+                </a:solidFill>
+                <a:latin typeface="Calibri"/>
+              </a:defRPr>
+            </a:pPr>
+            <a:r>
+              <a:t>83.3%</a:t>
             </a:r>
           </a:p>
         </p:txBody>
@@ -19530,14 +19586,14 @@
         </p:nvSpPr>
         <p:spPr>
           <a:xfrm>
-            <a:off x="502920" y="2642616"/>
-            <a:ext cx="1508760" cy="438912"/>
-          </a:xfrm>
-          <a:prstGeom prst="rect">
-            <a:avLst/>
-          </a:prstGeom>
-          <a:solidFill>
-            <a:srgbClr val="FFFFFF"/>
+            <a:off x="4221480" y="2029968"/>
+            <a:ext cx="1212088" cy="365760"/>
+          </a:xfrm>
+          <a:prstGeom prst="rect">
+            <a:avLst/>
+          </a:prstGeom>
+          <a:solidFill>
+            <a:srgbClr val="F2F2F2"/>
           </a:solidFill>
           <a:ln w="6350">
             <a:solidFill>
@@ -19564,15 +19620,15 @@
           <a:lstStyle/>
           <a:p>
             <a:pPr algn="ctr">
-              <a:defRPr sz="800" b="1">
-                <a:solidFill>
-                  <a:srgbClr val="1A1A1A"/>
-                </a:solidFill>
-                <a:latin typeface="Calibri"/>
-              </a:defRPr>
-            </a:pPr>
-            <a:r>
-              <a:t>MSC-195138</a:t>
+              <a:defRPr sz="700" b="0">
+                <a:solidFill>
+                  <a:srgbClr val="334155"/>
+                </a:solidFill>
+                <a:latin typeface="Calibri"/>
+              </a:defRPr>
+            </a:pPr>
+            <a:r>
+              <a:t>16/17 AC</a:t>
             </a:r>
           </a:p>
         </p:txBody>
@@ -19585,14 +19641,14 @@
         </p:nvSpPr>
         <p:spPr>
           <a:xfrm>
-            <a:off x="2103120" y="2642616"/>
-            <a:ext cx="1508760" cy="438912"/>
-          </a:xfrm>
-          <a:prstGeom prst="rect">
-            <a:avLst/>
-          </a:prstGeom>
-          <a:solidFill>
-            <a:srgbClr val="FFFFFF"/>
+            <a:off x="5461000" y="2029968"/>
+            <a:ext cx="1212088" cy="365760"/>
+          </a:xfrm>
+          <a:prstGeom prst="rect">
+            <a:avLst/>
+          </a:prstGeom>
+          <a:solidFill>
+            <a:srgbClr val="F2F2F2"/>
           </a:solidFill>
           <a:ln w="6350">
             <a:solidFill>
@@ -19619,15 +19675,15 @@
           <a:lstStyle/>
           <a:p>
             <a:pPr algn="ctr">
-              <a:defRPr sz="800" b="0">
-                <a:solidFill>
-                  <a:srgbClr val="1A1A1A"/>
-                </a:solidFill>
-                <a:latin typeface="Calibri"/>
-              </a:defRPr>
-            </a:pPr>
-            <a:r>
-              <a:t>Story · FF Race</a:t>
+              <a:defRPr sz="700" b="0">
+                <a:solidFill>
+                  <a:srgbClr val="D97706"/>
+                </a:solidFill>
+                <a:latin typeface="Calibri"/>
+              </a:defRPr>
+            </a:pPr>
+            <a:r>
+              <a:t>94.1%</a:t>
             </a:r>
           </a:p>
         </p:txBody>
@@ -19640,14 +19696,14 @@
         </p:nvSpPr>
         <p:spPr>
           <a:xfrm>
-            <a:off x="3703320" y="2642616"/>
-            <a:ext cx="1508760" cy="438912"/>
-          </a:xfrm>
-          <a:prstGeom prst="rect">
-            <a:avLst/>
-          </a:prstGeom>
-          <a:solidFill>
-            <a:srgbClr val="FFFFFF"/>
+            <a:off x="6700520" y="2029968"/>
+            <a:ext cx="1212088" cy="365760"/>
+          </a:xfrm>
+          <a:prstGeom prst="rect">
+            <a:avLst/>
+          </a:prstGeom>
+          <a:solidFill>
+            <a:srgbClr val="F2F2F2"/>
           </a:solidFill>
           <a:ln w="6350">
             <a:solidFill>
@@ -19674,7 +19730,7 @@
           <a:lstStyle/>
           <a:p>
             <a:pPr algn="ctr">
-              <a:defRPr sz="800" b="0">
+              <a:defRPr sz="700" b="0">
                 <a:solidFill>
                   <a:srgbClr val="334155"/>
                 </a:solidFill>
@@ -19682,7 +19738,7 @@
               </a:defRPr>
             </a:pPr>
             <a:r>
-              <a:t>—</a:t>
+              <a:t>2 items</a:t>
             </a:r>
           </a:p>
         </p:txBody>
@@ -19695,14 +19751,14 @@
         </p:nvSpPr>
         <p:spPr>
           <a:xfrm>
-            <a:off x="5303520" y="2642616"/>
-            <a:ext cx="1508760" cy="438912"/>
-          </a:xfrm>
-          <a:prstGeom prst="rect">
-            <a:avLst/>
-          </a:prstGeom>
-          <a:solidFill>
-            <a:srgbClr val="FFFFFF"/>
+            <a:off x="7940040" y="2029968"/>
+            <a:ext cx="1212088" cy="365760"/>
+          </a:xfrm>
+          <a:prstGeom prst="rect">
+            <a:avLst/>
+          </a:prstGeom>
+          <a:solidFill>
+            <a:srgbClr val="F2F2F2"/>
           </a:solidFill>
           <a:ln w="6350">
             <a:solidFill>
@@ -19729,7 +19785,7 @@
           <a:lstStyle/>
           <a:p>
             <a:pPr algn="ctr">
-              <a:defRPr sz="800" b="0">
+              <a:defRPr sz="700" b="0">
                 <a:solidFill>
                   <a:srgbClr val="334155"/>
                 </a:solidFill>
@@ -19737,7 +19793,7 @@
               </a:defRPr>
             </a:pPr>
             <a:r>
-              <a:t>—</a:t>
+              <a:t>2 High · 2 Med</a:t>
             </a:r>
           </a:p>
         </p:txBody>
@@ -19750,14 +19806,14 @@
         </p:nvSpPr>
         <p:spPr>
           <a:xfrm>
-            <a:off x="6903720" y="2642616"/>
-            <a:ext cx="1508760" cy="438912"/>
-          </a:xfrm>
-          <a:prstGeom prst="rect">
-            <a:avLst/>
-          </a:prstGeom>
-          <a:solidFill>
-            <a:srgbClr val="FFFFFF"/>
+            <a:off x="9179560" y="2029968"/>
+            <a:ext cx="1212088" cy="365760"/>
+          </a:xfrm>
+          <a:prstGeom prst="rect">
+            <a:avLst/>
+          </a:prstGeom>
+          <a:solidFill>
+            <a:srgbClr val="F2F2F2"/>
           </a:solidFill>
           <a:ln w="6350">
             <a:solidFill>
@@ -19784,15 +19840,15 @@
           <a:lstStyle/>
           <a:p>
             <a:pPr algn="ctr">
-              <a:defRPr sz="800" b="0">
-                <a:solidFill>
-                  <a:srgbClr val="D97706"/>
-                </a:solidFill>
-                <a:latin typeface="Calibri"/>
-              </a:defRPr>
-            </a:pPr>
-            <a:r>
-              <a:t>66.7%</a:t>
+              <a:defRPr sz="700" b="0">
+                <a:solidFill>
+                  <a:srgbClr val="94A3B8"/>
+                </a:solidFill>
+                <a:latin typeface="Calibri"/>
+              </a:defRPr>
+            </a:pPr>
+            <a:r>
+              <a:t>NA</a:t>
             </a:r>
           </a:p>
         </p:txBody>
@@ -19805,14 +19861,14 @@
         </p:nvSpPr>
         <p:spPr>
           <a:xfrm>
-            <a:off x="8503920" y="2642616"/>
-            <a:ext cx="1508760" cy="438912"/>
-          </a:xfrm>
-          <a:prstGeom prst="rect">
-            <a:avLst/>
-          </a:prstGeom>
-          <a:solidFill>
-            <a:srgbClr val="FFFFFF"/>
+            <a:off x="10419080" y="2029968"/>
+            <a:ext cx="1212088" cy="365760"/>
+          </a:xfrm>
+          <a:prstGeom prst="rect">
+            <a:avLst/>
+          </a:prstGeom>
+          <a:solidFill>
+            <a:srgbClr val="F2F2F2"/>
           </a:solidFill>
           <a:ln w="6350">
             <a:solidFill>
@@ -19839,7 +19895,7 @@
           <a:lstStyle/>
           <a:p>
             <a:pPr algn="ctr">
-              <a:defRPr sz="800" b="0">
+              <a:defRPr sz="700" b="0">
                 <a:solidFill>
                   <a:srgbClr val="D97706"/>
                 </a:solidFill>
@@ -19847,7 +19903,7 @@
               </a:defRPr>
             </a:pPr>
             <a:r>
-              <a:t>Pass with gaps</a:t>
+              <a:t>Pass w/ gaps</a:t>
             </a:r>
           </a:p>
         </p:txBody>
@@ -19860,8 +19916,8 @@
         </p:nvSpPr>
         <p:spPr>
           <a:xfrm>
-            <a:off x="10104120" y="2642616"/>
-            <a:ext cx="1508760" cy="438912"/>
+            <a:off x="502920" y="2432304"/>
+            <a:ext cx="1212088" cy="365760"/>
           </a:xfrm>
           <a:prstGeom prst="rect">
             <a:avLst/>
@@ -19894,15 +19950,1721 @@
           <a:lstStyle/>
           <a:p>
             <a:pPr algn="ctr">
+              <a:defRPr sz="700" b="1">
+                <a:solidFill>
+                  <a:srgbClr val="1A1A1A"/>
+                </a:solidFill>
+                <a:latin typeface="Calibri"/>
+              </a:defRPr>
+            </a:pPr>
+            <a:r>
+              <a:t>MSC-195138</a:t>
+            </a:r>
+          </a:p>
+        </p:txBody>
+      </p:sp>
+      <p:sp>
+        <p:nvSpPr>
+          <p:cNvPr id="36" name="Rectangle 35"/>
+          <p:cNvSpPr/>
+          <p:nvPr/>
+        </p:nvSpPr>
+        <p:spPr>
+          <a:xfrm>
+            <a:off x="1742440" y="2432304"/>
+            <a:ext cx="1212088" cy="365760"/>
+          </a:xfrm>
+          <a:prstGeom prst="rect">
+            <a:avLst/>
+          </a:prstGeom>
+          <a:solidFill>
+            <a:srgbClr val="FFFFFF"/>
+          </a:solidFill>
+          <a:ln w="6350">
+            <a:solidFill>
+              <a:srgbClr val="E2E8F0"/>
+            </a:solidFill>
+          </a:ln>
+        </p:spPr>
+        <p:style>
+          <a:lnRef idx="1">
+            <a:schemeClr val="accent1"/>
+          </a:lnRef>
+          <a:fillRef idx="3">
+            <a:schemeClr val="accent1"/>
+          </a:fillRef>
+          <a:effectRef idx="2">
+            <a:schemeClr val="accent1"/>
+          </a:effectRef>
+          <a:fontRef idx="minor">
+            <a:schemeClr val="lt1"/>
+          </a:fontRef>
+        </p:style>
+        <p:txBody>
+          <a:bodyPr rtlCol="0" anchor="ctr" wrap="square"/>
+          <a:lstStyle/>
+          <a:p>
+            <a:pPr algn="ctr">
+              <a:defRPr sz="700" b="0">
+                <a:solidFill>
+                  <a:srgbClr val="D97706"/>
+                </a:solidFill>
+                <a:latin typeface="Calibri"/>
+              </a:defRPr>
+            </a:pPr>
+            <a:r>
+              <a:t>83.3%</a:t>
+            </a:r>
+          </a:p>
+        </p:txBody>
+      </p:sp>
+      <p:sp>
+        <p:nvSpPr>
+          <p:cNvPr id="37" name="Rectangle 36"/>
+          <p:cNvSpPr/>
+          <p:nvPr/>
+        </p:nvSpPr>
+        <p:spPr>
+          <a:xfrm>
+            <a:off x="2981960" y="2432304"/>
+            <a:ext cx="1212088" cy="365760"/>
+          </a:xfrm>
+          <a:prstGeom prst="rect">
+            <a:avLst/>
+          </a:prstGeom>
+          <a:solidFill>
+            <a:srgbClr val="FFFFFF"/>
+          </a:solidFill>
+          <a:ln w="6350">
+            <a:solidFill>
+              <a:srgbClr val="E2E8F0"/>
+            </a:solidFill>
+          </a:ln>
+        </p:spPr>
+        <p:style>
+          <a:lnRef idx="1">
+            <a:schemeClr val="accent1"/>
+          </a:lnRef>
+          <a:fillRef idx="3">
+            <a:schemeClr val="accent1"/>
+          </a:fillRef>
+          <a:effectRef idx="2">
+            <a:schemeClr val="accent1"/>
+          </a:effectRef>
+          <a:fontRef idx="minor">
+            <a:schemeClr val="lt1"/>
+          </a:fontRef>
+        </p:style>
+        <p:txBody>
+          <a:bodyPr rtlCol="0" anchor="ctr" wrap="square"/>
+          <a:lstStyle/>
+          <a:p>
+            <a:pPr algn="ctr">
+              <a:defRPr sz="700" b="0">
+                <a:solidFill>
+                  <a:srgbClr val="D97706"/>
+                </a:solidFill>
+                <a:latin typeface="Calibri"/>
+              </a:defRPr>
+            </a:pPr>
+            <a:r>
+              <a:t>83.3%</a:t>
+            </a:r>
+          </a:p>
+        </p:txBody>
+      </p:sp>
+      <p:sp>
+        <p:nvSpPr>
+          <p:cNvPr id="38" name="Rectangle 37"/>
+          <p:cNvSpPr/>
+          <p:nvPr/>
+        </p:nvSpPr>
+        <p:spPr>
+          <a:xfrm>
+            <a:off x="4221480" y="2432304"/>
+            <a:ext cx="1212088" cy="365760"/>
+          </a:xfrm>
+          <a:prstGeom prst="rect">
+            <a:avLst/>
+          </a:prstGeom>
+          <a:solidFill>
+            <a:srgbClr val="FFFFFF"/>
+          </a:solidFill>
+          <a:ln w="6350">
+            <a:solidFill>
+              <a:srgbClr val="E2E8F0"/>
+            </a:solidFill>
+          </a:ln>
+        </p:spPr>
+        <p:style>
+          <a:lnRef idx="1">
+            <a:schemeClr val="accent1"/>
+          </a:lnRef>
+          <a:fillRef idx="3">
+            <a:schemeClr val="accent1"/>
+          </a:fillRef>
+          <a:effectRef idx="2">
+            <a:schemeClr val="accent1"/>
+          </a:effectRef>
+          <a:fontRef idx="minor">
+            <a:schemeClr val="lt1"/>
+          </a:fontRef>
+        </p:style>
+        <p:txBody>
+          <a:bodyPr rtlCol="0" anchor="ctr" wrap="square"/>
+          <a:lstStyle/>
+          <a:p>
+            <a:pPr algn="ctr">
+              <a:defRPr sz="700" b="0">
+                <a:solidFill>
+                  <a:srgbClr val="334155"/>
+                </a:solidFill>
+                <a:latin typeface="Calibri"/>
+              </a:defRPr>
+            </a:pPr>
+            <a:r>
+              <a:t>2/3 AC</a:t>
+            </a:r>
+          </a:p>
+        </p:txBody>
+      </p:sp>
+      <p:sp>
+        <p:nvSpPr>
+          <p:cNvPr id="39" name="Rectangle 38"/>
+          <p:cNvSpPr/>
+          <p:nvPr/>
+        </p:nvSpPr>
+        <p:spPr>
+          <a:xfrm>
+            <a:off x="5461000" y="2432304"/>
+            <a:ext cx="1212088" cy="365760"/>
+          </a:xfrm>
+          <a:prstGeom prst="rect">
+            <a:avLst/>
+          </a:prstGeom>
+          <a:solidFill>
+            <a:srgbClr val="FFFFFF"/>
+          </a:solidFill>
+          <a:ln w="6350">
+            <a:solidFill>
+              <a:srgbClr val="E2E8F0"/>
+            </a:solidFill>
+          </a:ln>
+        </p:spPr>
+        <p:style>
+          <a:lnRef idx="1">
+            <a:schemeClr val="accent1"/>
+          </a:lnRef>
+          <a:fillRef idx="3">
+            <a:schemeClr val="accent1"/>
+          </a:fillRef>
+          <a:effectRef idx="2">
+            <a:schemeClr val="accent1"/>
+          </a:effectRef>
+          <a:fontRef idx="minor">
+            <a:schemeClr val="lt1"/>
+          </a:fontRef>
+        </p:style>
+        <p:txBody>
+          <a:bodyPr rtlCol="0" anchor="ctr" wrap="square"/>
+          <a:lstStyle/>
+          <a:p>
+            <a:pPr algn="ctr">
+              <a:defRPr sz="700" b="0">
+                <a:solidFill>
+                  <a:srgbClr val="D97706"/>
+                </a:solidFill>
+                <a:latin typeface="Calibri"/>
+              </a:defRPr>
+            </a:pPr>
+            <a:r>
+              <a:t>66.7%</a:t>
+            </a:r>
+          </a:p>
+        </p:txBody>
+      </p:sp>
+      <p:sp>
+        <p:nvSpPr>
+          <p:cNvPr id="40" name="Rectangle 39"/>
+          <p:cNvSpPr/>
+          <p:nvPr/>
+        </p:nvSpPr>
+        <p:spPr>
+          <a:xfrm>
+            <a:off x="6700520" y="2432304"/>
+            <a:ext cx="1212088" cy="365760"/>
+          </a:xfrm>
+          <a:prstGeom prst="rect">
+            <a:avLst/>
+          </a:prstGeom>
+          <a:solidFill>
+            <a:srgbClr val="FFFFFF"/>
+          </a:solidFill>
+          <a:ln w="6350">
+            <a:solidFill>
+              <a:srgbClr val="E2E8F0"/>
+            </a:solidFill>
+          </a:ln>
+        </p:spPr>
+        <p:style>
+          <a:lnRef idx="1">
+            <a:schemeClr val="accent1"/>
+          </a:lnRef>
+          <a:fillRef idx="3">
+            <a:schemeClr val="accent1"/>
+          </a:fillRef>
+          <a:effectRef idx="2">
+            <a:schemeClr val="accent1"/>
+          </a:effectRef>
+          <a:fontRef idx="minor">
+            <a:schemeClr val="lt1"/>
+          </a:fontRef>
+        </p:style>
+        <p:txBody>
+          <a:bodyPr rtlCol="0" anchor="ctr" wrap="square"/>
+          <a:lstStyle/>
+          <a:p>
+            <a:pPr algn="ctr">
+              <a:defRPr sz="700" b="0">
+                <a:solidFill>
+                  <a:srgbClr val="334155"/>
+                </a:solidFill>
+                <a:latin typeface="Calibri"/>
+              </a:defRPr>
+            </a:pPr>
+            <a:r>
+              <a:t>3 items</a:t>
+            </a:r>
+          </a:p>
+        </p:txBody>
+      </p:sp>
+      <p:sp>
+        <p:nvSpPr>
+          <p:cNvPr id="41" name="Rectangle 40"/>
+          <p:cNvSpPr/>
+          <p:nvPr/>
+        </p:nvSpPr>
+        <p:spPr>
+          <a:xfrm>
+            <a:off x="7940040" y="2432304"/>
+            <a:ext cx="1212088" cy="365760"/>
+          </a:xfrm>
+          <a:prstGeom prst="rect">
+            <a:avLst/>
+          </a:prstGeom>
+          <a:solidFill>
+            <a:srgbClr val="FFFFFF"/>
+          </a:solidFill>
+          <a:ln w="6350">
+            <a:solidFill>
+              <a:srgbClr val="E2E8F0"/>
+            </a:solidFill>
+          </a:ln>
+        </p:spPr>
+        <p:style>
+          <a:lnRef idx="1">
+            <a:schemeClr val="accent1"/>
+          </a:lnRef>
+          <a:fillRef idx="3">
+            <a:schemeClr val="accent1"/>
+          </a:fillRef>
+          <a:effectRef idx="2">
+            <a:schemeClr val="accent1"/>
+          </a:effectRef>
+          <a:fontRef idx="minor">
+            <a:schemeClr val="lt1"/>
+          </a:fontRef>
+        </p:style>
+        <p:txBody>
+          <a:bodyPr rtlCol="0" anchor="ctr" wrap="square"/>
+          <a:lstStyle/>
+          <a:p>
+            <a:pPr algn="ctr">
+              <a:defRPr sz="700" b="0">
+                <a:solidFill>
+                  <a:srgbClr val="334155"/>
+                </a:solidFill>
+                <a:latin typeface="Calibri"/>
+              </a:defRPr>
+            </a:pPr>
+            <a:r>
+              <a:t>1 High · 3 Med</a:t>
+            </a:r>
+          </a:p>
+        </p:txBody>
+      </p:sp>
+      <p:sp>
+        <p:nvSpPr>
+          <p:cNvPr id="42" name="Rectangle 41"/>
+          <p:cNvSpPr/>
+          <p:nvPr/>
+        </p:nvSpPr>
+        <p:spPr>
+          <a:xfrm>
+            <a:off x="9179560" y="2432304"/>
+            <a:ext cx="1212088" cy="365760"/>
+          </a:xfrm>
+          <a:prstGeom prst="rect">
+            <a:avLst/>
+          </a:prstGeom>
+          <a:solidFill>
+            <a:srgbClr val="FFFFFF"/>
+          </a:solidFill>
+          <a:ln w="6350">
+            <a:solidFill>
+              <a:srgbClr val="E2E8F0"/>
+            </a:solidFill>
+          </a:ln>
+        </p:spPr>
+        <p:style>
+          <a:lnRef idx="1">
+            <a:schemeClr val="accent1"/>
+          </a:lnRef>
+          <a:fillRef idx="3">
+            <a:schemeClr val="accent1"/>
+          </a:fillRef>
+          <a:effectRef idx="2">
+            <a:schemeClr val="accent1"/>
+          </a:effectRef>
+          <a:fontRef idx="minor">
+            <a:schemeClr val="lt1"/>
+          </a:fontRef>
+        </p:style>
+        <p:txBody>
+          <a:bodyPr rtlCol="0" anchor="ctr" wrap="square"/>
+          <a:lstStyle/>
+          <a:p>
+            <a:pPr algn="ctr">
+              <a:defRPr sz="700" b="0">
+                <a:solidFill>
+                  <a:srgbClr val="94A3B8"/>
+                </a:solidFill>
+                <a:latin typeface="Calibri"/>
+              </a:defRPr>
+            </a:pPr>
+            <a:r>
+              <a:t>NA</a:t>
+            </a:r>
+          </a:p>
+        </p:txBody>
+      </p:sp>
+      <p:sp>
+        <p:nvSpPr>
+          <p:cNvPr id="43" name="Rectangle 42"/>
+          <p:cNvSpPr/>
+          <p:nvPr/>
+        </p:nvSpPr>
+        <p:spPr>
+          <a:xfrm>
+            <a:off x="10419080" y="2432304"/>
+            <a:ext cx="1212088" cy="365760"/>
+          </a:xfrm>
+          <a:prstGeom prst="rect">
+            <a:avLst/>
+          </a:prstGeom>
+          <a:solidFill>
+            <a:srgbClr val="FFFFFF"/>
+          </a:solidFill>
+          <a:ln w="6350">
+            <a:solidFill>
+              <a:srgbClr val="E2E8F0"/>
+            </a:solidFill>
+          </a:ln>
+        </p:spPr>
+        <p:style>
+          <a:lnRef idx="1">
+            <a:schemeClr val="accent1"/>
+          </a:lnRef>
+          <a:fillRef idx="3">
+            <a:schemeClr val="accent1"/>
+          </a:fillRef>
+          <a:effectRef idx="2">
+            <a:schemeClr val="accent1"/>
+          </a:effectRef>
+          <a:fontRef idx="minor">
+            <a:schemeClr val="lt1"/>
+          </a:fontRef>
+        </p:style>
+        <p:txBody>
+          <a:bodyPr rtlCol="0" anchor="ctr" wrap="square"/>
+          <a:lstStyle/>
+          <a:p>
+            <a:pPr algn="ctr">
+              <a:defRPr sz="700" b="0">
+                <a:solidFill>
+                  <a:srgbClr val="D97706"/>
+                </a:solidFill>
+                <a:latin typeface="Calibri"/>
+              </a:defRPr>
+            </a:pPr>
+            <a:r>
+              <a:t>Pass w/ gaps</a:t>
+            </a:r>
+          </a:p>
+        </p:txBody>
+      </p:sp>
+      <p:sp>
+        <p:nvSpPr>
+          <p:cNvPr id="44" name="Rounded Rectangle 43"/>
+          <p:cNvSpPr/>
+          <p:nvPr/>
+        </p:nvSpPr>
+        <p:spPr>
+          <a:xfrm>
+            <a:off x="502920" y="2788920"/>
+            <a:ext cx="11155680" cy="320040"/>
+          </a:xfrm>
+          <a:prstGeom prst="roundRect">
+            <a:avLst/>
+          </a:prstGeom>
+          <a:solidFill>
+            <a:srgbClr val="FF5E4F"/>
+          </a:solidFill>
+          <a:ln w="6350">
+            <a:solidFill>
+              <a:srgbClr val="E2E8F0"/>
+            </a:solidFill>
+          </a:ln>
+        </p:spPr>
+        <p:style>
+          <a:lnRef idx="1">
+            <a:schemeClr val="accent1"/>
+          </a:lnRef>
+          <a:fillRef idx="3">
+            <a:schemeClr val="accent1"/>
+          </a:fillRef>
+          <a:effectRef idx="2">
+            <a:schemeClr val="accent1"/>
+          </a:effectRef>
+          <a:fontRef idx="minor">
+            <a:schemeClr val="lt1"/>
+          </a:fontRef>
+        </p:style>
+        <p:txBody>
+          <a:bodyPr rtlCol="0" anchor="ctr" wrap="square"/>
+          <a:lstStyle/>
+          <a:p>
+            <a:pPr algn="ctr">
+              <a:defRPr sz="1100" b="1">
+                <a:solidFill>
+                  <a:srgbClr val="FFFFFF"/>
+                </a:solidFill>
+                <a:latin typeface="Calibri"/>
+              </a:defRPr>
+            </a:pPr>
+            <a:r>
+              <a:t>Report artifacts (latest)</a:t>
+            </a:r>
+          </a:p>
+        </p:txBody>
+      </p:sp>
+      <p:sp>
+        <p:nvSpPr>
+          <p:cNvPr id="45" name="Rectangle 44"/>
+          <p:cNvSpPr/>
+          <p:nvPr/>
+        </p:nvSpPr>
+        <p:spPr>
+          <a:xfrm>
+            <a:off x="502920" y="3182112"/>
+            <a:ext cx="11155680" cy="310896"/>
+          </a:xfrm>
+          <a:prstGeom prst="rect">
+            <a:avLst/>
+          </a:prstGeom>
+          <a:solidFill>
+            <a:srgbClr val="F2F2F2"/>
+          </a:solidFill>
+          <a:ln w="6350">
+            <a:solidFill>
+              <a:srgbClr val="E2E8F0"/>
+            </a:solidFill>
+          </a:ln>
+        </p:spPr>
+        <p:style>
+          <a:lnRef idx="1">
+            <a:schemeClr val="accent1"/>
+          </a:lnRef>
+          <a:fillRef idx="3">
+            <a:schemeClr val="accent1"/>
+          </a:fillRef>
+          <a:effectRef idx="2">
+            <a:schemeClr val="accent1"/>
+          </a:effectRef>
+          <a:fontRef idx="minor">
+            <a:schemeClr val="lt1"/>
+          </a:fontRef>
+        </p:style>
+        <p:txBody>
+          <a:bodyPr rtlCol="0" anchor="ctr" wrap="square"/>
+          <a:lstStyle/>
+          <a:p>
+            <a:pPr algn="ctr">
               <a:defRPr sz="800" b="0">
                 <a:solidFill>
+                  <a:srgbClr val="334155"/>
+                </a:solidFill>
+                <a:latin typeface="Calibri"/>
+              </a:defRPr>
+            </a:pPr>
+            <a:r>
+              <a:t>MSC-205625 · MSC-205625-05-29-2026-12-43-49-IST.html · 05-29-2026 12:43 IST · PR #161 pick-genie · MERGED · CI Passed · Domino · Inc as Fulll · 5/5 GWT · 3/4 AC</a:t>
+            </a:r>
+          </a:p>
+        </p:txBody>
+      </p:sp>
+      <p:sp>
+        <p:nvSpPr>
+          <p:cNvPr id="46" name="Rectangle 45"/>
+          <p:cNvSpPr/>
+          <p:nvPr/>
+        </p:nvSpPr>
+        <p:spPr>
+          <a:xfrm>
+            <a:off x="502920" y="3529584"/>
+            <a:ext cx="11155680" cy="310896"/>
+          </a:xfrm>
+          <a:prstGeom prst="rect">
+            <a:avLst/>
+          </a:prstGeom>
+          <a:solidFill>
+            <a:srgbClr val="E8F0FE"/>
+          </a:solidFill>
+          <a:ln w="6350">
+            <a:solidFill>
+              <a:srgbClr val="E2E8F0"/>
+            </a:solidFill>
+          </a:ln>
+        </p:spPr>
+        <p:style>
+          <a:lnRef idx="1">
+            <a:schemeClr val="accent1"/>
+          </a:lnRef>
+          <a:fillRef idx="3">
+            <a:schemeClr val="accent1"/>
+          </a:fillRef>
+          <a:effectRef idx="2">
+            <a:schemeClr val="accent1"/>
+          </a:effectRef>
+          <a:fontRef idx="minor">
+            <a:schemeClr val="lt1"/>
+          </a:fontRef>
+        </p:style>
+        <p:txBody>
+          <a:bodyPr rtlCol="0" anchor="ctr" wrap="square"/>
+          <a:lstStyle/>
+          <a:p>
+            <a:pPr algn="ctr">
+              <a:defRPr sz="800" b="0">
+                <a:solidFill>
+                  <a:srgbClr val="04066C"/>
+                </a:solidFill>
+                <a:latin typeface="Calibri"/>
+              </a:defRPr>
+            </a:pPr>
+            <a:r>
+              <a:t>MSC-204417 · MSC-204417-05-31-2026-10-19-28-IST.html · 05-31-2026 10:19 IST · No PR · develop branch · Caption Monitoring · 12/12 GWT · Confluence LADR requirements</a:t>
+            </a:r>
+          </a:p>
+        </p:txBody>
+      </p:sp>
+      <p:sp>
+        <p:nvSpPr>
+          <p:cNvPr id="47" name="Rectangle 46"/>
+          <p:cNvSpPr/>
+          <p:nvPr/>
+        </p:nvSpPr>
+        <p:spPr>
+          <a:xfrm>
+            <a:off x="502920" y="3877056"/>
+            <a:ext cx="11155680" cy="310896"/>
+          </a:xfrm>
+          <a:prstGeom prst="rect">
+            <a:avLst/>
+          </a:prstGeom>
+          <a:solidFill>
+            <a:srgbClr val="F2F2F2"/>
+          </a:solidFill>
+          <a:ln w="6350">
+            <a:solidFill>
+              <a:srgbClr val="E2E8F0"/>
+            </a:solidFill>
+          </a:ln>
+        </p:spPr>
+        <p:style>
+          <a:lnRef idx="1">
+            <a:schemeClr val="accent1"/>
+          </a:lnRef>
+          <a:fillRef idx="3">
+            <a:schemeClr val="accent1"/>
+          </a:fillRef>
+          <a:effectRef idx="2">
+            <a:schemeClr val="accent1"/>
+          </a:effectRef>
+          <a:fontRef idx="minor">
+            <a:schemeClr val="lt1"/>
+          </a:fontRef>
+        </p:style>
+        <p:txBody>
+          <a:bodyPr rtlCol="0" anchor="ctr" wrap="square"/>
+          <a:lstStyle/>
+          <a:p>
+            <a:pPr algn="ctr">
+              <a:defRPr sz="800" b="0">
+                <a:solidFill>
+                  <a:srgbClr val="334155"/>
+                </a:solidFill>
+                <a:latin typeface="Calibri"/>
+              </a:defRPr>
+            </a:pPr>
+            <a:r>
+              <a:t>MSC-195138 · MSC-195138-05-27-2026-17-57-12-IST.html · 05-27-2026 17:57 IST · PRs #22 + #75 · MERGED · FF Race · 11/11 GWT</a:t>
+            </a:r>
+          </a:p>
+        </p:txBody>
+      </p:sp>
+      <p:sp>
+        <p:nvSpPr>
+          <p:cNvPr id="48" name="Rectangle 47"/>
+          <p:cNvSpPr/>
+          <p:nvPr/>
+        </p:nvSpPr>
+        <p:spPr>
+          <a:xfrm>
+            <a:off x="502920" y="4343400"/>
+            <a:ext cx="5394960" cy="320040"/>
+          </a:xfrm>
+          <a:prstGeom prst="rect">
+            <a:avLst/>
+          </a:prstGeom>
+          <a:solidFill>
+            <a:srgbClr val="04066C"/>
+          </a:solidFill>
+          <a:ln w="6350">
+            <a:solidFill>
+              <a:srgbClr val="E2E8F0"/>
+            </a:solidFill>
+          </a:ln>
+        </p:spPr>
+        <p:style>
+          <a:lnRef idx="1">
+            <a:schemeClr val="accent1"/>
+          </a:lnRef>
+          <a:fillRef idx="3">
+            <a:schemeClr val="accent1"/>
+          </a:fillRef>
+          <a:effectRef idx="2">
+            <a:schemeClr val="accent1"/>
+          </a:effectRef>
+          <a:fontRef idx="minor">
+            <a:schemeClr val="lt1"/>
+          </a:fontRef>
+        </p:style>
+        <p:txBody>
+          <a:bodyPr rtlCol="0" anchor="ctr" wrap="square"/>
+          <a:lstStyle/>
+          <a:p>
+            <a:pPr algn="ctr">
+              <a:defRPr sz="1000" b="1">
+                <a:solidFill>
+                  <a:srgbClr val="FFFFFF"/>
+                </a:solidFill>
+                <a:latin typeface="Calibri"/>
+              </a:defRPr>
+            </a:pPr>
+            <a:r>
+              <a:t>MSC-204417 — sample §1 cards</a:t>
+            </a:r>
+          </a:p>
+        </p:txBody>
+      </p:sp>
+      <p:sp>
+        <p:nvSpPr>
+          <p:cNvPr id="49" name="Rounded Rectangle 48"/>
+          <p:cNvSpPr/>
+          <p:nvPr/>
+        </p:nvSpPr>
+        <p:spPr>
+          <a:xfrm>
+            <a:off x="502920" y="4709160"/>
+            <a:ext cx="1261872" cy="777240"/>
+          </a:xfrm>
+          <a:prstGeom prst="roundRect">
+            <a:avLst/>
+          </a:prstGeom>
+          <a:solidFill>
+            <a:srgbClr val="E8F0FE"/>
+          </a:solidFill>
+          <a:ln w="6350">
+            <a:solidFill>
+              <a:srgbClr val="E2E8F0"/>
+            </a:solidFill>
+          </a:ln>
+        </p:spPr>
+        <p:style>
+          <a:lnRef idx="1">
+            <a:schemeClr val="accent1"/>
+          </a:lnRef>
+          <a:fillRef idx="3">
+            <a:schemeClr val="accent1"/>
+          </a:fillRef>
+          <a:effectRef idx="2">
+            <a:schemeClr val="accent1"/>
+          </a:effectRef>
+          <a:fontRef idx="minor">
+            <a:schemeClr val="lt1"/>
+          </a:fontRef>
+        </p:style>
+        <p:txBody>
+          <a:bodyPr rtlCol="0" anchor="ctr"/>
+          <a:lstStyle/>
+          <a:p>
+            <a:pPr algn="ctr"/>
+          </a:p>
+        </p:txBody>
+      </p:sp>
+      <p:sp>
+        <p:nvSpPr>
+          <p:cNvPr id="50" name="TextBox 49"/>
+          <p:cNvSpPr txBox="1"/>
+          <p:nvPr/>
+        </p:nvSpPr>
+        <p:spPr>
+          <a:xfrm>
+            <a:off x="594360" y="4846320"/>
+            <a:ext cx="1078992" cy="502920"/>
+          </a:xfrm>
+          <a:prstGeom prst="rect">
+            <a:avLst/>
+          </a:prstGeom>
+          <a:noFill/>
+        </p:spPr>
+        <p:txBody>
+          <a:bodyPr wrap="none">
+            <a:spAutoFit/>
+          </a:bodyPr>
+          <a:lstStyle/>
+          <a:p>
+            <a:pPr algn="ctr">
+              <a:defRPr sz="2800" b="1">
+                <a:solidFill>
+                  <a:srgbClr val="04066C"/>
+                </a:solidFill>
+                <a:latin typeface="Calibri"/>
+              </a:defRPr>
+            </a:pPr>
+            <a:r>
+              <a:t>100%</a:t>
+            </a:r>
+          </a:p>
+        </p:txBody>
+      </p:sp>
+      <p:sp>
+        <p:nvSpPr>
+          <p:cNvPr id="51" name="TextBox 50"/>
+          <p:cNvSpPr txBox="1"/>
+          <p:nvPr/>
+        </p:nvSpPr>
+        <p:spPr>
+          <a:xfrm>
+            <a:off x="576072" y="5367528"/>
+            <a:ext cx="1115568" cy="411480"/>
+          </a:xfrm>
+          <a:prstGeom prst="rect">
+            <a:avLst/>
+          </a:prstGeom>
+          <a:noFill/>
+        </p:spPr>
+        <p:txBody>
+          <a:bodyPr wrap="none">
+            <a:spAutoFit/>
+          </a:bodyPr>
+          <a:lstStyle/>
+          <a:p>
+            <a:pPr algn="ctr">
+              <a:defRPr sz="1100" b="1">
+                <a:solidFill>
+                  <a:srgbClr val="04066C"/>
+                </a:solidFill>
+                <a:latin typeface="Calibri"/>
+              </a:defRPr>
+            </a:pPr>
+            <a:r>
+              <a:t>Dev code</a:t>
+            </a:r>
+          </a:p>
+        </p:txBody>
+      </p:sp>
+      <p:sp>
+        <p:nvSpPr>
+          <p:cNvPr id="52" name="Rounded Rectangle 51"/>
+          <p:cNvSpPr/>
+          <p:nvPr/>
+        </p:nvSpPr>
+        <p:spPr>
+          <a:xfrm>
+            <a:off x="1856232" y="4709160"/>
+            <a:ext cx="1261872" cy="777240"/>
+          </a:xfrm>
+          <a:prstGeom prst="roundRect">
+            <a:avLst/>
+          </a:prstGeom>
+          <a:solidFill>
+            <a:srgbClr val="E8F0FE"/>
+          </a:solidFill>
+          <a:ln w="6350">
+            <a:solidFill>
+              <a:srgbClr val="E2E8F0"/>
+            </a:solidFill>
+          </a:ln>
+        </p:spPr>
+        <p:style>
+          <a:lnRef idx="1">
+            <a:schemeClr val="accent1"/>
+          </a:lnRef>
+          <a:fillRef idx="3">
+            <a:schemeClr val="accent1"/>
+          </a:fillRef>
+          <a:effectRef idx="2">
+            <a:schemeClr val="accent1"/>
+          </a:effectRef>
+          <a:fontRef idx="minor">
+            <a:schemeClr val="lt1"/>
+          </a:fontRef>
+        </p:style>
+        <p:txBody>
+          <a:bodyPr rtlCol="0" anchor="ctr"/>
+          <a:lstStyle/>
+          <a:p>
+            <a:pPr algn="ctr"/>
+          </a:p>
+        </p:txBody>
+      </p:sp>
+      <p:sp>
+        <p:nvSpPr>
+          <p:cNvPr id="53" name="TextBox 52"/>
+          <p:cNvSpPr txBox="1"/>
+          <p:nvPr/>
+        </p:nvSpPr>
+        <p:spPr>
+          <a:xfrm>
+            <a:off x="1947672" y="4846320"/>
+            <a:ext cx="1078992" cy="502920"/>
+          </a:xfrm>
+          <a:prstGeom prst="rect">
+            <a:avLst/>
+          </a:prstGeom>
+          <a:noFill/>
+        </p:spPr>
+        <p:txBody>
+          <a:bodyPr wrap="none">
+            <a:spAutoFit/>
+          </a:bodyPr>
+          <a:lstStyle/>
+          <a:p>
+            <a:pPr algn="ctr">
+              <a:defRPr sz="2800" b="1">
+                <a:solidFill>
+                  <a:srgbClr val="04066C"/>
+                </a:solidFill>
+                <a:latin typeface="Calibri"/>
+              </a:defRPr>
+            </a:pPr>
+            <a:r>
+              <a:t>83.3%</a:t>
+            </a:r>
+          </a:p>
+        </p:txBody>
+      </p:sp>
+      <p:sp>
+        <p:nvSpPr>
+          <p:cNvPr id="54" name="TextBox 53"/>
+          <p:cNvSpPr txBox="1"/>
+          <p:nvPr/>
+        </p:nvSpPr>
+        <p:spPr>
+          <a:xfrm>
+            <a:off x="1929384" y="5367528"/>
+            <a:ext cx="1115568" cy="411480"/>
+          </a:xfrm>
+          <a:prstGeom prst="rect">
+            <a:avLst/>
+          </a:prstGeom>
+          <a:noFill/>
+        </p:spPr>
+        <p:txBody>
+          <a:bodyPr wrap="none">
+            <a:spAutoFit/>
+          </a:bodyPr>
+          <a:lstStyle/>
+          <a:p>
+            <a:pPr algn="ctr">
+              <a:defRPr sz="1100" b="1">
+                <a:solidFill>
+                  <a:srgbClr val="04066C"/>
+                </a:solidFill>
+                <a:latin typeface="Calibri"/>
+              </a:defRPr>
+            </a:pPr>
+            <a:r>
+              <a:t>Dev tests</a:t>
+            </a:r>
+          </a:p>
+        </p:txBody>
+      </p:sp>
+      <p:sp>
+        <p:nvSpPr>
+          <p:cNvPr id="55" name="Rounded Rectangle 54"/>
+          <p:cNvSpPr/>
+          <p:nvPr/>
+        </p:nvSpPr>
+        <p:spPr>
+          <a:xfrm>
+            <a:off x="3209544" y="4709160"/>
+            <a:ext cx="1261872" cy="777240"/>
+          </a:xfrm>
+          <a:prstGeom prst="roundRect">
+            <a:avLst/>
+          </a:prstGeom>
+          <a:solidFill>
+            <a:srgbClr val="E8F0FE"/>
+          </a:solidFill>
+          <a:ln w="6350">
+            <a:solidFill>
+              <a:srgbClr val="E2E8F0"/>
+            </a:solidFill>
+          </a:ln>
+        </p:spPr>
+        <p:style>
+          <a:lnRef idx="1">
+            <a:schemeClr val="accent1"/>
+          </a:lnRef>
+          <a:fillRef idx="3">
+            <a:schemeClr val="accent1"/>
+          </a:fillRef>
+          <a:effectRef idx="2">
+            <a:schemeClr val="accent1"/>
+          </a:effectRef>
+          <a:fontRef idx="minor">
+            <a:schemeClr val="lt1"/>
+          </a:fontRef>
+        </p:style>
+        <p:txBody>
+          <a:bodyPr rtlCol="0" anchor="ctr"/>
+          <a:lstStyle/>
+          <a:p>
+            <a:pPr algn="ctr"/>
+          </a:p>
+        </p:txBody>
+      </p:sp>
+      <p:sp>
+        <p:nvSpPr>
+          <p:cNvPr id="56" name="TextBox 55"/>
+          <p:cNvSpPr txBox="1"/>
+          <p:nvPr/>
+        </p:nvSpPr>
+        <p:spPr>
+          <a:xfrm>
+            <a:off x="3300984" y="4846320"/>
+            <a:ext cx="1078992" cy="502920"/>
+          </a:xfrm>
+          <a:prstGeom prst="rect">
+            <a:avLst/>
+          </a:prstGeom>
+          <a:noFill/>
+        </p:spPr>
+        <p:txBody>
+          <a:bodyPr wrap="none">
+            <a:spAutoFit/>
+          </a:bodyPr>
+          <a:lstStyle/>
+          <a:p>
+            <a:pPr algn="ctr">
+              <a:defRPr sz="2800" b="1">
+                <a:solidFill>
+                  <a:srgbClr val="04066C"/>
+                </a:solidFill>
+                <a:latin typeface="Calibri"/>
+              </a:defRPr>
+            </a:pPr>
+            <a:r>
+              <a:t>94.1%</a:t>
+            </a:r>
+          </a:p>
+        </p:txBody>
+      </p:sp>
+      <p:sp>
+        <p:nvSpPr>
+          <p:cNvPr id="57" name="TextBox 56"/>
+          <p:cNvSpPr txBox="1"/>
+          <p:nvPr/>
+        </p:nvSpPr>
+        <p:spPr>
+          <a:xfrm>
+            <a:off x="3282696" y="5367528"/>
+            <a:ext cx="1115568" cy="411480"/>
+          </a:xfrm>
+          <a:prstGeom prst="rect">
+            <a:avLst/>
+          </a:prstGeom>
+          <a:noFill/>
+        </p:spPr>
+        <p:txBody>
+          <a:bodyPr wrap="none">
+            <a:spAutoFit/>
+          </a:bodyPr>
+          <a:lstStyle/>
+          <a:p>
+            <a:pPr algn="ctr">
+              <a:defRPr sz="1100" b="1">
+                <a:solidFill>
+                  <a:srgbClr val="04066C"/>
+                </a:solidFill>
+                <a:latin typeface="Calibri"/>
+              </a:defRPr>
+            </a:pPr>
+            <a:r>
+              <a:t>Test plan AC</a:t>
+            </a:r>
+          </a:p>
+        </p:txBody>
+      </p:sp>
+      <p:sp>
+        <p:nvSpPr>
+          <p:cNvPr id="58" name="Rounded Rectangle 57"/>
+          <p:cNvSpPr/>
+          <p:nvPr/>
+        </p:nvSpPr>
+        <p:spPr>
+          <a:xfrm>
+            <a:off x="4562856" y="4709160"/>
+            <a:ext cx="1261872" cy="777240"/>
+          </a:xfrm>
+          <a:prstGeom prst="roundRect">
+            <a:avLst/>
+          </a:prstGeom>
+          <a:solidFill>
+            <a:srgbClr val="FFF8E1"/>
+          </a:solidFill>
+          <a:ln w="6350">
+            <a:solidFill>
+              <a:srgbClr val="E2E8F0"/>
+            </a:solidFill>
+          </a:ln>
+        </p:spPr>
+        <p:style>
+          <a:lnRef idx="1">
+            <a:schemeClr val="accent1"/>
+          </a:lnRef>
+          <a:fillRef idx="3">
+            <a:schemeClr val="accent1"/>
+          </a:fillRef>
+          <a:effectRef idx="2">
+            <a:schemeClr val="accent1"/>
+          </a:effectRef>
+          <a:fontRef idx="minor">
+            <a:schemeClr val="lt1"/>
+          </a:fontRef>
+        </p:style>
+        <p:txBody>
+          <a:bodyPr rtlCol="0" anchor="ctr"/>
+          <a:lstStyle/>
+          <a:p>
+            <a:pPr algn="ctr"/>
+          </a:p>
+        </p:txBody>
+      </p:sp>
+      <p:sp>
+        <p:nvSpPr>
+          <p:cNvPr id="59" name="TextBox 58"/>
+          <p:cNvSpPr txBox="1"/>
+          <p:nvPr/>
+        </p:nvSpPr>
+        <p:spPr>
+          <a:xfrm>
+            <a:off x="4654296" y="4846320"/>
+            <a:ext cx="1078992" cy="502920"/>
+          </a:xfrm>
+          <a:prstGeom prst="rect">
+            <a:avLst/>
+          </a:prstGeom>
+          <a:noFill/>
+        </p:spPr>
+        <p:txBody>
+          <a:bodyPr wrap="none">
+            <a:spAutoFit/>
+          </a:bodyPr>
+          <a:lstStyle/>
+          <a:p>
+            <a:pPr algn="ctr">
+              <a:defRPr sz="2800" b="1">
+                <a:solidFill>
+                  <a:srgbClr val="04066C"/>
+                </a:solidFill>
+                <a:latin typeface="Calibri"/>
+              </a:defRPr>
+            </a:pPr>
+            <a:r>
+              <a:t>NA</a:t>
+            </a:r>
+          </a:p>
+        </p:txBody>
+      </p:sp>
+      <p:sp>
+        <p:nvSpPr>
+          <p:cNvPr id="60" name="TextBox 59"/>
+          <p:cNvSpPr txBox="1"/>
+          <p:nvPr/>
+        </p:nvSpPr>
+        <p:spPr>
+          <a:xfrm>
+            <a:off x="4636008" y="5367528"/>
+            <a:ext cx="1115568" cy="411480"/>
+          </a:xfrm>
+          <a:prstGeom prst="rect">
+            <a:avLst/>
+          </a:prstGeom>
+          <a:noFill/>
+        </p:spPr>
+        <p:txBody>
+          <a:bodyPr wrap="none">
+            <a:spAutoFit/>
+          </a:bodyPr>
+          <a:lstStyle/>
+          <a:p>
+            <a:pPr algn="ctr">
+              <a:defRPr sz="1100" b="1">
+                <a:solidFill>
+                  <a:srgbClr val="04066C"/>
+                </a:solidFill>
+                <a:latin typeface="Calibri"/>
+              </a:defRPr>
+            </a:pPr>
+            <a:r>
+              <a:t>CI line</a:t>
+            </a:r>
+          </a:p>
+        </p:txBody>
+      </p:sp>
+      <p:sp>
+        <p:nvSpPr>
+          <p:cNvPr id="61" name="Rectangle 60"/>
+          <p:cNvSpPr/>
+          <p:nvPr/>
+        </p:nvSpPr>
+        <p:spPr>
+          <a:xfrm>
+            <a:off x="6080760" y="4343400"/>
+            <a:ext cx="5577840" cy="320040"/>
+          </a:xfrm>
+          <a:prstGeom prst="rect">
+            <a:avLst/>
+          </a:prstGeom>
+          <a:solidFill>
+            <a:srgbClr val="04066C"/>
+          </a:solidFill>
+          <a:ln w="6350">
+            <a:solidFill>
+              <a:srgbClr val="E2E8F0"/>
+            </a:solidFill>
+          </a:ln>
+        </p:spPr>
+        <p:style>
+          <a:lnRef idx="1">
+            <a:schemeClr val="accent1"/>
+          </a:lnRef>
+          <a:fillRef idx="3">
+            <a:schemeClr val="accent1"/>
+          </a:fillRef>
+          <a:effectRef idx="2">
+            <a:schemeClr val="accent1"/>
+          </a:effectRef>
+          <a:fontRef idx="minor">
+            <a:schemeClr val="lt1"/>
+          </a:fontRef>
+        </p:style>
+        <p:txBody>
+          <a:bodyPr rtlCol="0" anchor="ctr" wrap="square"/>
+          <a:lstStyle/>
+          <a:p>
+            <a:pPr algn="ctr">
+              <a:defRPr sz="1000" b="1">
+                <a:solidFill>
+                  <a:srgbClr val="FFFFFF"/>
+                </a:solidFill>
+                <a:latin typeface="Calibri"/>
+              </a:defRPr>
+            </a:pPr>
+            <a:r>
+              <a:t>MSC-205625 — sample §1 cards (PR + CI)</a:t>
+            </a:r>
+          </a:p>
+        </p:txBody>
+      </p:sp>
+      <p:sp>
+        <p:nvSpPr>
+          <p:cNvPr id="62" name="Rounded Rectangle 61"/>
+          <p:cNvSpPr/>
+          <p:nvPr/>
+        </p:nvSpPr>
+        <p:spPr>
+          <a:xfrm>
+            <a:off x="6080760" y="4709160"/>
+            <a:ext cx="1261872" cy="777240"/>
+          </a:xfrm>
+          <a:prstGeom prst="roundRect">
+            <a:avLst/>
+          </a:prstGeom>
+          <a:solidFill>
+            <a:srgbClr val="DCFCE7"/>
+          </a:solidFill>
+          <a:ln w="6350">
+            <a:solidFill>
+              <a:srgbClr val="E2E8F0"/>
+            </a:solidFill>
+          </a:ln>
+        </p:spPr>
+        <p:style>
+          <a:lnRef idx="1">
+            <a:schemeClr val="accent1"/>
+          </a:lnRef>
+          <a:fillRef idx="3">
+            <a:schemeClr val="accent1"/>
+          </a:fillRef>
+          <a:effectRef idx="2">
+            <a:schemeClr val="accent1"/>
+          </a:effectRef>
+          <a:fontRef idx="minor">
+            <a:schemeClr val="lt1"/>
+          </a:fontRef>
+        </p:style>
+        <p:txBody>
+          <a:bodyPr rtlCol="0" anchor="ctr"/>
+          <a:lstStyle/>
+          <a:p>
+            <a:pPr algn="ctr"/>
+          </a:p>
+        </p:txBody>
+      </p:sp>
+      <p:sp>
+        <p:nvSpPr>
+          <p:cNvPr id="63" name="TextBox 62"/>
+          <p:cNvSpPr txBox="1"/>
+          <p:nvPr/>
+        </p:nvSpPr>
+        <p:spPr>
+          <a:xfrm>
+            <a:off x="6172200" y="4846320"/>
+            <a:ext cx="1078992" cy="502920"/>
+          </a:xfrm>
+          <a:prstGeom prst="rect">
+            <a:avLst/>
+          </a:prstGeom>
+          <a:noFill/>
+        </p:spPr>
+        <p:txBody>
+          <a:bodyPr wrap="none">
+            <a:spAutoFit/>
+          </a:bodyPr>
+          <a:lstStyle/>
+          <a:p>
+            <a:pPr algn="ctr">
+              <a:defRPr sz="2800" b="1">
+                <a:solidFill>
                   <a:srgbClr val="16A34A"/>
                 </a:solidFill>
                 <a:latin typeface="Calibri"/>
               </a:defRPr>
             </a:pPr>
             <a:r>
-              <a:t>PRs #22 + #75 · 11/11 Given/When/Then</a:t>
+              <a:t>100%</a:t>
+            </a:r>
+          </a:p>
+        </p:txBody>
+      </p:sp>
+      <p:sp>
+        <p:nvSpPr>
+          <p:cNvPr id="64" name="TextBox 63"/>
+          <p:cNvSpPr txBox="1"/>
+          <p:nvPr/>
+        </p:nvSpPr>
+        <p:spPr>
+          <a:xfrm>
+            <a:off x="6153912" y="5367528"/>
+            <a:ext cx="1115568" cy="411480"/>
+          </a:xfrm>
+          <a:prstGeom prst="rect">
+            <a:avLst/>
+          </a:prstGeom>
+          <a:noFill/>
+        </p:spPr>
+        <p:txBody>
+          <a:bodyPr wrap="none">
+            <a:spAutoFit/>
+          </a:bodyPr>
+          <a:lstStyle/>
+          <a:p>
+            <a:pPr algn="ctr">
+              <a:defRPr sz="1100" b="1">
+                <a:solidFill>
+                  <a:srgbClr val="16A34A"/>
+                </a:solidFill>
+                <a:latin typeface="Calibri"/>
+              </a:defRPr>
+            </a:pPr>
+            <a:r>
+              <a:t>Dev code</a:t>
+            </a:r>
+          </a:p>
+        </p:txBody>
+      </p:sp>
+      <p:sp>
+        <p:nvSpPr>
+          <p:cNvPr id="65" name="Rounded Rectangle 64"/>
+          <p:cNvSpPr/>
+          <p:nvPr/>
+        </p:nvSpPr>
+        <p:spPr>
+          <a:xfrm>
+            <a:off x="7434072" y="4709160"/>
+            <a:ext cx="1261872" cy="777240"/>
+          </a:xfrm>
+          <a:prstGeom prst="roundRect">
+            <a:avLst/>
+          </a:prstGeom>
+          <a:solidFill>
+            <a:srgbClr val="DCFCE7"/>
+          </a:solidFill>
+          <a:ln w="6350">
+            <a:solidFill>
+              <a:srgbClr val="E2E8F0"/>
+            </a:solidFill>
+          </a:ln>
+        </p:spPr>
+        <p:style>
+          <a:lnRef idx="1">
+            <a:schemeClr val="accent1"/>
+          </a:lnRef>
+          <a:fillRef idx="3">
+            <a:schemeClr val="accent1"/>
+          </a:fillRef>
+          <a:effectRef idx="2">
+            <a:schemeClr val="accent1"/>
+          </a:effectRef>
+          <a:fontRef idx="minor">
+            <a:schemeClr val="lt1"/>
+          </a:fontRef>
+        </p:style>
+        <p:txBody>
+          <a:bodyPr rtlCol="0" anchor="ctr"/>
+          <a:lstStyle/>
+          <a:p>
+            <a:pPr algn="ctr"/>
+          </a:p>
+        </p:txBody>
+      </p:sp>
+      <p:sp>
+        <p:nvSpPr>
+          <p:cNvPr id="66" name="TextBox 65"/>
+          <p:cNvSpPr txBox="1"/>
+          <p:nvPr/>
+        </p:nvSpPr>
+        <p:spPr>
+          <a:xfrm>
+            <a:off x="7525512" y="4846320"/>
+            <a:ext cx="1078992" cy="502920"/>
+          </a:xfrm>
+          <a:prstGeom prst="rect">
+            <a:avLst/>
+          </a:prstGeom>
+          <a:noFill/>
+        </p:spPr>
+        <p:txBody>
+          <a:bodyPr wrap="none">
+            <a:spAutoFit/>
+          </a:bodyPr>
+          <a:lstStyle/>
+          <a:p>
+            <a:pPr algn="ctr">
+              <a:defRPr sz="2800" b="1">
+                <a:solidFill>
+                  <a:srgbClr val="16A34A"/>
+                </a:solidFill>
+                <a:latin typeface="Calibri"/>
+              </a:defRPr>
+            </a:pPr>
+            <a:r>
+              <a:t>75%</a:t>
+            </a:r>
+          </a:p>
+        </p:txBody>
+      </p:sp>
+      <p:sp>
+        <p:nvSpPr>
+          <p:cNvPr id="67" name="TextBox 66"/>
+          <p:cNvSpPr txBox="1"/>
+          <p:nvPr/>
+        </p:nvSpPr>
+        <p:spPr>
+          <a:xfrm>
+            <a:off x="7507224" y="5367528"/>
+            <a:ext cx="1115568" cy="411480"/>
+          </a:xfrm>
+          <a:prstGeom prst="rect">
+            <a:avLst/>
+          </a:prstGeom>
+          <a:noFill/>
+        </p:spPr>
+        <p:txBody>
+          <a:bodyPr wrap="none">
+            <a:spAutoFit/>
+          </a:bodyPr>
+          <a:lstStyle/>
+          <a:p>
+            <a:pPr algn="ctr">
+              <a:defRPr sz="1100" b="1">
+                <a:solidFill>
+                  <a:srgbClr val="16A34A"/>
+                </a:solidFill>
+                <a:latin typeface="Calibri"/>
+              </a:defRPr>
+            </a:pPr>
+            <a:r>
+              <a:t>Dev tests</a:t>
+            </a:r>
+          </a:p>
+        </p:txBody>
+      </p:sp>
+      <p:sp>
+        <p:nvSpPr>
+          <p:cNvPr id="68" name="Rounded Rectangle 67"/>
+          <p:cNvSpPr/>
+          <p:nvPr/>
+        </p:nvSpPr>
+        <p:spPr>
+          <a:xfrm>
+            <a:off x="8787384" y="4709160"/>
+            <a:ext cx="1261872" cy="777240"/>
+          </a:xfrm>
+          <a:prstGeom prst="roundRect">
+            <a:avLst/>
+          </a:prstGeom>
+          <a:solidFill>
+            <a:srgbClr val="DCFCE7"/>
+          </a:solidFill>
+          <a:ln w="6350">
+            <a:solidFill>
+              <a:srgbClr val="E2E8F0"/>
+            </a:solidFill>
+          </a:ln>
+        </p:spPr>
+        <p:style>
+          <a:lnRef idx="1">
+            <a:schemeClr val="accent1"/>
+          </a:lnRef>
+          <a:fillRef idx="3">
+            <a:schemeClr val="accent1"/>
+          </a:fillRef>
+          <a:effectRef idx="2">
+            <a:schemeClr val="accent1"/>
+          </a:effectRef>
+          <a:fontRef idx="minor">
+            <a:schemeClr val="lt1"/>
+          </a:fontRef>
+        </p:style>
+        <p:txBody>
+          <a:bodyPr rtlCol="0" anchor="ctr"/>
+          <a:lstStyle/>
+          <a:p>
+            <a:pPr algn="ctr"/>
+          </a:p>
+        </p:txBody>
+      </p:sp>
+      <p:sp>
+        <p:nvSpPr>
+          <p:cNvPr id="69" name="TextBox 68"/>
+          <p:cNvSpPr txBox="1"/>
+          <p:nvPr/>
+        </p:nvSpPr>
+        <p:spPr>
+          <a:xfrm>
+            <a:off x="8878824" y="4846320"/>
+            <a:ext cx="1078992" cy="502920"/>
+          </a:xfrm>
+          <a:prstGeom prst="rect">
+            <a:avLst/>
+          </a:prstGeom>
+          <a:noFill/>
+        </p:spPr>
+        <p:txBody>
+          <a:bodyPr wrap="none">
+            <a:spAutoFit/>
+          </a:bodyPr>
+          <a:lstStyle/>
+          <a:p>
+            <a:pPr algn="ctr">
+              <a:defRPr sz="2800" b="1">
+                <a:solidFill>
+                  <a:srgbClr val="16A34A"/>
+                </a:solidFill>
+                <a:latin typeface="Calibri"/>
+              </a:defRPr>
+            </a:pPr>
+            <a:r>
+              <a:t>75%</a:t>
+            </a:r>
+          </a:p>
+        </p:txBody>
+      </p:sp>
+      <p:sp>
+        <p:nvSpPr>
+          <p:cNvPr id="70" name="TextBox 69"/>
+          <p:cNvSpPr txBox="1"/>
+          <p:nvPr/>
+        </p:nvSpPr>
+        <p:spPr>
+          <a:xfrm>
+            <a:off x="8860536" y="5367528"/>
+            <a:ext cx="1115568" cy="411480"/>
+          </a:xfrm>
+          <a:prstGeom prst="rect">
+            <a:avLst/>
+          </a:prstGeom>
+          <a:noFill/>
+        </p:spPr>
+        <p:txBody>
+          <a:bodyPr wrap="none">
+            <a:spAutoFit/>
+          </a:bodyPr>
+          <a:lstStyle/>
+          <a:p>
+            <a:pPr algn="ctr">
+              <a:defRPr sz="1100" b="1">
+                <a:solidFill>
+                  <a:srgbClr val="16A34A"/>
+                </a:solidFill>
+                <a:latin typeface="Calibri"/>
+              </a:defRPr>
+            </a:pPr>
+            <a:r>
+              <a:t>Test plan AC</a:t>
+            </a:r>
+          </a:p>
+        </p:txBody>
+      </p:sp>
+      <p:sp>
+        <p:nvSpPr>
+          <p:cNvPr id="71" name="Rounded Rectangle 70"/>
+          <p:cNvSpPr/>
+          <p:nvPr/>
+        </p:nvSpPr>
+        <p:spPr>
+          <a:xfrm>
+            <a:off x="10140696" y="4709160"/>
+            <a:ext cx="1261872" cy="777240"/>
+          </a:xfrm>
+          <a:prstGeom prst="roundRect">
+            <a:avLst/>
+          </a:prstGeom>
+          <a:solidFill>
+            <a:srgbClr val="DCFCE7"/>
+          </a:solidFill>
+          <a:ln w="6350">
+            <a:solidFill>
+              <a:srgbClr val="E2E8F0"/>
+            </a:solidFill>
+          </a:ln>
+        </p:spPr>
+        <p:style>
+          <a:lnRef idx="1">
+            <a:schemeClr val="accent1"/>
+          </a:lnRef>
+          <a:fillRef idx="3">
+            <a:schemeClr val="accent1"/>
+          </a:fillRef>
+          <a:effectRef idx="2">
+            <a:schemeClr val="accent1"/>
+          </a:effectRef>
+          <a:fontRef idx="minor">
+            <a:schemeClr val="lt1"/>
+          </a:fontRef>
+        </p:style>
+        <p:txBody>
+          <a:bodyPr rtlCol="0" anchor="ctr"/>
+          <a:lstStyle/>
+          <a:p>
+            <a:pPr algn="ctr"/>
+          </a:p>
+        </p:txBody>
+      </p:sp>
+      <p:sp>
+        <p:nvSpPr>
+          <p:cNvPr id="72" name="TextBox 71"/>
+          <p:cNvSpPr txBox="1"/>
+          <p:nvPr/>
+        </p:nvSpPr>
+        <p:spPr>
+          <a:xfrm>
+            <a:off x="10232136" y="4846320"/>
+            <a:ext cx="1078992" cy="502920"/>
+          </a:xfrm>
+          <a:prstGeom prst="rect">
+            <a:avLst/>
+          </a:prstGeom>
+          <a:noFill/>
+        </p:spPr>
+        <p:txBody>
+          <a:bodyPr wrap="none">
+            <a:spAutoFit/>
+          </a:bodyPr>
+          <a:lstStyle/>
+          <a:p>
+            <a:pPr algn="ctr">
+              <a:defRPr sz="2800" b="1">
+                <a:solidFill>
+                  <a:srgbClr val="16A34A"/>
+                </a:solidFill>
+                <a:latin typeface="Calibri"/>
+              </a:defRPr>
+            </a:pPr>
+            <a:r>
+              <a:t>95.3%</a:t>
+            </a:r>
+          </a:p>
+        </p:txBody>
+      </p:sp>
+      <p:sp>
+        <p:nvSpPr>
+          <p:cNvPr id="73" name="TextBox 72"/>
+          <p:cNvSpPr txBox="1"/>
+          <p:nvPr/>
+        </p:nvSpPr>
+        <p:spPr>
+          <a:xfrm>
+            <a:off x="10213848" y="5367528"/>
+            <a:ext cx="1115568" cy="411480"/>
+          </a:xfrm>
+          <a:prstGeom prst="rect">
+            <a:avLst/>
+          </a:prstGeom>
+          <a:noFill/>
+        </p:spPr>
+        <p:txBody>
+          <a:bodyPr wrap="none">
+            <a:spAutoFit/>
+          </a:bodyPr>
+          <a:lstStyle/>
+          <a:p>
+            <a:pPr algn="ctr">
+              <a:defRPr sz="1100" b="1">
+                <a:solidFill>
+                  <a:srgbClr val="16A34A"/>
+                </a:solidFill>
+                <a:latin typeface="Calibri"/>
+              </a:defRPr>
+            </a:pPr>
+            <a:r>
+              <a:t>CI line</a:t>
             </a:r>
           </a:p>
         </p:txBody>
@@ -19916,6 +21678,1802 @@
 </file>
 
 <file path=ppt/slides/slide23.xml><?xml version="1.0" encoding="utf-8"?>
+<p:sld xmlns:a="http://schemas.openxmlformats.org/drawingml/2006/main" xmlns:p="http://schemas.openxmlformats.org/presentationml/2006/main" xmlns:r="http://schemas.openxmlformats.org/officeDocument/2006/relationships">
+  <p:cSld>
+    <p:bg>
+      <p:bgPr>
+        <a:solidFill>
+          <a:srgbClr val="FFFFFF"/>
+        </a:solidFill>
+        <a:effectLst/>
+      </p:bgPr>
+    </p:bg>
+    <p:spTree>
+      <p:nvGrpSpPr>
+        <p:cNvPr id="1" name=""/>
+        <p:cNvGrpSpPr/>
+        <p:nvPr/>
+      </p:nvGrpSpPr>
+      <p:grpSpPr/>
+      <p:sp>
+        <p:nvSpPr>
+          <p:cNvPr id="2" name="Rectangle 1"/>
+          <p:cNvSpPr/>
+          <p:nvPr/>
+        </p:nvSpPr>
+        <p:spPr>
+          <a:xfrm>
+            <a:off x="0" y="6327648"/>
+            <a:ext cx="12191695" cy="18288"/>
+          </a:xfrm>
+          <a:prstGeom prst="rect">
+            <a:avLst/>
+          </a:prstGeom>
+          <a:solidFill>
+            <a:srgbClr val="F2F2F2"/>
+          </a:solidFill>
+          <a:ln>
+            <a:noFill/>
+          </a:ln>
+        </p:spPr>
+        <p:style>
+          <a:lnRef idx="1">
+            <a:schemeClr val="accent1"/>
+          </a:lnRef>
+          <a:fillRef idx="3">
+            <a:schemeClr val="accent1"/>
+          </a:fillRef>
+          <a:effectRef idx="2">
+            <a:schemeClr val="accent1"/>
+          </a:effectRef>
+          <a:fontRef idx="minor">
+            <a:schemeClr val="lt1"/>
+          </a:fontRef>
+        </p:style>
+        <p:txBody>
+          <a:bodyPr rtlCol="0" anchor="ctr"/>
+          <a:lstStyle/>
+          <a:p>
+            <a:pPr algn="ctr"/>
+          </a:p>
+        </p:txBody>
+      </p:sp>
+      <p:sp>
+        <p:nvSpPr>
+          <p:cNvPr id="3" name="TextBox 2"/>
+          <p:cNvSpPr txBox="1"/>
+          <p:nvPr/>
+        </p:nvSpPr>
+        <p:spPr>
+          <a:xfrm>
+            <a:off x="457200" y="6400800"/>
+            <a:ext cx="8229600" cy="320040"/>
+          </a:xfrm>
+          <a:prstGeom prst="rect">
+            <a:avLst/>
+          </a:prstGeom>
+          <a:noFill/>
+        </p:spPr>
+        <p:txBody>
+          <a:bodyPr wrap="none">
+            <a:spAutoFit/>
+          </a:bodyPr>
+          <a:lstStyle/>
+          <a:p>
+            <a:pPr>
+              <a:defRPr sz="800">
+                <a:solidFill>
+                  <a:srgbClr val="94A3B8"/>
+                </a:solidFill>
+                <a:latin typeface="Calibri"/>
+              </a:defRPr>
+            </a:pPr>
+            <a:r>
+              <a:t>©LTM  |  Privileged and Confidential  |  MSC Dev Code and QA Test Coverage Validator  |  Developed by Mayur Gunjal</a:t>
+            </a:r>
+          </a:p>
+        </p:txBody>
+      </p:sp>
+      <p:sp>
+        <p:nvSpPr>
+          <p:cNvPr id="4" name="TextBox 3"/>
+          <p:cNvSpPr txBox="1"/>
+          <p:nvPr/>
+        </p:nvSpPr>
+        <p:spPr>
+          <a:xfrm>
+            <a:off x="11292840" y="6400800"/>
+            <a:ext cx="548640" cy="320040"/>
+          </a:xfrm>
+          <a:prstGeom prst="rect">
+            <a:avLst/>
+          </a:prstGeom>
+          <a:noFill/>
+        </p:spPr>
+        <p:txBody>
+          <a:bodyPr wrap="none">
+            <a:spAutoFit/>
+          </a:bodyPr>
+          <a:lstStyle/>
+          <a:p>
+            <a:pPr algn="r">
+              <a:defRPr sz="800">
+                <a:solidFill>
+                  <a:srgbClr val="94A3B8"/>
+                </a:solidFill>
+                <a:latin typeface="Calibri"/>
+              </a:defRPr>
+            </a:pPr>
+            <a:r>
+              <a:t>22</a:t>
+            </a:r>
+          </a:p>
+        </p:txBody>
+      </p:sp>
+      <p:sp>
+        <p:nvSpPr>
+          <p:cNvPr id="5" name="Rectangle 4"/>
+          <p:cNvSpPr/>
+          <p:nvPr/>
+        </p:nvSpPr>
+        <p:spPr>
+          <a:xfrm>
+            <a:off x="0" y="0"/>
+            <a:ext cx="109728" cy="6858000"/>
+          </a:xfrm>
+          <a:prstGeom prst="rect">
+            <a:avLst/>
+          </a:prstGeom>
+          <a:solidFill>
+            <a:srgbClr val="FF5E4F"/>
+          </a:solidFill>
+          <a:ln>
+            <a:noFill/>
+          </a:ln>
+        </p:spPr>
+        <p:style>
+          <a:lnRef idx="1">
+            <a:schemeClr val="accent1"/>
+          </a:lnRef>
+          <a:fillRef idx="3">
+            <a:schemeClr val="accent1"/>
+          </a:fillRef>
+          <a:effectRef idx="2">
+            <a:schemeClr val="accent1"/>
+          </a:effectRef>
+          <a:fontRef idx="minor">
+            <a:schemeClr val="lt1"/>
+          </a:fontRef>
+        </p:style>
+        <p:txBody>
+          <a:bodyPr rtlCol="0" anchor="ctr"/>
+          <a:lstStyle/>
+          <a:p>
+            <a:pPr algn="ctr"/>
+          </a:p>
+        </p:txBody>
+      </p:sp>
+      <p:sp>
+        <p:nvSpPr>
+          <p:cNvPr id="6" name="TextBox 5"/>
+          <p:cNvSpPr txBox="1"/>
+          <p:nvPr/>
+        </p:nvSpPr>
+        <p:spPr>
+          <a:xfrm>
+            <a:off x="502920" y="292608"/>
+            <a:ext cx="10972800" cy="594360"/>
+          </a:xfrm>
+          <a:prstGeom prst="rect">
+            <a:avLst/>
+          </a:prstGeom>
+          <a:noFill/>
+        </p:spPr>
+        <p:txBody>
+          <a:bodyPr wrap="none">
+            <a:spAutoFit/>
+          </a:bodyPr>
+          <a:lstStyle/>
+          <a:p>
+            <a:pPr>
+              <a:defRPr sz="2600" b="1">
+                <a:solidFill>
+                  <a:srgbClr val="04066C"/>
+                </a:solidFill>
+                <a:latin typeface="Calibri"/>
+              </a:defRPr>
+            </a:pPr>
+            <a:r>
+              <a:t>Proven MSC outcomes</a:t>
+            </a:r>
+          </a:p>
+        </p:txBody>
+      </p:sp>
+      <p:sp>
+        <p:nvSpPr>
+          <p:cNvPr id="7" name="TextBox 6"/>
+          <p:cNvSpPr txBox="1"/>
+          <p:nvPr/>
+        </p:nvSpPr>
+        <p:spPr>
+          <a:xfrm>
+            <a:off x="502920" y="804672"/>
+            <a:ext cx="10972800" cy="347472"/>
+          </a:xfrm>
+          <a:prstGeom prst="rect">
+            <a:avLst/>
+          </a:prstGeom>
+          <a:noFill/>
+        </p:spPr>
+        <p:txBody>
+          <a:bodyPr wrap="none">
+            <a:spAutoFit/>
+          </a:bodyPr>
+          <a:lstStyle/>
+          <a:p>
+            <a:pPr>
+              <a:defRPr sz="1300">
+                <a:solidFill>
+                  <a:srgbClr val="94A3B8"/>
+                </a:solidFill>
+                <a:latin typeface="Calibri"/>
+              </a:defRPr>
+            </a:pPr>
+            <a:r>
+              <a:t>Latest HTML reports — see full 8-card matrix on prior slide</a:t>
+            </a:r>
+          </a:p>
+        </p:txBody>
+      </p:sp>
+      <p:sp>
+        <p:nvSpPr>
+          <p:cNvPr id="8" name="Rectangle 7"/>
+          <p:cNvSpPr/>
+          <p:nvPr/>
+        </p:nvSpPr>
+        <p:spPr>
+          <a:xfrm>
+            <a:off x="502920" y="1234440"/>
+            <a:ext cx="1508760" cy="384048"/>
+          </a:xfrm>
+          <a:prstGeom prst="rect">
+            <a:avLst/>
+          </a:prstGeom>
+          <a:solidFill>
+            <a:srgbClr val="04066C"/>
+          </a:solidFill>
+          <a:ln w="6350">
+            <a:solidFill>
+              <a:srgbClr val="E2E8F0"/>
+            </a:solidFill>
+          </a:ln>
+        </p:spPr>
+        <p:style>
+          <a:lnRef idx="1">
+            <a:schemeClr val="accent1"/>
+          </a:lnRef>
+          <a:fillRef idx="3">
+            <a:schemeClr val="accent1"/>
+          </a:fillRef>
+          <a:effectRef idx="2">
+            <a:schemeClr val="accent1"/>
+          </a:effectRef>
+          <a:fontRef idx="minor">
+            <a:schemeClr val="lt1"/>
+          </a:fontRef>
+        </p:style>
+        <p:txBody>
+          <a:bodyPr rtlCol="0" anchor="ctr" wrap="square"/>
+          <a:lstStyle/>
+          <a:p>
+            <a:pPr algn="ctr">
+              <a:defRPr sz="900" b="1">
+                <a:solidFill>
+                  <a:srgbClr val="FFFFFF"/>
+                </a:solidFill>
+                <a:latin typeface="Calibri"/>
+              </a:defRPr>
+            </a:pPr>
+            <a:r>
+              <a:t>Ticket</a:t>
+            </a:r>
+          </a:p>
+        </p:txBody>
+      </p:sp>
+      <p:sp>
+        <p:nvSpPr>
+          <p:cNvPr id="9" name="Rectangle 8"/>
+          <p:cNvSpPr/>
+          <p:nvPr/>
+        </p:nvSpPr>
+        <p:spPr>
+          <a:xfrm>
+            <a:off x="2103120" y="1234440"/>
+            <a:ext cx="1508760" cy="384048"/>
+          </a:xfrm>
+          <a:prstGeom prst="rect">
+            <a:avLst/>
+          </a:prstGeom>
+          <a:solidFill>
+            <a:srgbClr val="04066C"/>
+          </a:solidFill>
+          <a:ln w="6350">
+            <a:solidFill>
+              <a:srgbClr val="E2E8F0"/>
+            </a:solidFill>
+          </a:ln>
+        </p:spPr>
+        <p:style>
+          <a:lnRef idx="1">
+            <a:schemeClr val="accent1"/>
+          </a:lnRef>
+          <a:fillRef idx="3">
+            <a:schemeClr val="accent1"/>
+          </a:fillRef>
+          <a:effectRef idx="2">
+            <a:schemeClr val="accent1"/>
+          </a:effectRef>
+          <a:fontRef idx="minor">
+            <a:schemeClr val="lt1"/>
+          </a:fontRef>
+        </p:style>
+        <p:txBody>
+          <a:bodyPr rtlCol="0" anchor="ctr" wrap="square"/>
+          <a:lstStyle/>
+          <a:p>
+            <a:pPr algn="ctr">
+              <a:defRPr sz="900" b="1">
+                <a:solidFill>
+                  <a:srgbClr val="FFFFFF"/>
+                </a:solidFill>
+                <a:latin typeface="Calibri"/>
+              </a:defRPr>
+            </a:pPr>
+            <a:r>
+              <a:t>Type</a:t>
+            </a:r>
+          </a:p>
+        </p:txBody>
+      </p:sp>
+      <p:sp>
+        <p:nvSpPr>
+          <p:cNvPr id="10" name="Rectangle 9"/>
+          <p:cNvSpPr/>
+          <p:nvPr/>
+        </p:nvSpPr>
+        <p:spPr>
+          <a:xfrm>
+            <a:off x="3703320" y="1234440"/>
+            <a:ext cx="1508760" cy="384048"/>
+          </a:xfrm>
+          <a:prstGeom prst="rect">
+            <a:avLst/>
+          </a:prstGeom>
+          <a:solidFill>
+            <a:srgbClr val="04066C"/>
+          </a:solidFill>
+          <a:ln w="6350">
+            <a:solidFill>
+              <a:srgbClr val="E2E8F0"/>
+            </a:solidFill>
+          </a:ln>
+        </p:spPr>
+        <p:style>
+          <a:lnRef idx="1">
+            <a:schemeClr val="accent1"/>
+          </a:lnRef>
+          <a:fillRef idx="3">
+            <a:schemeClr val="accent1"/>
+          </a:fillRef>
+          <a:effectRef idx="2">
+            <a:schemeClr val="accent1"/>
+          </a:effectRef>
+          <a:fontRef idx="minor">
+            <a:schemeClr val="lt1"/>
+          </a:fontRef>
+        </p:style>
+        <p:txBody>
+          <a:bodyPr rtlCol="0" anchor="ctr" wrap="square"/>
+          <a:lstStyle/>
+          <a:p>
+            <a:pPr algn="ctr">
+              <a:defRPr sz="900" b="1">
+                <a:solidFill>
+                  <a:srgbClr val="FFFFFF"/>
+                </a:solidFill>
+                <a:latin typeface="Calibri"/>
+              </a:defRPr>
+            </a:pPr>
+            <a:r>
+              <a:t>Code</a:t>
+            </a:r>
+          </a:p>
+        </p:txBody>
+      </p:sp>
+      <p:sp>
+        <p:nvSpPr>
+          <p:cNvPr id="11" name="Rectangle 10"/>
+          <p:cNvSpPr/>
+          <p:nvPr/>
+        </p:nvSpPr>
+        <p:spPr>
+          <a:xfrm>
+            <a:off x="5303520" y="1234440"/>
+            <a:ext cx="1508760" cy="384048"/>
+          </a:xfrm>
+          <a:prstGeom prst="rect">
+            <a:avLst/>
+          </a:prstGeom>
+          <a:solidFill>
+            <a:srgbClr val="04066C"/>
+          </a:solidFill>
+          <a:ln w="6350">
+            <a:solidFill>
+              <a:srgbClr val="E2E8F0"/>
+            </a:solidFill>
+          </a:ln>
+        </p:spPr>
+        <p:style>
+          <a:lnRef idx="1">
+            <a:schemeClr val="accent1"/>
+          </a:lnRef>
+          <a:fillRef idx="3">
+            <a:schemeClr val="accent1"/>
+          </a:fillRef>
+          <a:effectRef idx="2">
+            <a:schemeClr val="accent1"/>
+          </a:effectRef>
+          <a:fontRef idx="minor">
+            <a:schemeClr val="lt1"/>
+          </a:fontRef>
+        </p:style>
+        <p:txBody>
+          <a:bodyPr rtlCol="0" anchor="ctr" wrap="square"/>
+          <a:lstStyle/>
+          <a:p>
+            <a:pPr algn="ctr">
+              <a:defRPr sz="900" b="1">
+                <a:solidFill>
+                  <a:srgbClr val="FFFFFF"/>
+                </a:solidFill>
+                <a:latin typeface="Calibri"/>
+              </a:defRPr>
+            </a:pPr>
+            <a:r>
+              <a:t>Dev tests</a:t>
+            </a:r>
+          </a:p>
+        </p:txBody>
+      </p:sp>
+      <p:sp>
+        <p:nvSpPr>
+          <p:cNvPr id="12" name="Rectangle 11"/>
+          <p:cNvSpPr/>
+          <p:nvPr/>
+        </p:nvSpPr>
+        <p:spPr>
+          <a:xfrm>
+            <a:off x="6903720" y="1234440"/>
+            <a:ext cx="1508760" cy="384048"/>
+          </a:xfrm>
+          <a:prstGeom prst="rect">
+            <a:avLst/>
+          </a:prstGeom>
+          <a:solidFill>
+            <a:srgbClr val="04066C"/>
+          </a:solidFill>
+          <a:ln w="6350">
+            <a:solidFill>
+              <a:srgbClr val="E2E8F0"/>
+            </a:solidFill>
+          </a:ln>
+        </p:spPr>
+        <p:style>
+          <a:lnRef idx="1">
+            <a:schemeClr val="accent1"/>
+          </a:lnRef>
+          <a:fillRef idx="3">
+            <a:schemeClr val="accent1"/>
+          </a:fillRef>
+          <a:effectRef idx="2">
+            <a:schemeClr val="accent1"/>
+          </a:effectRef>
+          <a:fontRef idx="minor">
+            <a:schemeClr val="lt1"/>
+          </a:fontRef>
+        </p:style>
+        <p:txBody>
+          <a:bodyPr rtlCol="0" anchor="ctr" wrap="square"/>
+          <a:lstStyle/>
+          <a:p>
+            <a:pPr algn="ctr">
+              <a:defRPr sz="900" b="1">
+                <a:solidFill>
+                  <a:srgbClr val="FFFFFF"/>
+                </a:solidFill>
+                <a:latin typeface="Calibri"/>
+              </a:defRPr>
+            </a:pPr>
+            <a:r>
+              <a:t>Plan AC</a:t>
+            </a:r>
+          </a:p>
+        </p:txBody>
+      </p:sp>
+      <p:sp>
+        <p:nvSpPr>
+          <p:cNvPr id="13" name="Rectangle 12"/>
+          <p:cNvSpPr/>
+          <p:nvPr/>
+        </p:nvSpPr>
+        <p:spPr>
+          <a:xfrm>
+            <a:off x="8503920" y="1234440"/>
+            <a:ext cx="1508760" cy="384048"/>
+          </a:xfrm>
+          <a:prstGeom prst="rect">
+            <a:avLst/>
+          </a:prstGeom>
+          <a:solidFill>
+            <a:srgbClr val="04066C"/>
+          </a:solidFill>
+          <a:ln w="6350">
+            <a:solidFill>
+              <a:srgbClr val="E2E8F0"/>
+            </a:solidFill>
+          </a:ln>
+        </p:spPr>
+        <p:style>
+          <a:lnRef idx="1">
+            <a:schemeClr val="accent1"/>
+          </a:lnRef>
+          <a:fillRef idx="3">
+            <a:schemeClr val="accent1"/>
+          </a:fillRef>
+          <a:effectRef idx="2">
+            <a:schemeClr val="accent1"/>
+          </a:effectRef>
+          <a:fontRef idx="minor">
+            <a:schemeClr val="lt1"/>
+          </a:fontRef>
+        </p:style>
+        <p:txBody>
+          <a:bodyPr rtlCol="0" anchor="ctr" wrap="square"/>
+          <a:lstStyle/>
+          <a:p>
+            <a:pPr algn="ctr">
+              <a:defRPr sz="900" b="1">
+                <a:solidFill>
+                  <a:srgbClr val="FFFFFF"/>
+                </a:solidFill>
+                <a:latin typeface="Calibri"/>
+              </a:defRPr>
+            </a:pPr>
+            <a:r>
+              <a:t>Verdict</a:t>
+            </a:r>
+          </a:p>
+        </p:txBody>
+      </p:sp>
+      <p:sp>
+        <p:nvSpPr>
+          <p:cNvPr id="14" name="Rectangle 13"/>
+          <p:cNvSpPr/>
+          <p:nvPr/>
+        </p:nvSpPr>
+        <p:spPr>
+          <a:xfrm>
+            <a:off x="10104120" y="1234440"/>
+            <a:ext cx="1508760" cy="384048"/>
+          </a:xfrm>
+          <a:prstGeom prst="rect">
+            <a:avLst/>
+          </a:prstGeom>
+          <a:solidFill>
+            <a:srgbClr val="04066C"/>
+          </a:solidFill>
+          <a:ln w="6350">
+            <a:solidFill>
+              <a:srgbClr val="E2E8F0"/>
+            </a:solidFill>
+          </a:ln>
+        </p:spPr>
+        <p:style>
+          <a:lnRef idx="1">
+            <a:schemeClr val="accent1"/>
+          </a:lnRef>
+          <a:fillRef idx="3">
+            <a:schemeClr val="accent1"/>
+          </a:fillRef>
+          <a:effectRef idx="2">
+            <a:schemeClr val="accent1"/>
+          </a:effectRef>
+          <a:fontRef idx="minor">
+            <a:schemeClr val="lt1"/>
+          </a:fontRef>
+        </p:style>
+        <p:txBody>
+          <a:bodyPr rtlCol="0" anchor="ctr" wrap="square"/>
+          <a:lstStyle/>
+          <a:p>
+            <a:pPr algn="ctr">
+              <a:defRPr sz="900" b="1">
+                <a:solidFill>
+                  <a:srgbClr val="FFFFFF"/>
+                </a:solidFill>
+                <a:latin typeface="Calibri"/>
+              </a:defRPr>
+            </a:pPr>
+            <a:r>
+              <a:t>Notes</a:t>
+            </a:r>
+          </a:p>
+        </p:txBody>
+      </p:sp>
+      <p:sp>
+        <p:nvSpPr>
+          <p:cNvPr id="15" name="Rectangle 14"/>
+          <p:cNvSpPr/>
+          <p:nvPr/>
+        </p:nvSpPr>
+        <p:spPr>
+          <a:xfrm>
+            <a:off x="502920" y="1691640"/>
+            <a:ext cx="1508760" cy="438912"/>
+          </a:xfrm>
+          <a:prstGeom prst="rect">
+            <a:avLst/>
+          </a:prstGeom>
+          <a:solidFill>
+            <a:srgbClr val="FFFFFF"/>
+          </a:solidFill>
+          <a:ln w="6350">
+            <a:solidFill>
+              <a:srgbClr val="E2E8F0"/>
+            </a:solidFill>
+          </a:ln>
+        </p:spPr>
+        <p:style>
+          <a:lnRef idx="1">
+            <a:schemeClr val="accent1"/>
+          </a:lnRef>
+          <a:fillRef idx="3">
+            <a:schemeClr val="accent1"/>
+          </a:fillRef>
+          <a:effectRef idx="2">
+            <a:schemeClr val="accent1"/>
+          </a:effectRef>
+          <a:fontRef idx="minor">
+            <a:schemeClr val="lt1"/>
+          </a:fontRef>
+        </p:style>
+        <p:txBody>
+          <a:bodyPr rtlCol="0" anchor="ctr" wrap="square"/>
+          <a:lstStyle/>
+          <a:p>
+            <a:pPr algn="ctr">
+              <a:defRPr sz="800" b="1">
+                <a:solidFill>
+                  <a:srgbClr val="1A1A1A"/>
+                </a:solidFill>
+                <a:latin typeface="Calibri"/>
+              </a:defRPr>
+            </a:pPr>
+            <a:r>
+              <a:t>MSC-205625</a:t>
+            </a:r>
+          </a:p>
+        </p:txBody>
+      </p:sp>
+      <p:sp>
+        <p:nvSpPr>
+          <p:cNvPr id="16" name="Rectangle 15"/>
+          <p:cNvSpPr/>
+          <p:nvPr/>
+        </p:nvSpPr>
+        <p:spPr>
+          <a:xfrm>
+            <a:off x="2103120" y="1691640"/>
+            <a:ext cx="1508760" cy="438912"/>
+          </a:xfrm>
+          <a:prstGeom prst="rect">
+            <a:avLst/>
+          </a:prstGeom>
+          <a:solidFill>
+            <a:srgbClr val="FFFFFF"/>
+          </a:solidFill>
+          <a:ln w="6350">
+            <a:solidFill>
+              <a:srgbClr val="E2E8F0"/>
+            </a:solidFill>
+          </a:ln>
+        </p:spPr>
+        <p:style>
+          <a:lnRef idx="1">
+            <a:schemeClr val="accent1"/>
+          </a:lnRef>
+          <a:fillRef idx="3">
+            <a:schemeClr val="accent1"/>
+          </a:fillRef>
+          <a:effectRef idx="2">
+            <a:schemeClr val="accent1"/>
+          </a:effectRef>
+          <a:fontRef idx="minor">
+            <a:schemeClr val="lt1"/>
+          </a:fontRef>
+        </p:style>
+        <p:txBody>
+          <a:bodyPr rtlCol="0" anchor="ctr" wrap="square"/>
+          <a:lstStyle/>
+          <a:p>
+            <a:pPr algn="ctr">
+              <a:defRPr sz="800" b="0">
+                <a:solidFill>
+                  <a:srgbClr val="1A1A1A"/>
+                </a:solidFill>
+                <a:latin typeface="Calibri"/>
+              </a:defRPr>
+            </a:pPr>
+            <a:r>
+              <a:t>Bug · Ready for Release</a:t>
+            </a:r>
+          </a:p>
+        </p:txBody>
+      </p:sp>
+      <p:sp>
+        <p:nvSpPr>
+          <p:cNvPr id="17" name="Rectangle 16"/>
+          <p:cNvSpPr/>
+          <p:nvPr/>
+        </p:nvSpPr>
+        <p:spPr>
+          <a:xfrm>
+            <a:off x="3703320" y="1691640"/>
+            <a:ext cx="1508760" cy="438912"/>
+          </a:xfrm>
+          <a:prstGeom prst="rect">
+            <a:avLst/>
+          </a:prstGeom>
+          <a:solidFill>
+            <a:srgbClr val="FFFFFF"/>
+          </a:solidFill>
+          <a:ln w="6350">
+            <a:solidFill>
+              <a:srgbClr val="E2E8F0"/>
+            </a:solidFill>
+          </a:ln>
+        </p:spPr>
+        <p:style>
+          <a:lnRef idx="1">
+            <a:schemeClr val="accent1"/>
+          </a:lnRef>
+          <a:fillRef idx="3">
+            <a:schemeClr val="accent1"/>
+          </a:fillRef>
+          <a:effectRef idx="2">
+            <a:schemeClr val="accent1"/>
+          </a:effectRef>
+          <a:fontRef idx="minor">
+            <a:schemeClr val="lt1"/>
+          </a:fontRef>
+        </p:style>
+        <p:txBody>
+          <a:bodyPr rtlCol="0" anchor="ctr" wrap="square"/>
+          <a:lstStyle/>
+          <a:p>
+            <a:pPr algn="ctr">
+              <a:defRPr sz="800" b="0">
+                <a:solidFill>
+                  <a:srgbClr val="16A34A"/>
+                </a:solidFill>
+                <a:latin typeface="Calibri"/>
+              </a:defRPr>
+            </a:pPr>
+            <a:r>
+              <a:t>100%</a:t>
+            </a:r>
+          </a:p>
+        </p:txBody>
+      </p:sp>
+      <p:sp>
+        <p:nvSpPr>
+          <p:cNvPr id="18" name="Rectangle 17"/>
+          <p:cNvSpPr/>
+          <p:nvPr/>
+        </p:nvSpPr>
+        <p:spPr>
+          <a:xfrm>
+            <a:off x="5303520" y="1691640"/>
+            <a:ext cx="1508760" cy="438912"/>
+          </a:xfrm>
+          <a:prstGeom prst="rect">
+            <a:avLst/>
+          </a:prstGeom>
+          <a:solidFill>
+            <a:srgbClr val="FFFFFF"/>
+          </a:solidFill>
+          <a:ln w="6350">
+            <a:solidFill>
+              <a:srgbClr val="E2E8F0"/>
+            </a:solidFill>
+          </a:ln>
+        </p:spPr>
+        <p:style>
+          <a:lnRef idx="1">
+            <a:schemeClr val="accent1"/>
+          </a:lnRef>
+          <a:fillRef idx="3">
+            <a:schemeClr val="accent1"/>
+          </a:fillRef>
+          <a:effectRef idx="2">
+            <a:schemeClr val="accent1"/>
+          </a:effectRef>
+          <a:fontRef idx="minor">
+            <a:schemeClr val="lt1"/>
+          </a:fontRef>
+        </p:style>
+        <p:txBody>
+          <a:bodyPr rtlCol="0" anchor="ctr" wrap="square"/>
+          <a:lstStyle/>
+          <a:p>
+            <a:pPr algn="ctr">
+              <a:defRPr sz="800" b="0">
+                <a:solidFill>
+                  <a:srgbClr val="D97706"/>
+                </a:solidFill>
+                <a:latin typeface="Calibri"/>
+              </a:defRPr>
+            </a:pPr>
+            <a:r>
+              <a:t>75%</a:t>
+            </a:r>
+          </a:p>
+        </p:txBody>
+      </p:sp>
+      <p:sp>
+        <p:nvSpPr>
+          <p:cNvPr id="19" name="Rectangle 18"/>
+          <p:cNvSpPr/>
+          <p:nvPr/>
+        </p:nvSpPr>
+        <p:spPr>
+          <a:xfrm>
+            <a:off x="6903720" y="1691640"/>
+            <a:ext cx="1508760" cy="438912"/>
+          </a:xfrm>
+          <a:prstGeom prst="rect">
+            <a:avLst/>
+          </a:prstGeom>
+          <a:solidFill>
+            <a:srgbClr val="FFFFFF"/>
+          </a:solidFill>
+          <a:ln w="6350">
+            <a:solidFill>
+              <a:srgbClr val="E2E8F0"/>
+            </a:solidFill>
+          </a:ln>
+        </p:spPr>
+        <p:style>
+          <a:lnRef idx="1">
+            <a:schemeClr val="accent1"/>
+          </a:lnRef>
+          <a:fillRef idx="3">
+            <a:schemeClr val="accent1"/>
+          </a:fillRef>
+          <a:effectRef idx="2">
+            <a:schemeClr val="accent1"/>
+          </a:effectRef>
+          <a:fontRef idx="minor">
+            <a:schemeClr val="lt1"/>
+          </a:fontRef>
+        </p:style>
+        <p:txBody>
+          <a:bodyPr rtlCol="0" anchor="ctr" wrap="square"/>
+          <a:lstStyle/>
+          <a:p>
+            <a:pPr algn="ctr">
+              <a:defRPr sz="800" b="0">
+                <a:solidFill>
+                  <a:srgbClr val="D97706"/>
+                </a:solidFill>
+                <a:latin typeface="Calibri"/>
+              </a:defRPr>
+            </a:pPr>
+            <a:r>
+              <a:t>75%</a:t>
+            </a:r>
+          </a:p>
+        </p:txBody>
+      </p:sp>
+      <p:sp>
+        <p:nvSpPr>
+          <p:cNvPr id="20" name="Rectangle 19"/>
+          <p:cNvSpPr/>
+          <p:nvPr/>
+        </p:nvSpPr>
+        <p:spPr>
+          <a:xfrm>
+            <a:off x="8503920" y="1691640"/>
+            <a:ext cx="1508760" cy="438912"/>
+          </a:xfrm>
+          <a:prstGeom prst="rect">
+            <a:avLst/>
+          </a:prstGeom>
+          <a:solidFill>
+            <a:srgbClr val="FFFFFF"/>
+          </a:solidFill>
+          <a:ln w="6350">
+            <a:solidFill>
+              <a:srgbClr val="E2E8F0"/>
+            </a:solidFill>
+          </a:ln>
+        </p:spPr>
+        <p:style>
+          <a:lnRef idx="1">
+            <a:schemeClr val="accent1"/>
+          </a:lnRef>
+          <a:fillRef idx="3">
+            <a:schemeClr val="accent1"/>
+          </a:fillRef>
+          <a:effectRef idx="2">
+            <a:schemeClr val="accent1"/>
+          </a:effectRef>
+          <a:fontRef idx="minor">
+            <a:schemeClr val="lt1"/>
+          </a:fontRef>
+        </p:style>
+        <p:txBody>
+          <a:bodyPr rtlCol="0" anchor="ctr" wrap="square"/>
+          <a:lstStyle/>
+          <a:p>
+            <a:pPr algn="ctr">
+              <a:defRPr sz="800" b="0">
+                <a:solidFill>
+                  <a:srgbClr val="D97706"/>
+                </a:solidFill>
+                <a:latin typeface="Calibri"/>
+              </a:defRPr>
+            </a:pPr>
+            <a:r>
+              <a:t>Pass w/ gaps</a:t>
+            </a:r>
+          </a:p>
+        </p:txBody>
+      </p:sp>
+      <p:sp>
+        <p:nvSpPr>
+          <p:cNvPr id="21" name="Rectangle 20"/>
+          <p:cNvSpPr/>
+          <p:nvPr/>
+        </p:nvSpPr>
+        <p:spPr>
+          <a:xfrm>
+            <a:off x="10104120" y="1691640"/>
+            <a:ext cx="1508760" cy="438912"/>
+          </a:xfrm>
+          <a:prstGeom prst="rect">
+            <a:avLst/>
+          </a:prstGeom>
+          <a:solidFill>
+            <a:srgbClr val="FFFFFF"/>
+          </a:solidFill>
+          <a:ln w="6350">
+            <a:solidFill>
+              <a:srgbClr val="E2E8F0"/>
+            </a:solidFill>
+          </a:ln>
+        </p:spPr>
+        <p:style>
+          <a:lnRef idx="1">
+            <a:schemeClr val="accent1"/>
+          </a:lnRef>
+          <a:fillRef idx="3">
+            <a:schemeClr val="accent1"/>
+          </a:fillRef>
+          <a:effectRef idx="2">
+            <a:schemeClr val="accent1"/>
+          </a:effectRef>
+          <a:fontRef idx="minor">
+            <a:schemeClr val="lt1"/>
+          </a:fontRef>
+        </p:style>
+        <p:txBody>
+          <a:bodyPr rtlCol="0" anchor="ctr" wrap="square"/>
+          <a:lstStyle/>
+          <a:p>
+            <a:pPr algn="ctr">
+              <a:defRPr sz="800" b="0">
+                <a:solidFill>
+                  <a:srgbClr val="334155"/>
+                </a:solidFill>
+                <a:latin typeface="Calibri"/>
+              </a:defRPr>
+            </a:pPr>
+            <a:r>
+              <a:t>PR #161 pick-genie · MERGED · CI Passed · …</a:t>
+            </a:r>
+          </a:p>
+        </p:txBody>
+      </p:sp>
+      <p:sp>
+        <p:nvSpPr>
+          <p:cNvPr id="22" name="Rectangle 21"/>
+          <p:cNvSpPr/>
+          <p:nvPr/>
+        </p:nvSpPr>
+        <p:spPr>
+          <a:xfrm>
+            <a:off x="502920" y="2167128"/>
+            <a:ext cx="1508760" cy="438912"/>
+          </a:xfrm>
+          <a:prstGeom prst="rect">
+            <a:avLst/>
+          </a:prstGeom>
+          <a:solidFill>
+            <a:srgbClr val="F2F2F2"/>
+          </a:solidFill>
+          <a:ln w="6350">
+            <a:solidFill>
+              <a:srgbClr val="E2E8F0"/>
+            </a:solidFill>
+          </a:ln>
+        </p:spPr>
+        <p:style>
+          <a:lnRef idx="1">
+            <a:schemeClr val="accent1"/>
+          </a:lnRef>
+          <a:fillRef idx="3">
+            <a:schemeClr val="accent1"/>
+          </a:fillRef>
+          <a:effectRef idx="2">
+            <a:schemeClr val="accent1"/>
+          </a:effectRef>
+          <a:fontRef idx="minor">
+            <a:schemeClr val="lt1"/>
+          </a:fontRef>
+        </p:style>
+        <p:txBody>
+          <a:bodyPr rtlCol="0" anchor="ctr" wrap="square"/>
+          <a:lstStyle/>
+          <a:p>
+            <a:pPr algn="ctr">
+              <a:defRPr sz="800" b="1">
+                <a:solidFill>
+                  <a:srgbClr val="1A1A1A"/>
+                </a:solidFill>
+                <a:latin typeface="Calibri"/>
+              </a:defRPr>
+            </a:pPr>
+            <a:r>
+              <a:t>MSC-204417</a:t>
+            </a:r>
+          </a:p>
+        </p:txBody>
+      </p:sp>
+      <p:sp>
+        <p:nvSpPr>
+          <p:cNvPr id="23" name="Rectangle 22"/>
+          <p:cNvSpPr/>
+          <p:nvPr/>
+        </p:nvSpPr>
+        <p:spPr>
+          <a:xfrm>
+            <a:off x="2103120" y="2167128"/>
+            <a:ext cx="1508760" cy="438912"/>
+          </a:xfrm>
+          <a:prstGeom prst="rect">
+            <a:avLst/>
+          </a:prstGeom>
+          <a:solidFill>
+            <a:srgbClr val="F2F2F2"/>
+          </a:solidFill>
+          <a:ln w="6350">
+            <a:solidFill>
+              <a:srgbClr val="E2E8F0"/>
+            </a:solidFill>
+          </a:ln>
+        </p:spPr>
+        <p:style>
+          <a:lnRef idx="1">
+            <a:schemeClr val="accent1"/>
+          </a:lnRef>
+          <a:fillRef idx="3">
+            <a:schemeClr val="accent1"/>
+          </a:fillRef>
+          <a:effectRef idx="2">
+            <a:schemeClr val="accent1"/>
+          </a:effectRef>
+          <a:fontRef idx="minor">
+            <a:schemeClr val="lt1"/>
+          </a:fontRef>
+        </p:style>
+        <p:txBody>
+          <a:bodyPr rtlCol="0" anchor="ctr" wrap="square"/>
+          <a:lstStyle/>
+          <a:p>
+            <a:pPr algn="ctr">
+              <a:defRPr sz="800" b="0">
+                <a:solidFill>
+                  <a:srgbClr val="1A1A1A"/>
+                </a:solidFill>
+                <a:latin typeface="Calibri"/>
+              </a:defRPr>
+            </a:pPr>
+            <a:r>
+              <a:t>Story · In QA</a:t>
+            </a:r>
+          </a:p>
+        </p:txBody>
+      </p:sp>
+      <p:sp>
+        <p:nvSpPr>
+          <p:cNvPr id="24" name="Rectangle 23"/>
+          <p:cNvSpPr/>
+          <p:nvPr/>
+        </p:nvSpPr>
+        <p:spPr>
+          <a:xfrm>
+            <a:off x="3703320" y="2167128"/>
+            <a:ext cx="1508760" cy="438912"/>
+          </a:xfrm>
+          <a:prstGeom prst="rect">
+            <a:avLst/>
+          </a:prstGeom>
+          <a:solidFill>
+            <a:srgbClr val="F2F2F2"/>
+          </a:solidFill>
+          <a:ln w="6350">
+            <a:solidFill>
+              <a:srgbClr val="E2E8F0"/>
+            </a:solidFill>
+          </a:ln>
+        </p:spPr>
+        <p:style>
+          <a:lnRef idx="1">
+            <a:schemeClr val="accent1"/>
+          </a:lnRef>
+          <a:fillRef idx="3">
+            <a:schemeClr val="accent1"/>
+          </a:fillRef>
+          <a:effectRef idx="2">
+            <a:schemeClr val="accent1"/>
+          </a:effectRef>
+          <a:fontRef idx="minor">
+            <a:schemeClr val="lt1"/>
+          </a:fontRef>
+        </p:style>
+        <p:txBody>
+          <a:bodyPr rtlCol="0" anchor="ctr" wrap="square"/>
+          <a:lstStyle/>
+          <a:p>
+            <a:pPr algn="ctr">
+              <a:defRPr sz="800" b="0">
+                <a:solidFill>
+                  <a:srgbClr val="16A34A"/>
+                </a:solidFill>
+                <a:latin typeface="Calibri"/>
+              </a:defRPr>
+            </a:pPr>
+            <a:r>
+              <a:t>100%</a:t>
+            </a:r>
+          </a:p>
+        </p:txBody>
+      </p:sp>
+      <p:sp>
+        <p:nvSpPr>
+          <p:cNvPr id="25" name="Rectangle 24"/>
+          <p:cNvSpPr/>
+          <p:nvPr/>
+        </p:nvSpPr>
+        <p:spPr>
+          <a:xfrm>
+            <a:off x="5303520" y="2167128"/>
+            <a:ext cx="1508760" cy="438912"/>
+          </a:xfrm>
+          <a:prstGeom prst="rect">
+            <a:avLst/>
+          </a:prstGeom>
+          <a:solidFill>
+            <a:srgbClr val="F2F2F2"/>
+          </a:solidFill>
+          <a:ln w="6350">
+            <a:solidFill>
+              <a:srgbClr val="E2E8F0"/>
+            </a:solidFill>
+          </a:ln>
+        </p:spPr>
+        <p:style>
+          <a:lnRef idx="1">
+            <a:schemeClr val="accent1"/>
+          </a:lnRef>
+          <a:fillRef idx="3">
+            <a:schemeClr val="accent1"/>
+          </a:fillRef>
+          <a:effectRef idx="2">
+            <a:schemeClr val="accent1"/>
+          </a:effectRef>
+          <a:fontRef idx="minor">
+            <a:schemeClr val="lt1"/>
+          </a:fontRef>
+        </p:style>
+        <p:txBody>
+          <a:bodyPr rtlCol="0" anchor="ctr" wrap="square"/>
+          <a:lstStyle/>
+          <a:p>
+            <a:pPr algn="ctr">
+              <a:defRPr sz="800" b="0">
+                <a:solidFill>
+                  <a:srgbClr val="D97706"/>
+                </a:solidFill>
+                <a:latin typeface="Calibri"/>
+              </a:defRPr>
+            </a:pPr>
+            <a:r>
+              <a:t>83.3%</a:t>
+            </a:r>
+          </a:p>
+        </p:txBody>
+      </p:sp>
+      <p:sp>
+        <p:nvSpPr>
+          <p:cNvPr id="26" name="Rectangle 25"/>
+          <p:cNvSpPr/>
+          <p:nvPr/>
+        </p:nvSpPr>
+        <p:spPr>
+          <a:xfrm>
+            <a:off x="6903720" y="2167128"/>
+            <a:ext cx="1508760" cy="438912"/>
+          </a:xfrm>
+          <a:prstGeom prst="rect">
+            <a:avLst/>
+          </a:prstGeom>
+          <a:solidFill>
+            <a:srgbClr val="F2F2F2"/>
+          </a:solidFill>
+          <a:ln w="6350">
+            <a:solidFill>
+              <a:srgbClr val="E2E8F0"/>
+            </a:solidFill>
+          </a:ln>
+        </p:spPr>
+        <p:style>
+          <a:lnRef idx="1">
+            <a:schemeClr val="accent1"/>
+          </a:lnRef>
+          <a:fillRef idx="3">
+            <a:schemeClr val="accent1"/>
+          </a:fillRef>
+          <a:effectRef idx="2">
+            <a:schemeClr val="accent1"/>
+          </a:effectRef>
+          <a:fontRef idx="minor">
+            <a:schemeClr val="lt1"/>
+          </a:fontRef>
+        </p:style>
+        <p:txBody>
+          <a:bodyPr rtlCol="0" anchor="ctr" wrap="square"/>
+          <a:lstStyle/>
+          <a:p>
+            <a:pPr algn="ctr">
+              <a:defRPr sz="800" b="0">
+                <a:solidFill>
+                  <a:srgbClr val="D97706"/>
+                </a:solidFill>
+                <a:latin typeface="Calibri"/>
+              </a:defRPr>
+            </a:pPr>
+            <a:r>
+              <a:t>94.1%</a:t>
+            </a:r>
+          </a:p>
+        </p:txBody>
+      </p:sp>
+      <p:sp>
+        <p:nvSpPr>
+          <p:cNvPr id="27" name="Rectangle 26"/>
+          <p:cNvSpPr/>
+          <p:nvPr/>
+        </p:nvSpPr>
+        <p:spPr>
+          <a:xfrm>
+            <a:off x="8503920" y="2167128"/>
+            <a:ext cx="1508760" cy="438912"/>
+          </a:xfrm>
+          <a:prstGeom prst="rect">
+            <a:avLst/>
+          </a:prstGeom>
+          <a:solidFill>
+            <a:srgbClr val="F2F2F2"/>
+          </a:solidFill>
+          <a:ln w="6350">
+            <a:solidFill>
+              <a:srgbClr val="E2E8F0"/>
+            </a:solidFill>
+          </a:ln>
+        </p:spPr>
+        <p:style>
+          <a:lnRef idx="1">
+            <a:schemeClr val="accent1"/>
+          </a:lnRef>
+          <a:fillRef idx="3">
+            <a:schemeClr val="accent1"/>
+          </a:fillRef>
+          <a:effectRef idx="2">
+            <a:schemeClr val="accent1"/>
+          </a:effectRef>
+          <a:fontRef idx="minor">
+            <a:schemeClr val="lt1"/>
+          </a:fontRef>
+        </p:style>
+        <p:txBody>
+          <a:bodyPr rtlCol="0" anchor="ctr" wrap="square"/>
+          <a:lstStyle/>
+          <a:p>
+            <a:pPr algn="ctr">
+              <a:defRPr sz="800" b="0">
+                <a:solidFill>
+                  <a:srgbClr val="D97706"/>
+                </a:solidFill>
+                <a:latin typeface="Calibri"/>
+              </a:defRPr>
+            </a:pPr>
+            <a:r>
+              <a:t>Pass w/ gaps</a:t>
+            </a:r>
+          </a:p>
+        </p:txBody>
+      </p:sp>
+      <p:sp>
+        <p:nvSpPr>
+          <p:cNvPr id="28" name="Rectangle 27"/>
+          <p:cNvSpPr/>
+          <p:nvPr/>
+        </p:nvSpPr>
+        <p:spPr>
+          <a:xfrm>
+            <a:off x="10104120" y="2167128"/>
+            <a:ext cx="1508760" cy="438912"/>
+          </a:xfrm>
+          <a:prstGeom prst="rect">
+            <a:avLst/>
+          </a:prstGeom>
+          <a:solidFill>
+            <a:srgbClr val="F2F2F2"/>
+          </a:solidFill>
+          <a:ln w="6350">
+            <a:solidFill>
+              <a:srgbClr val="E2E8F0"/>
+            </a:solidFill>
+          </a:ln>
+        </p:spPr>
+        <p:style>
+          <a:lnRef idx="1">
+            <a:schemeClr val="accent1"/>
+          </a:lnRef>
+          <a:fillRef idx="3">
+            <a:schemeClr val="accent1"/>
+          </a:fillRef>
+          <a:effectRef idx="2">
+            <a:schemeClr val="accent1"/>
+          </a:effectRef>
+          <a:fontRef idx="minor">
+            <a:schemeClr val="lt1"/>
+          </a:fontRef>
+        </p:style>
+        <p:txBody>
+          <a:bodyPr rtlCol="0" anchor="ctr" wrap="square"/>
+          <a:lstStyle/>
+          <a:p>
+            <a:pPr algn="ctr">
+              <a:defRPr sz="800" b="0">
+                <a:solidFill>
+                  <a:srgbClr val="334155"/>
+                </a:solidFill>
+                <a:latin typeface="Calibri"/>
+              </a:defRPr>
+            </a:pPr>
+            <a:r>
+              <a:t>Confluence LADR requirements · No PR · dev…</a:t>
+            </a:r>
+          </a:p>
+        </p:txBody>
+      </p:sp>
+      <p:sp>
+        <p:nvSpPr>
+          <p:cNvPr id="29" name="Rectangle 28"/>
+          <p:cNvSpPr/>
+          <p:nvPr/>
+        </p:nvSpPr>
+        <p:spPr>
+          <a:xfrm>
+            <a:off x="502920" y="2642616"/>
+            <a:ext cx="1508760" cy="438912"/>
+          </a:xfrm>
+          <a:prstGeom prst="rect">
+            <a:avLst/>
+          </a:prstGeom>
+          <a:solidFill>
+            <a:srgbClr val="FFFFFF"/>
+          </a:solidFill>
+          <a:ln w="6350">
+            <a:solidFill>
+              <a:srgbClr val="E2E8F0"/>
+            </a:solidFill>
+          </a:ln>
+        </p:spPr>
+        <p:style>
+          <a:lnRef idx="1">
+            <a:schemeClr val="accent1"/>
+          </a:lnRef>
+          <a:fillRef idx="3">
+            <a:schemeClr val="accent1"/>
+          </a:fillRef>
+          <a:effectRef idx="2">
+            <a:schemeClr val="accent1"/>
+          </a:effectRef>
+          <a:fontRef idx="minor">
+            <a:schemeClr val="lt1"/>
+          </a:fontRef>
+        </p:style>
+        <p:txBody>
+          <a:bodyPr rtlCol="0" anchor="ctr" wrap="square"/>
+          <a:lstStyle/>
+          <a:p>
+            <a:pPr algn="ctr">
+              <a:defRPr sz="800" b="1">
+                <a:solidFill>
+                  <a:srgbClr val="1A1A1A"/>
+                </a:solidFill>
+                <a:latin typeface="Calibri"/>
+              </a:defRPr>
+            </a:pPr>
+            <a:r>
+              <a:t>MSC-195138</a:t>
+            </a:r>
+          </a:p>
+        </p:txBody>
+      </p:sp>
+      <p:sp>
+        <p:nvSpPr>
+          <p:cNvPr id="30" name="Rectangle 29"/>
+          <p:cNvSpPr/>
+          <p:nvPr/>
+        </p:nvSpPr>
+        <p:spPr>
+          <a:xfrm>
+            <a:off x="2103120" y="2642616"/>
+            <a:ext cx="1508760" cy="438912"/>
+          </a:xfrm>
+          <a:prstGeom prst="rect">
+            <a:avLst/>
+          </a:prstGeom>
+          <a:solidFill>
+            <a:srgbClr val="FFFFFF"/>
+          </a:solidFill>
+          <a:ln w="6350">
+            <a:solidFill>
+              <a:srgbClr val="E2E8F0"/>
+            </a:solidFill>
+          </a:ln>
+        </p:spPr>
+        <p:style>
+          <a:lnRef idx="1">
+            <a:schemeClr val="accent1"/>
+          </a:lnRef>
+          <a:fillRef idx="3">
+            <a:schemeClr val="accent1"/>
+          </a:fillRef>
+          <a:effectRef idx="2">
+            <a:schemeClr val="accent1"/>
+          </a:effectRef>
+          <a:fontRef idx="minor">
+            <a:schemeClr val="lt1"/>
+          </a:fontRef>
+        </p:style>
+        <p:txBody>
+          <a:bodyPr rtlCol="0" anchor="ctr" wrap="square"/>
+          <a:lstStyle/>
+          <a:p>
+            <a:pPr algn="ctr">
+              <a:defRPr sz="800" b="0">
+                <a:solidFill>
+                  <a:srgbClr val="1A1A1A"/>
+                </a:solidFill>
+                <a:latin typeface="Calibri"/>
+              </a:defRPr>
+            </a:pPr>
+            <a:r>
+              <a:t>Story · Done</a:t>
+            </a:r>
+          </a:p>
+        </p:txBody>
+      </p:sp>
+      <p:sp>
+        <p:nvSpPr>
+          <p:cNvPr id="31" name="Rectangle 30"/>
+          <p:cNvSpPr/>
+          <p:nvPr/>
+        </p:nvSpPr>
+        <p:spPr>
+          <a:xfrm>
+            <a:off x="3703320" y="2642616"/>
+            <a:ext cx="1508760" cy="438912"/>
+          </a:xfrm>
+          <a:prstGeom prst="rect">
+            <a:avLst/>
+          </a:prstGeom>
+          <a:solidFill>
+            <a:srgbClr val="FFFFFF"/>
+          </a:solidFill>
+          <a:ln w="6350">
+            <a:solidFill>
+              <a:srgbClr val="E2E8F0"/>
+            </a:solidFill>
+          </a:ln>
+        </p:spPr>
+        <p:style>
+          <a:lnRef idx="1">
+            <a:schemeClr val="accent1"/>
+          </a:lnRef>
+          <a:fillRef idx="3">
+            <a:schemeClr val="accent1"/>
+          </a:fillRef>
+          <a:effectRef idx="2">
+            <a:schemeClr val="accent1"/>
+          </a:effectRef>
+          <a:fontRef idx="minor">
+            <a:schemeClr val="lt1"/>
+          </a:fontRef>
+        </p:style>
+        <p:txBody>
+          <a:bodyPr rtlCol="0" anchor="ctr" wrap="square"/>
+          <a:lstStyle/>
+          <a:p>
+            <a:pPr algn="ctr">
+              <a:defRPr sz="800" b="0">
+                <a:solidFill>
+                  <a:srgbClr val="D97706"/>
+                </a:solidFill>
+                <a:latin typeface="Calibri"/>
+              </a:defRPr>
+            </a:pPr>
+            <a:r>
+              <a:t>83.3%</a:t>
+            </a:r>
+          </a:p>
+        </p:txBody>
+      </p:sp>
+      <p:sp>
+        <p:nvSpPr>
+          <p:cNvPr id="32" name="Rectangle 31"/>
+          <p:cNvSpPr/>
+          <p:nvPr/>
+        </p:nvSpPr>
+        <p:spPr>
+          <a:xfrm>
+            <a:off x="5303520" y="2642616"/>
+            <a:ext cx="1508760" cy="438912"/>
+          </a:xfrm>
+          <a:prstGeom prst="rect">
+            <a:avLst/>
+          </a:prstGeom>
+          <a:solidFill>
+            <a:srgbClr val="FFFFFF"/>
+          </a:solidFill>
+          <a:ln w="6350">
+            <a:solidFill>
+              <a:srgbClr val="E2E8F0"/>
+            </a:solidFill>
+          </a:ln>
+        </p:spPr>
+        <p:style>
+          <a:lnRef idx="1">
+            <a:schemeClr val="accent1"/>
+          </a:lnRef>
+          <a:fillRef idx="3">
+            <a:schemeClr val="accent1"/>
+          </a:fillRef>
+          <a:effectRef idx="2">
+            <a:schemeClr val="accent1"/>
+          </a:effectRef>
+          <a:fontRef idx="minor">
+            <a:schemeClr val="lt1"/>
+          </a:fontRef>
+        </p:style>
+        <p:txBody>
+          <a:bodyPr rtlCol="0" anchor="ctr" wrap="square"/>
+          <a:lstStyle/>
+          <a:p>
+            <a:pPr algn="ctr">
+              <a:defRPr sz="800" b="0">
+                <a:solidFill>
+                  <a:srgbClr val="D97706"/>
+                </a:solidFill>
+                <a:latin typeface="Calibri"/>
+              </a:defRPr>
+            </a:pPr>
+            <a:r>
+              <a:t>83.3%</a:t>
+            </a:r>
+          </a:p>
+        </p:txBody>
+      </p:sp>
+      <p:sp>
+        <p:nvSpPr>
+          <p:cNvPr id="33" name="Rectangle 32"/>
+          <p:cNvSpPr/>
+          <p:nvPr/>
+        </p:nvSpPr>
+        <p:spPr>
+          <a:xfrm>
+            <a:off x="6903720" y="2642616"/>
+            <a:ext cx="1508760" cy="438912"/>
+          </a:xfrm>
+          <a:prstGeom prst="rect">
+            <a:avLst/>
+          </a:prstGeom>
+          <a:solidFill>
+            <a:srgbClr val="FFFFFF"/>
+          </a:solidFill>
+          <a:ln w="6350">
+            <a:solidFill>
+              <a:srgbClr val="E2E8F0"/>
+            </a:solidFill>
+          </a:ln>
+        </p:spPr>
+        <p:style>
+          <a:lnRef idx="1">
+            <a:schemeClr val="accent1"/>
+          </a:lnRef>
+          <a:fillRef idx="3">
+            <a:schemeClr val="accent1"/>
+          </a:fillRef>
+          <a:effectRef idx="2">
+            <a:schemeClr val="accent1"/>
+          </a:effectRef>
+          <a:fontRef idx="minor">
+            <a:schemeClr val="lt1"/>
+          </a:fontRef>
+        </p:style>
+        <p:txBody>
+          <a:bodyPr rtlCol="0" anchor="ctr" wrap="square"/>
+          <a:lstStyle/>
+          <a:p>
+            <a:pPr algn="ctr">
+              <a:defRPr sz="800" b="0">
+                <a:solidFill>
+                  <a:srgbClr val="D97706"/>
+                </a:solidFill>
+                <a:latin typeface="Calibri"/>
+              </a:defRPr>
+            </a:pPr>
+            <a:r>
+              <a:t>66.7%</a:t>
+            </a:r>
+          </a:p>
+        </p:txBody>
+      </p:sp>
+      <p:sp>
+        <p:nvSpPr>
+          <p:cNvPr id="34" name="Rectangle 33"/>
+          <p:cNvSpPr/>
+          <p:nvPr/>
+        </p:nvSpPr>
+        <p:spPr>
+          <a:xfrm>
+            <a:off x="8503920" y="2642616"/>
+            <a:ext cx="1508760" cy="438912"/>
+          </a:xfrm>
+          <a:prstGeom prst="rect">
+            <a:avLst/>
+          </a:prstGeom>
+          <a:solidFill>
+            <a:srgbClr val="FFFFFF"/>
+          </a:solidFill>
+          <a:ln w="6350">
+            <a:solidFill>
+              <a:srgbClr val="E2E8F0"/>
+            </a:solidFill>
+          </a:ln>
+        </p:spPr>
+        <p:style>
+          <a:lnRef idx="1">
+            <a:schemeClr val="accent1"/>
+          </a:lnRef>
+          <a:fillRef idx="3">
+            <a:schemeClr val="accent1"/>
+          </a:fillRef>
+          <a:effectRef idx="2">
+            <a:schemeClr val="accent1"/>
+          </a:effectRef>
+          <a:fontRef idx="minor">
+            <a:schemeClr val="lt1"/>
+          </a:fontRef>
+        </p:style>
+        <p:txBody>
+          <a:bodyPr rtlCol="0" anchor="ctr" wrap="square"/>
+          <a:lstStyle/>
+          <a:p>
+            <a:pPr algn="ctr">
+              <a:defRPr sz="800" b="0">
+                <a:solidFill>
+                  <a:srgbClr val="D97706"/>
+                </a:solidFill>
+                <a:latin typeface="Calibri"/>
+              </a:defRPr>
+            </a:pPr>
+            <a:r>
+              <a:t>Pass w/ gaps</a:t>
+            </a:r>
+          </a:p>
+        </p:txBody>
+      </p:sp>
+      <p:sp>
+        <p:nvSpPr>
+          <p:cNvPr id="35" name="Rectangle 34"/>
+          <p:cNvSpPr/>
+          <p:nvPr/>
+        </p:nvSpPr>
+        <p:spPr>
+          <a:xfrm>
+            <a:off x="10104120" y="2642616"/>
+            <a:ext cx="1508760" cy="438912"/>
+          </a:xfrm>
+          <a:prstGeom prst="rect">
+            <a:avLst/>
+          </a:prstGeom>
+          <a:solidFill>
+            <a:srgbClr val="FFFFFF"/>
+          </a:solidFill>
+          <a:ln w="6350">
+            <a:solidFill>
+              <a:srgbClr val="E2E8F0"/>
+            </a:solidFill>
+          </a:ln>
+        </p:spPr>
+        <p:style>
+          <a:lnRef idx="1">
+            <a:schemeClr val="accent1"/>
+          </a:lnRef>
+          <a:fillRef idx="3">
+            <a:schemeClr val="accent1"/>
+          </a:fillRef>
+          <a:effectRef idx="2">
+            <a:schemeClr val="accent1"/>
+          </a:effectRef>
+          <a:fontRef idx="minor">
+            <a:schemeClr val="lt1"/>
+          </a:fontRef>
+        </p:style>
+        <p:txBody>
+          <a:bodyPr rtlCol="0" anchor="ctr" wrap="square"/>
+          <a:lstStyle/>
+          <a:p>
+            <a:pPr algn="ctr">
+              <a:defRPr sz="800" b="0">
+                <a:solidFill>
+                  <a:srgbClr val="334155"/>
+                </a:solidFill>
+                <a:latin typeface="Calibri"/>
+              </a:defRPr>
+            </a:pPr>
+            <a:r>
+              <a:t>PRs #22 + #75 · MERGED · FF Race · 11/11 G…</a:t>
+            </a:r>
+          </a:p>
+        </p:txBody>
+      </p:sp>
+    </p:spTree>
+  </p:cSld>
+  <p:clrMapOvr>
+    <a:masterClrMapping/>
+  </p:clrMapOvr>
+</p:sld>
+</file>
+
+<file path=ppt/slides/slide24.xml><?xml version="1.0" encoding="utf-8"?>
 <p:sld xmlns:a="http://schemas.openxmlformats.org/drawingml/2006/main" xmlns:p="http://schemas.openxmlformats.org/presentationml/2006/main" xmlns:r="http://schemas.openxmlformats.org/officeDocument/2006/relationships">
   <p:cSld>
     <p:spTree>
@@ -20595,7 +24153,7 @@
               </a:defRPr>
             </a:pPr>
             <a:r>
-              <a:t>Cursor subagent correlates Jira AC + Confluence LADR ESS scenarios → code → dev tests → QA plan → verdict.</a:t>
+              <a:t>Cursor subagent correlates Jira AC + Confluence LADR requirements → code → dev tests → QA plan → verdict.</a:t>
             </a:r>
           </a:p>
         </p:txBody>
@@ -23612,7 +27170,7 @@
               </a:defRPr>
             </a:pPr>
             <a:r>
-              <a:t>• Maps Jira AC + LADR ESS scenarios → code → dev tests → QA scope</a:t>
+              <a:t>• Maps Jira AC + Confluence LADR requirements → code → dev tests → QA scope</a:t>
             </a:r>
           </a:p>
           <a:p>
@@ -26508,7 +30066,7 @@
           </a:p>
           <a:p>
             <a:r>
-              <a:t>ESS milestones</a:t>
+              <a:t>LADR requirements</a:t>
             </a:r>
           </a:p>
           <a:p>
@@ -27403,7 +30961,7 @@
               </a:defRPr>
             </a:pPr>
             <a:r>
-              <a:t>Performance: reports/.cache/ stores Jira, Confluence LADR, test plan, and GitHub prefetch — reuse with --from-cache --auto. When Jira comments reference LADR or wiki URLs, fetch_confluence_requirements.py (or getConfluencePage MCP) merges ESS milestones with Jira AC before test plan scoring.</a:t>
+              <a:t>Performance: reports/.cache/ stores Jira, Confluence LADR, test plan, and GitHub prefetch — reuse with --from-cache --auto. When Jira comments reference LADR or wiki URLs, fetch_confluence_requirements.py (or getConfluencePage MCP) merges Confluence LADR requirements with Jira AC before test plan scoring.</a:t>
             </a:r>
           </a:p>
         </p:txBody>

</xml_diff>

<commit_message>
Correct challenge slide to four silos including Confluence LADR.
Aligns with 4 Systems unified KPI; updates executive summary and problem narrative.

Co-authored-by: Cursor <cursoragent@cursor.com>
</commit_message>
<xml_diff>
--- a/docs/MSC-Dev-Code-and-QA-Test-Coverage-Validator-Guide.pptx
+++ b/docs/MSC-Dev-Code-and-QA-Test-Coverage-Validator-Guide.pptx
@@ -24062,7 +24062,7 @@
               </a:defRPr>
             </a:pPr>
             <a:r>
-              <a:t>Jira, GitHub, and attached Excel test plans live in silos — release reviews lack a single evidence trail.</a:t>
+              <a:t>Jira, GitHub, Excel test plans, and Confluence LADR (when linked) live in silos — release reviews lack one evidence trail.</a:t>
             </a:r>
           </a:p>
         </p:txBody>
@@ -24935,7 +24935,7 @@
               </a:defRPr>
             </a:pPr>
             <a:r>
-              <a:t>"We no longer ask five people whether the PR, unit tests, and Jira test plan align — the validator answers that in one report." — MSC QA lead workflow</a:t>
+              <a:t>"We no longer ask five people whether the PR, unit tests, Jira test plan, and LADR design doc align — the validator answers that in one report." — MSC QA lead workflow</a:t>
             </a:r>
           </a:p>
         </p:txBody>
@@ -25147,7 +25147,7 @@
               </a:defRPr>
             </a:pPr>
             <a:r>
-              <a:t>Why fragmented Jira · GitHub · Excel test plans blocks confident releases</a:t>
+              <a:t>Why fragmented Jira · GitHub · Excel test plans · Confluence LADR blocks confident releases</a:t>
             </a:r>
           </a:p>
         </p:txBody>
@@ -25482,7 +25482,7 @@
               </a:defRPr>
             </a:pPr>
             <a:r>
-              <a:t>The challenge — three silos, zero single view</a:t>
+              <a:t>The challenge — four silos, zero single view</a:t>
             </a:r>
           </a:p>
         </p:txBody>
@@ -25531,8 +25531,8 @@
         </p:nvSpPr>
         <p:spPr>
           <a:xfrm>
-            <a:off x="594360" y="1325880"/>
-            <a:ext cx="3520440" cy="2926080"/>
+            <a:off x="502920" y="1325880"/>
+            <a:ext cx="2697480" cy="2926080"/>
           </a:xfrm>
           <a:prstGeom prst="roundRect">
             <a:avLst/>
@@ -25576,7 +25576,7 @@
         </p:nvSpPr>
         <p:spPr>
           <a:xfrm>
-            <a:off x="1920240" y="1600200"/>
+            <a:off x="1417320" y="1600200"/>
             <a:ext cx="868680" cy="868680"/>
           </a:xfrm>
           <a:prstGeom prst="ellipse">
@@ -25629,8 +25629,8 @@
         </p:nvSpPr>
         <p:spPr>
           <a:xfrm>
-            <a:off x="594360" y="2606040"/>
-            <a:ext cx="3520440" cy="365760"/>
+            <a:off x="502920" y="2606040"/>
+            <a:ext cx="2697480" cy="365760"/>
           </a:xfrm>
           <a:prstGeom prst="rect">
             <a:avLst/>
@@ -25665,8 +25665,8 @@
         </p:nvSpPr>
         <p:spPr>
           <a:xfrm>
-            <a:off x="777240" y="3063240"/>
-            <a:ext cx="3154680" cy="914400"/>
+            <a:off x="612648" y="3063240"/>
+            <a:ext cx="2478024" cy="914400"/>
           </a:xfrm>
           <a:prstGeom prst="rect">
             <a:avLst/>
@@ -25706,8 +25706,8 @@
         </p:nvSpPr>
         <p:spPr>
           <a:xfrm>
-            <a:off x="4389120" y="1325880"/>
-            <a:ext cx="3520440" cy="2926080"/>
+            <a:off x="3337560" y="1325880"/>
+            <a:ext cx="2697480" cy="2926080"/>
           </a:xfrm>
           <a:prstGeom prst="roundRect">
             <a:avLst/>
@@ -25751,7 +25751,7 @@
         </p:nvSpPr>
         <p:spPr>
           <a:xfrm>
-            <a:off x="5715000" y="1600200"/>
+            <a:off x="4251960" y="1600200"/>
             <a:ext cx="868680" cy="868680"/>
           </a:xfrm>
           <a:prstGeom prst="ellipse">
@@ -25804,8 +25804,8 @@
         </p:nvSpPr>
         <p:spPr>
           <a:xfrm>
-            <a:off x="4389120" y="2606040"/>
-            <a:ext cx="3520440" cy="365760"/>
+            <a:off x="3337560" y="2606040"/>
+            <a:ext cx="2697480" cy="365760"/>
           </a:xfrm>
           <a:prstGeom prst="rect">
             <a:avLst/>
@@ -25840,8 +25840,8 @@
         </p:nvSpPr>
         <p:spPr>
           <a:xfrm>
-            <a:off x="4572000" y="3063240"/>
-            <a:ext cx="3154680" cy="914400"/>
+            <a:off x="3447288" y="3063240"/>
+            <a:ext cx="2478024" cy="914400"/>
           </a:xfrm>
           <a:prstGeom prst="rect">
             <a:avLst/>
@@ -25881,8 +25881,8 @@
         </p:nvSpPr>
         <p:spPr>
           <a:xfrm>
-            <a:off x="8183880" y="1325880"/>
-            <a:ext cx="3520440" cy="2926080"/>
+            <a:off x="6172200" y="1325880"/>
+            <a:ext cx="2697480" cy="2926080"/>
           </a:xfrm>
           <a:prstGeom prst="roundRect">
             <a:avLst/>
@@ -25926,7 +25926,7 @@
         </p:nvSpPr>
         <p:spPr>
           <a:xfrm>
-            <a:off x="9509760" y="1600200"/>
+            <a:off x="7086600" y="1600200"/>
             <a:ext cx="868680" cy="868680"/>
           </a:xfrm>
           <a:prstGeom prst="ellipse">
@@ -25979,8 +25979,8 @@
         </p:nvSpPr>
         <p:spPr>
           <a:xfrm>
-            <a:off x="8183880" y="2606040"/>
-            <a:ext cx="3520440" cy="365760"/>
+            <a:off x="6172200" y="2606040"/>
+            <a:ext cx="2697480" cy="365760"/>
           </a:xfrm>
           <a:prstGeom prst="rect">
             <a:avLst/>
@@ -26015,8 +26015,8 @@
         </p:nvSpPr>
         <p:spPr>
           <a:xfrm>
-            <a:off x="8366760" y="3063240"/>
-            <a:ext cx="3154680" cy="914400"/>
+            <a:off x="6281928" y="3063240"/>
+            <a:ext cx="2478024" cy="914400"/>
           </a:xfrm>
           <a:prstGeom prst="rect">
             <a:avLst/>
@@ -26043,7 +26043,7 @@
           </a:p>
           <a:p>
             <a:r>
-              <a:t>Given/When/Then · Mascot links</a:t>
+              <a:t>Given/When/Then · Mascot</a:t>
             </a:r>
           </a:p>
         </p:txBody>
@@ -26051,6 +26051,181 @@
       <p:sp>
         <p:nvSpPr>
           <p:cNvPr id="20" name="Rounded Rectangle 19"/>
+          <p:cNvSpPr/>
+          <p:nvPr/>
+        </p:nvSpPr>
+        <p:spPr>
+          <a:xfrm>
+            <a:off x="9006840" y="1325880"/>
+            <a:ext cx="2697480" cy="2926080"/>
+          </a:xfrm>
+          <a:prstGeom prst="roundRect">
+            <a:avLst/>
+          </a:prstGeom>
+          <a:solidFill>
+            <a:srgbClr val="CCFBF1"/>
+          </a:solidFill>
+          <a:ln w="6350">
+            <a:solidFill>
+              <a:srgbClr val="E2E8F0"/>
+            </a:solidFill>
+          </a:ln>
+        </p:spPr>
+        <p:style>
+          <a:lnRef idx="1">
+            <a:schemeClr val="accent1"/>
+          </a:lnRef>
+          <a:fillRef idx="3">
+            <a:schemeClr val="accent1"/>
+          </a:fillRef>
+          <a:effectRef idx="2">
+            <a:schemeClr val="accent1"/>
+          </a:effectRef>
+          <a:fontRef idx="minor">
+            <a:schemeClr val="lt1"/>
+          </a:fontRef>
+        </p:style>
+        <p:txBody>
+          <a:bodyPr rtlCol="0" anchor="ctr"/>
+          <a:lstStyle/>
+          <a:p>
+            <a:pPr algn="ctr"/>
+          </a:p>
+        </p:txBody>
+      </p:sp>
+      <p:sp>
+        <p:nvSpPr>
+          <p:cNvPr id="21" name="Oval 20"/>
+          <p:cNvSpPr/>
+          <p:nvPr/>
+        </p:nvSpPr>
+        <p:spPr>
+          <a:xfrm>
+            <a:off x="9921240" y="1600200"/>
+            <a:ext cx="868680" cy="868680"/>
+          </a:xfrm>
+          <a:prstGeom prst="ellipse">
+            <a:avLst/>
+          </a:prstGeom>
+          <a:solidFill>
+            <a:srgbClr val="009688"/>
+          </a:solidFill>
+          <a:ln>
+            <a:noFill/>
+          </a:ln>
+        </p:spPr>
+        <p:style>
+          <a:lnRef idx="1">
+            <a:schemeClr val="accent1"/>
+          </a:lnRef>
+          <a:fillRef idx="3">
+            <a:schemeClr val="accent1"/>
+          </a:fillRef>
+          <a:effectRef idx="2">
+            <a:schemeClr val="accent1"/>
+          </a:effectRef>
+          <a:fontRef idx="minor">
+            <a:schemeClr val="lt1"/>
+          </a:fontRef>
+        </p:style>
+        <p:txBody>
+          <a:bodyPr rtlCol="0" anchor="ctr"/>
+          <a:lstStyle/>
+          <a:p>
+            <a:pPr algn="ctr">
+              <a:defRPr sz="1800" b="1">
+                <a:solidFill>
+                  <a:srgbClr val="FFFFFF"/>
+                </a:solidFill>
+                <a:latin typeface="Calibri"/>
+              </a:defRPr>
+            </a:pPr>
+            <a:r>
+              <a:t>CF</a:t>
+            </a:r>
+          </a:p>
+        </p:txBody>
+      </p:sp>
+      <p:sp>
+        <p:nvSpPr>
+          <p:cNvPr id="22" name="TextBox 21"/>
+          <p:cNvSpPr txBox="1"/>
+          <p:nvPr/>
+        </p:nvSpPr>
+        <p:spPr>
+          <a:xfrm>
+            <a:off x="9006840" y="2606040"/>
+            <a:ext cx="2697480" cy="365760"/>
+          </a:xfrm>
+          <a:prstGeom prst="rect">
+            <a:avLst/>
+          </a:prstGeom>
+          <a:noFill/>
+        </p:spPr>
+        <p:txBody>
+          <a:bodyPr wrap="none">
+            <a:spAutoFit/>
+          </a:bodyPr>
+          <a:lstStyle/>
+          <a:p>
+            <a:pPr algn="ctr">
+              <a:defRPr sz="1800" b="1">
+                <a:solidFill>
+                  <a:srgbClr val="1A1A1A"/>
+                </a:solidFill>
+                <a:latin typeface="Calibri"/>
+              </a:defRPr>
+            </a:pPr>
+            <a:r>
+              <a:t>Confluence LADR</a:t>
+            </a:r>
+          </a:p>
+        </p:txBody>
+      </p:sp>
+      <p:sp>
+        <p:nvSpPr>
+          <p:cNvPr id="23" name="TextBox 22"/>
+          <p:cNvSpPr txBox="1"/>
+          <p:nvPr/>
+        </p:nvSpPr>
+        <p:spPr>
+          <a:xfrm>
+            <a:off x="9116568" y="3063240"/>
+            <a:ext cx="2478024" cy="914400"/>
+          </a:xfrm>
+          <a:prstGeom prst="rect">
+            <a:avLst/>
+          </a:prstGeom>
+          <a:noFill/>
+        </p:spPr>
+        <p:txBody>
+          <a:bodyPr wrap="none">
+            <a:spAutoFit/>
+          </a:bodyPr>
+          <a:lstStyle/>
+          <a:p>
+            <a:pPr algn="ctr">
+              <a:defRPr sz="1100">
+                <a:solidFill>
+                  <a:srgbClr val="334155"/>
+                </a:solidFill>
+                <a:latin typeface="Calibri"/>
+              </a:defRPr>
+            </a:pPr>
+            <a:r>
+              <a:t>Design requirements</a:t>
+            </a:r>
+          </a:p>
+          <a:p>
+            <a:r>
+              <a:t>when linked from Jira</a:t>
+            </a:r>
+          </a:p>
+        </p:txBody>
+      </p:sp>
+      <p:sp>
+        <p:nvSpPr>
+          <p:cNvPr id="24" name="Rounded Rectangle 23"/>
           <p:cNvSpPr/>
           <p:nvPr/>
         </p:nvSpPr>
@@ -26105,7 +26280,7 @@
       </p:sp>
       <p:sp>
         <p:nvSpPr>
-          <p:cNvPr id="21" name="Rounded Rectangle 20"/>
+          <p:cNvPr id="25" name="Rounded Rectangle 24"/>
           <p:cNvSpPr/>
           <p:nvPr/>
         </p:nvSpPr>
@@ -26160,7 +26335,7 @@
       </p:sp>
       <p:sp>
         <p:nvSpPr>
-          <p:cNvPr id="22" name="Rounded Rectangle 21"/>
+          <p:cNvPr id="26" name="Rounded Rectangle 25"/>
           <p:cNvSpPr/>
           <p:nvPr/>
         </p:nvSpPr>
@@ -26208,14 +26383,14 @@
               </a:defRPr>
             </a:pPr>
             <a:r>
-              <a:t>Tribal release knowledge</a:t>
-            </a:r>
-          </a:p>
-        </p:txBody>
-      </p:sp>
-      <p:sp>
-        <p:nvSpPr>
-          <p:cNvPr id="23" name="Rounded Rectangle 22"/>
+              <a:t>LADR not tied to test plan</a:t>
+            </a:r>
+          </a:p>
+        </p:txBody>
+      </p:sp>
+      <p:sp>
+        <p:nvSpPr>
+          <p:cNvPr id="27" name="Rounded Rectangle 26"/>
           <p:cNvSpPr/>
           <p:nvPr/>
         </p:nvSpPr>
@@ -26263,14 +26438,14 @@
               </a:defRPr>
             </a:pPr>
             <a:r>
-              <a:t>Weak test-plan ↔ AC mapping</a:t>
-            </a:r>
-          </a:p>
-        </p:txBody>
-      </p:sp>
-      <p:sp>
-        <p:nvSpPr>
-          <p:cNvPr id="24" name="Rounded Rectangle 23"/>
+              <a:t>Weak AC ↔ evidence mapping</a:t>
+            </a:r>
+          </a:p>
+        </p:txBody>
+      </p:sp>
+      <p:sp>
+        <p:nvSpPr>
+          <p:cNvPr id="28" name="Rounded Rectangle 27"/>
           <p:cNvSpPr/>
           <p:nvPr/>
         </p:nvSpPr>
@@ -26313,7 +26488,7 @@
       </p:sp>
       <p:sp>
         <p:nvSpPr>
-          <p:cNvPr id="25" name="TextBox 24"/>
+          <p:cNvPr id="29" name="TextBox 28"/>
           <p:cNvSpPr txBox="1"/>
           <p:nvPr/>
         </p:nvSpPr>
@@ -26342,7 +26517,7 @@
               </a:defRPr>
             </a:pPr>
             <a:r>
-              <a:t>→  MSC Dev Code and QA Test Coverage Validator unifies all three into one HTML readiness report with numbered recommended actions</a:t>
+              <a:t>→  MSC Dev Code and QA Test Coverage Validator unifies all four silos into one HTML readiness report with numbered recommended actions</a:t>
             </a:r>
           </a:p>
         </p:txBody>
@@ -26748,7 +26923,7 @@
               </a:defRPr>
             </a:pPr>
             <a:r>
-              <a:t>• AC in Jira, code in GitHub, test plans in Jira Excel attachments — no single view</a:t>
+              <a:t>• AC in Jira, code in GitHub, Excel test plans, and Confluence LADR — four silos, no single view</a:t>
             </a:r>
           </a:p>
           <a:p>

</xml_diff>

<commit_message>
Tie Confluence LADR to Excel test plan in validator report and PPT.
Adds LADR traceability table in report section 3, ladrTraceability cache,
build_testplan_report_fields helper, and PPT wording for LADR-to-test-case mapping.

Co-authored-by: Cursor <cursoragent@cursor.com>
</commit_message>
<xml_diff>
--- a/docs/MSC-Dev-Code-and-QA-Test-Coverage-Validator-Guide.pptx
+++ b/docs/MSC-Dev-Code-and-QA-Test-Coverage-Validator-Guide.pptx
@@ -12035,7 +12035,7 @@
               </a:defRPr>
             </a:pPr>
             <a:r>
-              <a:t>→ Test cases map to both (semantic match)</a:t>
+              <a:t>→ Test cases map to R* and L* (semantic match)</a:t>
             </a:r>
           </a:p>
         </p:txBody>
@@ -12071,6 +12071,42 @@
               </a:defRPr>
             </a:pPr>
             <a:r>
+              <a:t>→ Report §3: LADR ↔ test case traceability table</a:t>
+            </a:r>
+          </a:p>
+        </p:txBody>
+      </p:sp>
+      <p:sp>
+        <p:nvSpPr>
+          <p:cNvPr id="23" name="TextBox 22"/>
+          <p:cNvSpPr txBox="1"/>
+          <p:nvPr/>
+        </p:nvSpPr>
+        <p:spPr>
+          <a:xfrm>
+            <a:off x="8183879" y="3639312"/>
+            <a:ext cx="3291840" cy="411480"/>
+          </a:xfrm>
+          <a:prstGeom prst="rect">
+            <a:avLst/>
+          </a:prstGeom>
+          <a:noFill/>
+        </p:spPr>
+        <p:txBody>
+          <a:bodyPr wrap="none">
+            <a:spAutoFit/>
+          </a:bodyPr>
+          <a:lstStyle/>
+          <a:p>
+            <a:pPr>
+              <a:defRPr sz="1000">
+                <a:solidFill>
+                  <a:srgbClr val="334155"/>
+                </a:solidFill>
+                <a:latin typeface="Calibri"/>
+              </a:defRPr>
+            </a:pPr>
+            <a:r>
               <a:t>→ Test plan AC coverage % uses combined set</a:t>
             </a:r>
           </a:p>
@@ -12078,7 +12114,7 @@
       </p:sp>
       <p:sp>
         <p:nvSpPr>
-          <p:cNvPr id="23" name="Rounded Rectangle 22"/>
+          <p:cNvPr id="24" name="Rounded Rectangle 23"/>
           <p:cNvSpPr/>
           <p:nvPr/>
         </p:nvSpPr>
@@ -12123,7 +12159,7 @@
       </p:sp>
       <p:sp>
         <p:nvSpPr>
-          <p:cNvPr id="24" name="TextBox 23"/>
+          <p:cNvPr id="25" name="TextBox 24"/>
           <p:cNvSpPr txBox="1"/>
           <p:nvPr/>
         </p:nvSpPr>
@@ -12159,7 +12195,7 @@
       </p:sp>
       <p:sp>
         <p:nvSpPr>
-          <p:cNvPr id="25" name="Rectangle 24"/>
+          <p:cNvPr id="26" name="Rectangle 25"/>
           <p:cNvSpPr/>
           <p:nvPr/>
         </p:nvSpPr>
@@ -12214,7 +12250,7 @@
       </p:sp>
       <p:sp>
         <p:nvSpPr>
-          <p:cNvPr id="26" name="Rounded Rectangle 25"/>
+          <p:cNvPr id="27" name="Rounded Rectangle 26"/>
           <p:cNvSpPr/>
           <p:nvPr/>
         </p:nvSpPr>
@@ -12269,7 +12305,7 @@
       </p:sp>
       <p:sp>
         <p:nvSpPr>
-          <p:cNvPr id="27" name="Rounded Rectangle 26"/>
+          <p:cNvPr id="28" name="Rounded Rectangle 27"/>
           <p:cNvSpPr/>
           <p:nvPr/>
         </p:nvSpPr>
@@ -12324,7 +12360,7 @@
       </p:sp>
       <p:sp>
         <p:nvSpPr>
-          <p:cNvPr id="28" name="Rounded Rectangle 27"/>
+          <p:cNvPr id="29" name="Rounded Rectangle 28"/>
           <p:cNvSpPr/>
           <p:nvPr/>
         </p:nvSpPr>
@@ -12379,7 +12415,7 @@
       </p:sp>
       <p:sp>
         <p:nvSpPr>
-          <p:cNvPr id="29" name="Rounded Rectangle 28"/>
+          <p:cNvPr id="30" name="Rounded Rectangle 29"/>
           <p:cNvSpPr/>
           <p:nvPr/>
         </p:nvSpPr>
@@ -12427,7 +12463,7 @@
               </a:defRPr>
             </a:pPr>
             <a:r>
-              <a:t>Gap list for unmapped L* / R* items</a:t>
+              <a:t>LADR ↔ test case table + gap list for unmapped L*</a:t>
             </a:r>
           </a:p>
         </p:txBody>
@@ -12934,7 +12970,7 @@
               </a:defRPr>
             </a:pPr>
             <a:r>
-              <a:t>Domino Excel test plan (Jira attachment)</a:t>
+              <a:t>LADR ↔ test plan traceability</a:t>
             </a:r>
           </a:p>
         </p:txBody>
@@ -12970,7 +13006,7 @@
               </a:defRPr>
             </a:pPr>
             <a:r>
-              <a:t>Jira attachment or local testplans/</a:t>
+              <a:t>Each L1…Ln requirement tied to Excel test case IDs in report §3</a:t>
             </a:r>
           </a:p>
         </p:txBody>
@@ -13023,7 +13059,7 @@
               </a:defRPr>
             </a:pPr>
             <a:r>
-              <a:t>fetch_jira_testplan.py</a:t>
+              <a:t>13/14 LADR mapped · MSC-204417</a:t>
             </a:r>
           </a:p>
         </p:txBody>
@@ -13104,7 +13140,7 @@
               </a:defRPr>
             </a:pPr>
             <a:r>
-              <a:t>Given / When / Then</a:t>
+              <a:t>Domino Excel test plan (Jira attachment)</a:t>
             </a:r>
           </a:p>
         </p:txBody>
@@ -13140,7 +13176,7 @@
               </a:defRPr>
             </a:pPr>
             <a:r>
-              <a:t>Content-based Given/When/Then scoring (not column-name only)</a:t>
+              <a:t>Jira attachment or local testplans/</a:t>
             </a:r>
           </a:p>
         </p:txBody>
@@ -13193,7 +13229,7 @@
               </a:defRPr>
             </a:pPr>
             <a:r>
-              <a:t>12/12 GWT · MSC-204417</a:t>
+              <a:t>fetch_jira_testplan.py</a:t>
             </a:r>
           </a:p>
         </p:txBody>
@@ -13274,7 +13310,7 @@
               </a:defRPr>
             </a:pPr>
             <a:r>
-              <a:t>LADR + Jira AC mapping</a:t>
+              <a:t>Given / When / Then</a:t>
             </a:r>
           </a:p>
         </p:txBody>
@@ -13310,7 +13346,7 @@
               </a:defRPr>
             </a:pPr>
             <a:r>
-              <a:t>Semantic match of test cases to Jira AC and Confluence LADR requirements</a:t>
+              <a:t>Content-based Given/When/Then scoring (not column-name only)</a:t>
             </a:r>
           </a:p>
         </p:txBody>
@@ -13363,7 +13399,7 @@
               </a:defRPr>
             </a:pPr>
             <a:r>
-              <a:t>94.1% · MSC-204417</a:t>
+              <a:t>12/12 GWT · MSC-204417</a:t>
             </a:r>
           </a:p>
         </p:txBody>
@@ -13444,7 +13480,7 @@
               </a:defRPr>
             </a:pPr>
             <a:r>
-              <a:t>Mascot hyperlinks</a:t>
+              <a:t>LADR + Jira AC mapping</a:t>
             </a:r>
           </a:p>
         </p:txBody>
@@ -13480,7 +13516,7 @@
               </a:defRPr>
             </a:pPr>
             <a:r>
-              <a:t>Evidence column URLs rendered in report</a:t>
+              <a:t>Semantic match of test cases to Jira AC and Confluence LADR requirements</a:t>
             </a:r>
           </a:p>
         </p:txBody>
@@ -13533,7 +13569,7 @@
               </a:defRPr>
             </a:pPr>
             <a:r>
-              <a:t>Monitor E2E traceability</a:t>
+              <a:t>94.1% · MSC-204417</a:t>
             </a:r>
           </a:p>
         </p:txBody>
@@ -13546,14 +13582,14 @@
         </p:nvSpPr>
         <p:spPr>
           <a:xfrm>
-            <a:off x="6217920" y="5349240"/>
-            <a:ext cx="5440680" cy="365760"/>
-          </a:xfrm>
-          <a:prstGeom prst="rect">
-            <a:avLst/>
-          </a:prstGeom>
-          <a:solidFill>
-            <a:srgbClr val="04066C"/>
+            <a:off x="502920" y="5166360"/>
+            <a:ext cx="73152" cy="868680"/>
+          </a:xfrm>
+          <a:prstGeom prst="rect">
+            <a:avLst/>
+          </a:prstGeom>
+          <a:solidFill>
+            <a:srgbClr val="FF5E4F"/>
           </a:solidFill>
           <a:ln w="6350">
             <a:solidFill>
@@ -13576,39 +13612,154 @@
           </a:fontRef>
         </p:style>
         <p:txBody>
+          <a:bodyPr rtlCol="0" anchor="ctr"/>
+          <a:lstStyle/>
+          <a:p>
+            <a:pPr algn="ctr"/>
+          </a:p>
+        </p:txBody>
+      </p:sp>
+      <p:sp>
+        <p:nvSpPr>
+          <p:cNvPr id="29" name="TextBox 28"/>
+          <p:cNvSpPr txBox="1"/>
+          <p:nvPr/>
+        </p:nvSpPr>
+        <p:spPr>
+          <a:xfrm>
+            <a:off x="685800" y="5166360"/>
+            <a:ext cx="5029200" cy="320040"/>
+          </a:xfrm>
+          <a:prstGeom prst="rect">
+            <a:avLst/>
+          </a:prstGeom>
+          <a:noFill/>
+        </p:spPr>
+        <p:txBody>
+          <a:bodyPr wrap="none">
+            <a:spAutoFit/>
+          </a:bodyPr>
+          <a:lstStyle/>
+          <a:p>
+            <a:pPr>
+              <a:defRPr sz="1400" b="1">
+                <a:solidFill>
+                  <a:srgbClr val="04066C"/>
+                </a:solidFill>
+                <a:latin typeface="Calibri"/>
+              </a:defRPr>
+            </a:pPr>
+            <a:r>
+              <a:t>Mascot hyperlinks</a:t>
+            </a:r>
+          </a:p>
+        </p:txBody>
+      </p:sp>
+      <p:sp>
+        <p:nvSpPr>
+          <p:cNvPr id="30" name="TextBox 29"/>
+          <p:cNvSpPr txBox="1"/>
+          <p:nvPr/>
+        </p:nvSpPr>
+        <p:spPr>
+          <a:xfrm>
+            <a:off x="685800" y="5513832"/>
+            <a:ext cx="5303520" cy="457200"/>
+          </a:xfrm>
+          <a:prstGeom prst="rect">
+            <a:avLst/>
+          </a:prstGeom>
+          <a:noFill/>
+        </p:spPr>
+        <p:txBody>
+          <a:bodyPr wrap="none">
+            <a:spAutoFit/>
+          </a:bodyPr>
+          <a:lstStyle/>
+          <a:p>
+            <a:pPr>
+              <a:defRPr sz="1100">
+                <a:solidFill>
+                  <a:srgbClr val="334155"/>
+                </a:solidFill>
+                <a:latin typeface="Calibri"/>
+              </a:defRPr>
+            </a:pPr>
+            <a:r>
+              <a:t>Evidence column URLs rendered in report</a:t>
+            </a:r>
+          </a:p>
+        </p:txBody>
+      </p:sp>
+      <p:sp>
+        <p:nvSpPr>
+          <p:cNvPr id="31" name="Rounded Rectangle 30"/>
+          <p:cNvSpPr/>
+          <p:nvPr/>
+        </p:nvSpPr>
+        <p:spPr>
+          <a:xfrm>
+            <a:off x="6217920" y="5303520"/>
+            <a:ext cx="5440680" cy="685800"/>
+          </a:xfrm>
+          <a:prstGeom prst="roundRect">
+            <a:avLst/>
+          </a:prstGeom>
+          <a:solidFill>
+            <a:srgbClr val="E8F0FE"/>
+          </a:solidFill>
+          <a:ln w="6350">
+            <a:noFill/>
+          </a:ln>
+        </p:spPr>
+        <p:style>
+          <a:lnRef idx="1">
+            <a:schemeClr val="accent1"/>
+          </a:lnRef>
+          <a:fillRef idx="3">
+            <a:schemeClr val="accent1"/>
+          </a:fillRef>
+          <a:effectRef idx="2">
+            <a:schemeClr val="accent1"/>
+          </a:effectRef>
+          <a:fontRef idx="minor">
+            <a:schemeClr val="lt1"/>
+          </a:fontRef>
+        </p:style>
+        <p:txBody>
           <a:bodyPr rtlCol="0" anchor="ctr" wrap="square"/>
           <a:lstStyle/>
           <a:p>
             <a:pPr algn="ctr">
-              <a:defRPr sz="1000" b="1">
-                <a:solidFill>
-                  <a:srgbClr val="FFFFFF"/>
-                </a:solidFill>
-                <a:latin typeface="Calibri"/>
-              </a:defRPr>
-            </a:pPr>
-            <a:r>
-              <a:t>Scenario examples</a:t>
-            </a:r>
-          </a:p>
-        </p:txBody>
-      </p:sp>
-      <p:sp>
-        <p:nvSpPr>
-          <p:cNvPr id="29" name="Rectangle 28"/>
+              <a:defRPr sz="1100" b="1">
+                <a:solidFill>
+                  <a:srgbClr val="04066C"/>
+                </a:solidFill>
+                <a:latin typeface="Calibri"/>
+              </a:defRPr>
+            </a:pPr>
+            <a:r>
+              <a:t>Monitor E2E traceability</a:t>
+            </a:r>
+          </a:p>
+        </p:txBody>
+      </p:sp>
+      <p:sp>
+        <p:nvSpPr>
+          <p:cNvPr id="32" name="Rectangle 31"/>
           <p:cNvSpPr/>
           <p:nvPr/>
         </p:nvSpPr>
         <p:spPr>
           <a:xfrm>
-            <a:off x="6217920" y="5742432"/>
-            <a:ext cx="5440680" cy="320040"/>
-          </a:xfrm>
-          <a:prstGeom prst="rect">
-            <a:avLst/>
-          </a:prstGeom>
-          <a:solidFill>
-            <a:srgbClr val="F2F2F2"/>
+            <a:off x="6217920" y="5349240"/>
+            <a:ext cx="5440680" cy="365760"/>
+          </a:xfrm>
+          <a:prstGeom prst="rect">
+            <a:avLst/>
+          </a:prstGeom>
+          <a:solidFill>
+            <a:srgbClr val="04066C"/>
           </a:solidFill>
           <a:ln w="6350">
             <a:solidFill>
@@ -13635,35 +13786,35 @@
           <a:lstStyle/>
           <a:p>
             <a:pPr algn="ctr">
-              <a:defRPr sz="900" b="0">
-                <a:solidFill>
-                  <a:srgbClr val="334155"/>
-                </a:solidFill>
-                <a:latin typeface="Calibri"/>
-              </a:defRPr>
-            </a:pPr>
-            <a:r>
-              <a:t>MSC-204417 · LADR requirements · 94.1% test plan AC</a:t>
-            </a:r>
-          </a:p>
-        </p:txBody>
-      </p:sp>
-      <p:sp>
-        <p:nvSpPr>
-          <p:cNvPr id="30" name="Rectangle 29"/>
+              <a:defRPr sz="1000" b="1">
+                <a:solidFill>
+                  <a:srgbClr val="FFFFFF"/>
+                </a:solidFill>
+                <a:latin typeface="Calibri"/>
+              </a:defRPr>
+            </a:pPr>
+            <a:r>
+              <a:t>Scenario examples</a:t>
+            </a:r>
+          </a:p>
+        </p:txBody>
+      </p:sp>
+      <p:sp>
+        <p:nvSpPr>
+          <p:cNvPr id="33" name="Rectangle 32"/>
           <p:cNvSpPr/>
           <p:nvPr/>
         </p:nvSpPr>
         <p:spPr>
           <a:xfrm>
-            <a:off x="6217920" y="6089904"/>
+            <a:off x="6217920" y="5742432"/>
             <a:ext cx="5440680" cy="320040"/>
           </a:xfrm>
           <a:prstGeom prst="rect">
             <a:avLst/>
           </a:prstGeom>
           <a:solidFill>
-            <a:srgbClr val="E8F0FE"/>
+            <a:srgbClr val="F2F2F2"/>
           </a:solidFill>
           <a:ln w="6350">
             <a:solidFill>
@@ -13698,6 +13849,61 @@
               </a:defRPr>
             </a:pPr>
             <a:r>
+              <a:t>MSC-204417 · LADR requirements · 94.1% test plan AC</a:t>
+            </a:r>
+          </a:p>
+        </p:txBody>
+      </p:sp>
+      <p:sp>
+        <p:nvSpPr>
+          <p:cNvPr id="34" name="Rectangle 33"/>
+          <p:cNvSpPr/>
+          <p:nvPr/>
+        </p:nvSpPr>
+        <p:spPr>
+          <a:xfrm>
+            <a:off x="6217920" y="6089904"/>
+            <a:ext cx="5440680" cy="320040"/>
+          </a:xfrm>
+          <a:prstGeom prst="rect">
+            <a:avLst/>
+          </a:prstGeom>
+          <a:solidFill>
+            <a:srgbClr val="E8F0FE"/>
+          </a:solidFill>
+          <a:ln w="6350">
+            <a:solidFill>
+              <a:srgbClr val="E2E8F0"/>
+            </a:solidFill>
+          </a:ln>
+        </p:spPr>
+        <p:style>
+          <a:lnRef idx="1">
+            <a:schemeClr val="accent1"/>
+          </a:lnRef>
+          <a:fillRef idx="3">
+            <a:schemeClr val="accent1"/>
+          </a:fillRef>
+          <a:effectRef idx="2">
+            <a:schemeClr val="accent1"/>
+          </a:effectRef>
+          <a:fontRef idx="minor">
+            <a:schemeClr val="lt1"/>
+          </a:fontRef>
+        </p:style>
+        <p:txBody>
+          <a:bodyPr rtlCol="0" anchor="ctr" wrap="square"/>
+          <a:lstStyle/>
+          <a:p>
+            <a:pPr algn="ctr">
+              <a:defRPr sz="900" b="0">
+                <a:solidFill>
+                  <a:srgbClr val="334155"/>
+                </a:solidFill>
+                <a:latin typeface="Calibri"/>
+              </a:defRPr>
+            </a:pPr>
+            <a:r>
               <a:t>MSC-205625 · Inc as Fulll · 75% test plan AC</a:t>
             </a:r>
           </a:p>
@@ -13705,7 +13911,7 @@
       </p:sp>
       <p:sp>
         <p:nvSpPr>
-          <p:cNvPr id="31" name="Rectangle 30"/>
+          <p:cNvPr id="35" name="Rectangle 34"/>
           <p:cNvSpPr/>
           <p:nvPr/>
         </p:nvSpPr>
@@ -26383,7 +26589,7 @@
               </a:defRPr>
             </a:pPr>
             <a:r>
-              <a:t>LADR not tied to test plan</a:t>
+              <a:t>No LADR ↔ test plan traceability</a:t>
             </a:r>
           </a:p>
         </p:txBody>
@@ -27345,7 +27551,7 @@
               </a:defRPr>
             </a:pPr>
             <a:r>
-              <a:t>• Maps Jira AC + Confluence LADR requirements → code → dev tests → QA scope</a:t>
+              <a:t>• Maps Jira AC + LADR L1…Ln → test cases → code → dev tests</a:t>
             </a:r>
           </a:p>
           <a:p>
@@ -27361,7 +27567,7 @@
               </a:defRPr>
             </a:pPr>
             <a:r>
-              <a:t>• HTML report + Pass / Pass with gaps / Fail</a:t>
+              <a:t>• HTML report + LADR traceability table + Pass / Pass with gaps / Fail</a:t>
             </a:r>
           </a:p>
         </p:txBody>

</xml_diff>

<commit_message>
Evidence fallback: Mascot links or Edit/Job/Request UUIDs in report.
Adds testplan_evidence.py, render_testplan_evidence(), cache evidence_ids,
skill/agent/PPT updates for test plan Evidence column.

Co-authored-by: Cursor <cursoragent@cursor.com>
</commit_message>
<xml_diff>
--- a/docs/MSC-Dev-Code-and-QA-Test-Coverage-Validator-Guide.pptx
+++ b/docs/MSC-Dev-Code-and-QA-Test-Coverage-Validator-Guide.pptx
@@ -5810,7 +5810,7 @@
               </a:defRPr>
             </a:pPr>
             <a:r>
-              <a:t>Excel attachment · GWT · Mascot</a:t>
+              <a:t>Excel attachment · GWT · Mascot or IDs</a:t>
             </a:r>
           </a:p>
         </p:txBody>
@@ -12719,7 +12719,7 @@
               </a:defRPr>
             </a:pPr>
             <a:r>
-              <a:t>Confluence LADR requirements when linked · Excel attachment · Given/When/Then · Mascot</a:t>
+              <a:t>Confluence LADR requirements when linked · Excel attachment · Given/When/Then · Evidence</a:t>
             </a:r>
           </a:p>
         </p:txBody>
@@ -13650,7 +13650,7 @@
               </a:defRPr>
             </a:pPr>
             <a:r>
-              <a:t>Mascot hyperlinks</a:t>
+              <a:t>Evidence (Mascot or IDs)</a:t>
             </a:r>
           </a:p>
         </p:txBody>
@@ -13686,7 +13686,7 @@
               </a:defRPr>
             </a:pPr>
             <a:r>
-              <a:t>Evidence column URLs rendered in report</a:t>
+              <a:t>Mascot fulfillment URLs when present; else Edit ID, Job ID, Media Request, or UUID from plan or mapped Jira AC</a:t>
             </a:r>
           </a:p>
         </p:txBody>
@@ -13739,7 +13739,7 @@
               </a:defRPr>
             </a:pPr>
             <a:r>
-              <a:t>Monitor E2E traceability</a:t>
+              <a:t>Mascot links · MSC-205625</a:t>
             </a:r>
           </a:p>
         </p:txBody>
@@ -26249,7 +26249,7 @@
           </a:p>
           <a:p>
             <a:r>
-              <a:t>Given/When/Then · Mascot</a:t>
+              <a:t>Given/When/Then · Mascot or IDs</a:t>
             </a:r>
           </a:p>
         </p:txBody>

</xml_diff>

<commit_message>
Fix Evidence column: parse SIT Jobs and similar columns for Edit/Group/Pegasus IDs.
Caption Monitoring plan stores UUIDs in SIT Jobs; row_evidence_text feeds testplan_evidence extraction.

Co-authored-by: Cursor <cursoragent@cursor.com>
</commit_message>
<xml_diff>
--- a/docs/MSC-Dev-Code-and-QA-Test-Coverage-Validator-Guide.pptx
+++ b/docs/MSC-Dev-Code-and-QA-Test-Coverage-Validator-Guide.pptx
@@ -5810,7 +5810,7 @@
               </a:defRPr>
             </a:pPr>
             <a:r>
-              <a:t>Excel attachment · GWT · Mascot or IDs</a:t>
+              <a:t>Excel attachment · GWT · Mascot</a:t>
             </a:r>
           </a:p>
         </p:txBody>
@@ -12719,7 +12719,7 @@
               </a:defRPr>
             </a:pPr>
             <a:r>
-              <a:t>Confluence LADR requirements when linked · Excel attachment · Given/When/Then · Evidence</a:t>
+              <a:t>Confluence LADR requirements when linked · Excel attachment · Given/When/Then · Mascot</a:t>
             </a:r>
           </a:p>
         </p:txBody>
@@ -13650,7 +13650,7 @@
               </a:defRPr>
             </a:pPr>
             <a:r>
-              <a:t>Evidence (Mascot or IDs)</a:t>
+              <a:t>Mascot hyperlinks</a:t>
             </a:r>
           </a:p>
         </p:txBody>
@@ -13686,7 +13686,7 @@
               </a:defRPr>
             </a:pPr>
             <a:r>
-              <a:t>Mascot fulfillment URLs when present; else Edit ID, Job ID, Media Request, or UUID from plan or mapped Jira AC</a:t>
+              <a:t>Evidence column URLs rendered in report</a:t>
             </a:r>
           </a:p>
         </p:txBody>
@@ -13739,7 +13739,7 @@
               </a:defRPr>
             </a:pPr>
             <a:r>
-              <a:t>Mascot links · MSC-205625</a:t>
+              <a:t>Monitor E2E traceability</a:t>
             </a:r>
           </a:p>
         </p:txBody>
@@ -26249,7 +26249,7 @@
           </a:p>
           <a:p>
             <a:r>
-              <a:t>Given/When/Then · Mascot or IDs</a:t>
+              <a:t>Given/When/Then · Mascot</a:t>
             </a:r>
           </a:p>
         </p:txBody>

</xml_diff>

<commit_message>
Align agent, skill, command, PPT with LADR traceability and SIT Jobs evidence.
Documents render_testplan_evidence(), build_testplan_report_fields(), SIT Jobs ID parsing, and four-silo workflow in guide deck.

Co-authored-by: Cursor <cursoragent@cursor.com>
</commit_message>
<xml_diff>
--- a/docs/MSC-Dev-Code-and-QA-Test-Coverage-Validator-Guide.pptx
+++ b/docs/MSC-Dev-Code-and-QA-Test-Coverage-Validator-Guide.pptx
@@ -5810,7 +5810,7 @@
               </a:defRPr>
             </a:pPr>
             <a:r>
-              <a:t>Excel attachment · GWT · Mascot</a:t>
+              <a:t>Excel attachment · GWT · Mascot or IDs</a:t>
             </a:r>
           </a:p>
         </p:txBody>
@@ -12719,7 +12719,7 @@
               </a:defRPr>
             </a:pPr>
             <a:r>
-              <a:t>Confluence LADR requirements when linked · Excel attachment · Given/When/Then · Mascot</a:t>
+              <a:t>Confluence LADR requirements when linked · Excel attachment · Given/When/Then · Evidence</a:t>
             </a:r>
           </a:p>
         </p:txBody>
@@ -13650,7 +13650,7 @@
               </a:defRPr>
             </a:pPr>
             <a:r>
-              <a:t>Mascot hyperlinks</a:t>
+              <a:t>Evidence (Mascot or IDs)</a:t>
             </a:r>
           </a:p>
         </p:txBody>
@@ -13686,7 +13686,7 @@
               </a:defRPr>
             </a:pPr>
             <a:r>
-              <a:t>Evidence column URLs rendered in report</a:t>
+              <a:t>Mascot URLs when present; else Edit ID, Caption Group ID, Pegasus ID from SIT Jobs / Comments columns (MSC-204417 Caption Monitoring)</a:t>
             </a:r>
           </a:p>
         </p:txBody>
@@ -13739,7 +13739,7 @@
               </a:defRPr>
             </a:pPr>
             <a:r>
-              <a:t>Monitor E2E traceability</a:t>
+              <a:t>Edit ID · SIT Jobs · MSC-204417</a:t>
             </a:r>
           </a:p>
         </p:txBody>
@@ -26249,7 +26249,7 @@
           </a:p>
           <a:p>
             <a:r>
-              <a:t>Given/When/Then · Mascot</a:t>
+              <a:t>Given/When/Then · Mascot or IDs</a:t>
             </a:r>
           </a:p>
         </p:txBody>
@@ -27957,7 +27957,7 @@
               </a:defRPr>
             </a:pPr>
             <a:r>
-              <a:t>• Mascot + Given/When/Then test-plan validation</a:t>
+              <a:t>• Mascot + Given/When/Then + SIT Jobs ID evidence</a:t>
             </a:r>
           </a:p>
           <a:p>
@@ -29712,7 +29712,7 @@
               </a:defRPr>
             </a:pPr>
             <a:r>
-              <a:t>Excel plan vs Jira AC</a:t>
+              <a:t>Excel plan vs Jira AC + LADR</a:t>
             </a:r>
           </a:p>
         </p:txBody>
@@ -29748,7 +29748,7 @@
               </a:defRPr>
             </a:pPr>
             <a:r>
-              <a:t>Given/When/Then quality, Mascot links</a:t>
+              <a:t>GWT quality · Mascot or SIT Jobs IDs</a:t>
             </a:r>
           </a:p>
         </p:txBody>

</xml_diff>

<commit_message>
Sync coverage validator: build report pipeline, branch-only stories, passport LADR, CI columns, updated guide PPT
Co-authored-by: Cursor <cursoragent@cursor.com>
</commit_message>
<xml_diff>
--- a/docs/MSC-Dev-Code-and-QA-Test-Coverage-Validator-Guide.pptx
+++ b/docs/MSC-Dev-Code-and-QA-Test-Coverage-Validator-Guide.pptx
@@ -5659,7 +5659,7 @@
               </a:defRPr>
             </a:pPr>
             <a:r>
-              <a:t>PR · Repo · State · Title · Dev tests · CI</a:t>
+              <a:t>PR · Repo · State · Title · Files · Dev tests · CI</a:t>
             </a:r>
           </a:p>
         </p:txBody>
@@ -6644,7 +6644,7 @@
               </a:defRPr>
             </a:pPr>
             <a:r>
-              <a:t>MSC-205625  ·  Verdict: Pass with gaps  ·  Generated 05-29-2026 12:43 IST</a:t>
+              <a:t>MSC-212571  ·  Verdict: Fail  ·  Generated 06-02-2026 14:53 IST</a:t>
             </a:r>
           </a:p>
         </p:txBody>
@@ -7099,7 +7099,7 @@
               </a:defRPr>
             </a:pPr>
             <a:r>
-              <a:t>i  Linked PR(s) — 6 column headers (PR, Repo, State, Title, Dev tests, CI status)</a:t>
+              <a:t>i  Linked PR(s) — 7 columns (PR, Repo, State, Title, Files, Dev tests, CI status)</a:t>
             </a:r>
           </a:p>
         </p:txBody>
@@ -7925,7 +7925,7 @@
               </a:defRPr>
             </a:pPr>
             <a:r>
-              <a:t>Generated by msc-dev-code-and-qa-test-coverage-validator · Developed by Mayur Gunjal  (MSC-205625-05-29-2026-12-43-49-IST.html)</a:t>
+              <a:t>Generated by msc-dev-code-and-qa-test-coverage-validator · Developed by Mayur Gunjal  (MSC-212571-06-02-2026-14-53-07-IST.html)</a:t>
             </a:r>
           </a:p>
         </p:txBody>
@@ -8298,7 +8298,7 @@
               </a:defRPr>
             </a:pPr>
             <a:r>
-              <a:t>100%</a:t>
+              <a:t>100.0%</a:t>
             </a:r>
           </a:p>
         </p:txBody>
@@ -8415,7 +8415,7 @@
               </a:defRPr>
             </a:pPr>
             <a:r>
-              <a:t>75%</a:t>
+              <a:t>5.6%</a:t>
             </a:r>
           </a:p>
         </p:txBody>
@@ -8532,7 +8532,7 @@
               </a:defRPr>
             </a:pPr>
             <a:r>
-              <a:t>4/4 AC</a:t>
+              <a:t>6/9 AC in test plan</a:t>
             </a:r>
           </a:p>
         </p:txBody>
@@ -8685,7 +8685,7 @@
               </a:defRPr>
             </a:pPr>
             <a:r>
-              <a:t>75%</a:t>
+              <a:t>66.7%</a:t>
             </a:r>
           </a:p>
         </p:txBody>
@@ -8802,7 +8802,7 @@
               </a:defRPr>
             </a:pPr>
             <a:r>
-              <a:t>1 item</a:t>
+              <a:t>28 scenarios</a:t>
             </a:r>
           </a:p>
         </p:txBody>
@@ -8919,7 +8919,7 @@
               </a:defRPr>
             </a:pPr>
             <a:r>
-              <a:t>2 Med</a:t>
+              <a:t>0 High · 11 Med</a:t>
             </a:r>
           </a:p>
         </p:txBody>
@@ -9072,7 +9072,7 @@
               </a:defRPr>
             </a:pPr>
             <a:r>
-              <a:t>95.3%</a:t>
+              <a:t>99.2%</a:t>
             </a:r>
           </a:p>
         </p:txBody>
@@ -9189,7 +9189,7 @@
               </a:defRPr>
             </a:pPr>
             <a:r>
-              <a:t>94.5%</a:t>
+              <a:t>99.2%</a:t>
             </a:r>
           </a:p>
         </p:txBody>
@@ -9701,7 +9701,7 @@
               </a:defRPr>
             </a:pPr>
             <a:r>
-              <a:t>MSC-205625 · Domino · Inc as Fulll · 5/5 GWT · 3/4 AC · PR #161 pick-genie · MERGED · CI Passed</a:t>
+              <a:t>MSC-212571 · DirecTV Scenarios · 28/28 GWT · PR #99 partner-config OPEN · #148 transmogrifier MERGED</a:t>
             </a:r>
           </a:p>
         </p:txBody>
@@ -12188,7 +12188,7 @@
               </a:defRPr>
             </a:pPr>
             <a:r>
-              <a:t>Example — MSC-204417: Jira references a LADR doc; agent fetches Confluence LADR requirements and merges with Promo Caption Monitoring test plan (12 scenarios, Caption Monitoring · 12/12 GWT). Report MSC-204417-05-31-2026-10-19-28-IST.html: 100% dev code · 94.1% test plan AC · 16/17 AC mapped · Pass with gaps. Generic LADR parsing — not limited to one domain.</a:t>
+              <a:t>Example — MSC-204417: Jira references a LADR doc; agent fetches Confluence LADR requirements and merges with Promo Caption Monitoring test plan (12 scenarios, Caption Monitoring · 12/12 GWT). Report MSC-204417-06-02-2026-14-43-39-IST.html: 100.0% dev code · 94.1% test plan AC · 16/17 AC in test plan mapped · Fail. ESS LADR + passport scenario pages (word-boundary safe).</a:t>
             </a:r>
           </a:p>
         </p:txBody>
@@ -14440,7 +14440,7 @@
               </a:defRPr>
             </a:pPr>
             <a:r>
-              <a:t>✓  SonarQube CI — 95.3% line (PR #161)</a:t>
+              <a:t>✓  SonarQube CI — 99.2% line (PR #161)</a:t>
             </a:r>
           </a:p>
         </p:txBody>
@@ -18028,7 +18028,7 @@
               </a:defRPr>
             </a:pPr>
             <a:r>
-              <a:t>apply_report_ui_enhancements()  ·  Cache: reports/.cache/{KEY}-*.json</a:t>
+              <a:t>map_requirements_to_diff.py  ·  build_coverage_report.py  ·  apply_report_ui_enhancements()</a:t>
             </a:r>
           </a:p>
           <a:p>
@@ -18624,7 +18624,7 @@
               </a:defRPr>
             </a:pPr>
             <a:r>
-              <a:t>From generated HTML reports · MSC-205625 · MSC-204417 · MSC-195138</a:t>
+              <a:t>From HTML reports · newest: MSC-212571 (06-02-2026 14:53 IST)</a:t>
             </a:r>
           </a:p>
         </p:txBody>
@@ -19132,8 +19132,8 @@
         </p:nvSpPr>
         <p:spPr>
           <a:xfrm>
-            <a:off x="502920" y="1627632"/>
-            <a:ext cx="1212088" cy="365760"/>
+            <a:off x="502920" y="1591056"/>
+            <a:ext cx="1212088" cy="329184"/>
           </a:xfrm>
           <a:prstGeom prst="rect">
             <a:avLst/>
@@ -19174,7 +19174,7 @@
               </a:defRPr>
             </a:pPr>
             <a:r>
-              <a:t>MSC-205625</a:t>
+              <a:t>MSC-212571</a:t>
             </a:r>
           </a:p>
         </p:txBody>
@@ -19187,8 +19187,8 @@
         </p:nvSpPr>
         <p:spPr>
           <a:xfrm>
-            <a:off x="1742440" y="1627632"/>
-            <a:ext cx="1212088" cy="365760"/>
+            <a:off x="1742440" y="1591056"/>
+            <a:ext cx="1212088" cy="329184"/>
           </a:xfrm>
           <a:prstGeom prst="rect">
             <a:avLst/>
@@ -19229,7 +19229,7 @@
               </a:defRPr>
             </a:pPr>
             <a:r>
-              <a:t>100%</a:t>
+              <a:t>100.0%</a:t>
             </a:r>
           </a:p>
         </p:txBody>
@@ -19242,8 +19242,8 @@
         </p:nvSpPr>
         <p:spPr>
           <a:xfrm>
-            <a:off x="2981960" y="1627632"/>
-            <a:ext cx="1212088" cy="365760"/>
+            <a:off x="2981960" y="1591056"/>
+            <a:ext cx="1212088" cy="329184"/>
           </a:xfrm>
           <a:prstGeom prst="rect">
             <a:avLst/>
@@ -19284,7 +19284,7 @@
               </a:defRPr>
             </a:pPr>
             <a:r>
-              <a:t>75%</a:t>
+              <a:t>5.6%</a:t>
             </a:r>
           </a:p>
         </p:txBody>
@@ -19297,8 +19297,8 @@
         </p:nvSpPr>
         <p:spPr>
           <a:xfrm>
-            <a:off x="4221480" y="1627632"/>
-            <a:ext cx="1212088" cy="365760"/>
+            <a:off x="4221480" y="1591056"/>
+            <a:ext cx="1212088" cy="329184"/>
           </a:xfrm>
           <a:prstGeom prst="rect">
             <a:avLst/>
@@ -19339,7 +19339,7 @@
               </a:defRPr>
             </a:pPr>
             <a:r>
-              <a:t>4/4 AC</a:t>
+              <a:t>6/9 AC in test plan</a:t>
             </a:r>
           </a:p>
         </p:txBody>
@@ -19352,8 +19352,8 @@
         </p:nvSpPr>
         <p:spPr>
           <a:xfrm>
-            <a:off x="5461000" y="1627632"/>
-            <a:ext cx="1212088" cy="365760"/>
+            <a:off x="5461000" y="1591056"/>
+            <a:ext cx="1212088" cy="329184"/>
           </a:xfrm>
           <a:prstGeom prst="rect">
             <a:avLst/>
@@ -19394,7 +19394,7 @@
               </a:defRPr>
             </a:pPr>
             <a:r>
-              <a:t>75%</a:t>
+              <a:t>66.7%</a:t>
             </a:r>
           </a:p>
         </p:txBody>
@@ -19407,8 +19407,8 @@
         </p:nvSpPr>
         <p:spPr>
           <a:xfrm>
-            <a:off x="6700520" y="1627632"/>
-            <a:ext cx="1212088" cy="365760"/>
+            <a:off x="6700520" y="1591056"/>
+            <a:ext cx="1212088" cy="329184"/>
           </a:xfrm>
           <a:prstGeom prst="rect">
             <a:avLst/>
@@ -19449,7 +19449,7 @@
               </a:defRPr>
             </a:pPr>
             <a:r>
-              <a:t>1 item</a:t>
+              <a:t>28 scenarios</a:t>
             </a:r>
           </a:p>
         </p:txBody>
@@ -19462,8 +19462,8 @@
         </p:nvSpPr>
         <p:spPr>
           <a:xfrm>
-            <a:off x="7940040" y="1627632"/>
-            <a:ext cx="1212088" cy="365760"/>
+            <a:off x="7940040" y="1591056"/>
+            <a:ext cx="1212088" cy="329184"/>
           </a:xfrm>
           <a:prstGeom prst="rect">
             <a:avLst/>
@@ -19504,7 +19504,7 @@
               </a:defRPr>
             </a:pPr>
             <a:r>
-              <a:t>2 Med</a:t>
+              <a:t>0 High · 11 Med</a:t>
             </a:r>
           </a:p>
         </p:txBody>
@@ -19517,8 +19517,8 @@
         </p:nvSpPr>
         <p:spPr>
           <a:xfrm>
-            <a:off x="9179560" y="1627632"/>
-            <a:ext cx="1212088" cy="365760"/>
+            <a:off x="9179560" y="1591056"/>
+            <a:ext cx="1212088" cy="329184"/>
           </a:xfrm>
           <a:prstGeom prst="rect">
             <a:avLst/>
@@ -19559,7 +19559,7 @@
               </a:defRPr>
             </a:pPr>
             <a:r>
-              <a:t>95.3%</a:t>
+              <a:t>99.2%</a:t>
             </a:r>
           </a:p>
         </p:txBody>
@@ -19572,8 +19572,8 @@
         </p:nvSpPr>
         <p:spPr>
           <a:xfrm>
-            <a:off x="10419080" y="1627632"/>
-            <a:ext cx="1212088" cy="365760"/>
+            <a:off x="10419080" y="1591056"/>
+            <a:ext cx="1212088" cy="329184"/>
           </a:xfrm>
           <a:prstGeom prst="rect">
             <a:avLst/>
@@ -19608,13 +19608,13 @@
             <a:pPr algn="ctr">
               <a:defRPr sz="700" b="0">
                 <a:solidFill>
-                  <a:srgbClr val="D97706"/>
-                </a:solidFill>
-                <a:latin typeface="Calibri"/>
-              </a:defRPr>
-            </a:pPr>
-            <a:r>
-              <a:t>Pass w/ gaps</a:t>
+                  <a:srgbClr val="334155"/>
+                </a:solidFill>
+                <a:latin typeface="Calibri"/>
+              </a:defRPr>
+            </a:pPr>
+            <a:r>
+              <a:t>Fail</a:t>
             </a:r>
           </a:p>
         </p:txBody>
@@ -19627,8 +19627,8 @@
         </p:nvSpPr>
         <p:spPr>
           <a:xfrm>
-            <a:off x="502920" y="2029968"/>
-            <a:ext cx="1212088" cy="365760"/>
+            <a:off x="502920" y="1938528"/>
+            <a:ext cx="1212088" cy="329184"/>
           </a:xfrm>
           <a:prstGeom prst="rect">
             <a:avLst/>
@@ -19669,7 +19669,7 @@
               </a:defRPr>
             </a:pPr>
             <a:r>
-              <a:t>MSC-204417</a:t>
+              <a:t>MSC-205625</a:t>
             </a:r>
           </a:p>
         </p:txBody>
@@ -19682,8 +19682,8 @@
         </p:nvSpPr>
         <p:spPr>
           <a:xfrm>
-            <a:off x="1742440" y="2029968"/>
-            <a:ext cx="1212088" cy="365760"/>
+            <a:off x="1742440" y="1938528"/>
+            <a:ext cx="1212088" cy="329184"/>
           </a:xfrm>
           <a:prstGeom prst="rect">
             <a:avLst/>
@@ -19718,13 +19718,13 @@
             <a:pPr algn="ctr">
               <a:defRPr sz="700" b="0">
                 <a:solidFill>
-                  <a:srgbClr val="16A34A"/>
-                </a:solidFill>
-                <a:latin typeface="Calibri"/>
-              </a:defRPr>
-            </a:pPr>
-            <a:r>
-              <a:t>100%</a:t>
+                  <a:srgbClr val="D97706"/>
+                </a:solidFill>
+                <a:latin typeface="Calibri"/>
+              </a:defRPr>
+            </a:pPr>
+            <a:r>
+              <a:t>87.5%</a:t>
             </a:r>
           </a:p>
         </p:txBody>
@@ -19737,8 +19737,8 @@
         </p:nvSpPr>
         <p:spPr>
           <a:xfrm>
-            <a:off x="2981960" y="2029968"/>
-            <a:ext cx="1212088" cy="365760"/>
+            <a:off x="2981960" y="1938528"/>
+            <a:ext cx="1212088" cy="329184"/>
           </a:xfrm>
           <a:prstGeom prst="rect">
             <a:avLst/>
@@ -19792,8 +19792,8 @@
         </p:nvSpPr>
         <p:spPr>
           <a:xfrm>
-            <a:off x="4221480" y="2029968"/>
-            <a:ext cx="1212088" cy="365760"/>
+            <a:off x="4221480" y="1938528"/>
+            <a:ext cx="1212088" cy="329184"/>
           </a:xfrm>
           <a:prstGeom prst="rect">
             <a:avLst/>
@@ -19834,7 +19834,7 @@
               </a:defRPr>
             </a:pPr>
             <a:r>
-              <a:t>16/17 AC</a:t>
+              <a:t>7/9 AC in test plan</a:t>
             </a:r>
           </a:p>
         </p:txBody>
@@ -19847,8 +19847,8 @@
         </p:nvSpPr>
         <p:spPr>
           <a:xfrm>
-            <a:off x="5461000" y="2029968"/>
-            <a:ext cx="1212088" cy="365760"/>
+            <a:off x="5461000" y="1938528"/>
+            <a:ext cx="1212088" cy="329184"/>
           </a:xfrm>
           <a:prstGeom prst="rect">
             <a:avLst/>
@@ -19889,7 +19889,7 @@
               </a:defRPr>
             </a:pPr>
             <a:r>
-              <a:t>94.1%</a:t>
+              <a:t>77.8%</a:t>
             </a:r>
           </a:p>
         </p:txBody>
@@ -19902,8 +19902,8 @@
         </p:nvSpPr>
         <p:spPr>
           <a:xfrm>
-            <a:off x="6700520" y="2029968"/>
-            <a:ext cx="1212088" cy="365760"/>
+            <a:off x="6700520" y="1938528"/>
+            <a:ext cx="1212088" cy="329184"/>
           </a:xfrm>
           <a:prstGeom prst="rect">
             <a:avLst/>
@@ -19944,7 +19944,7 @@
               </a:defRPr>
             </a:pPr>
             <a:r>
-              <a:t>2 items</a:t>
+              <a:t>5 scenarios</a:t>
             </a:r>
           </a:p>
         </p:txBody>
@@ -19957,8 +19957,8 @@
         </p:nvSpPr>
         <p:spPr>
           <a:xfrm>
-            <a:off x="7940040" y="2029968"/>
-            <a:ext cx="1212088" cy="365760"/>
+            <a:off x="7940040" y="1938528"/>
+            <a:ext cx="1212088" cy="329184"/>
           </a:xfrm>
           <a:prstGeom prst="rect">
             <a:avLst/>
@@ -19999,7 +19999,7 @@
               </a:defRPr>
             </a:pPr>
             <a:r>
-              <a:t>2 High · 2 Med</a:t>
+              <a:t>0 High · 1 Med</a:t>
             </a:r>
           </a:p>
         </p:txBody>
@@ -20012,8 +20012,8 @@
         </p:nvSpPr>
         <p:spPr>
           <a:xfrm>
-            <a:off x="9179560" y="2029968"/>
-            <a:ext cx="1212088" cy="365760"/>
+            <a:off x="9179560" y="1938528"/>
+            <a:ext cx="1212088" cy="329184"/>
           </a:xfrm>
           <a:prstGeom prst="rect">
             <a:avLst/>
@@ -20048,13 +20048,13 @@
             <a:pPr algn="ctr">
               <a:defRPr sz="700" b="0">
                 <a:solidFill>
-                  <a:srgbClr val="94A3B8"/>
-                </a:solidFill>
-                <a:latin typeface="Calibri"/>
-              </a:defRPr>
-            </a:pPr>
-            <a:r>
-              <a:t>NA</a:t>
+                  <a:srgbClr val="334155"/>
+                </a:solidFill>
+                <a:latin typeface="Calibri"/>
+              </a:defRPr>
+            </a:pPr>
+            <a:r>
+              <a:t>95.3%</a:t>
             </a:r>
           </a:p>
         </p:txBody>
@@ -20067,8 +20067,8 @@
         </p:nvSpPr>
         <p:spPr>
           <a:xfrm>
-            <a:off x="10419080" y="2029968"/>
-            <a:ext cx="1212088" cy="365760"/>
+            <a:off x="10419080" y="1938528"/>
+            <a:ext cx="1212088" cy="329184"/>
           </a:xfrm>
           <a:prstGeom prst="rect">
             <a:avLst/>
@@ -20103,13 +20103,13 @@
             <a:pPr algn="ctr">
               <a:defRPr sz="700" b="0">
                 <a:solidFill>
-                  <a:srgbClr val="D97706"/>
-                </a:solidFill>
-                <a:latin typeface="Calibri"/>
-              </a:defRPr>
-            </a:pPr>
-            <a:r>
-              <a:t>Pass w/ gaps</a:t>
+                  <a:srgbClr val="334155"/>
+                </a:solidFill>
+                <a:latin typeface="Calibri"/>
+              </a:defRPr>
+            </a:pPr>
+            <a:r>
+              <a:t>Fail</a:t>
             </a:r>
           </a:p>
         </p:txBody>
@@ -20122,8 +20122,8 @@
         </p:nvSpPr>
         <p:spPr>
           <a:xfrm>
-            <a:off x="502920" y="2432304"/>
-            <a:ext cx="1212088" cy="365760"/>
+            <a:off x="502920" y="2286000"/>
+            <a:ext cx="1212088" cy="329184"/>
           </a:xfrm>
           <a:prstGeom prst="rect">
             <a:avLst/>
@@ -20164,7 +20164,7 @@
               </a:defRPr>
             </a:pPr>
             <a:r>
-              <a:t>MSC-195138</a:t>
+              <a:t>MSC-204417</a:t>
             </a:r>
           </a:p>
         </p:txBody>
@@ -20177,8 +20177,8 @@
         </p:nvSpPr>
         <p:spPr>
           <a:xfrm>
-            <a:off x="1742440" y="2432304"/>
-            <a:ext cx="1212088" cy="365760"/>
+            <a:off x="1742440" y="2286000"/>
+            <a:ext cx="1212088" cy="329184"/>
           </a:xfrm>
           <a:prstGeom prst="rect">
             <a:avLst/>
@@ -20213,13 +20213,13 @@
             <a:pPr algn="ctr">
               <a:defRPr sz="700" b="0">
                 <a:solidFill>
-                  <a:srgbClr val="D97706"/>
-                </a:solidFill>
-                <a:latin typeface="Calibri"/>
-              </a:defRPr>
-            </a:pPr>
-            <a:r>
-              <a:t>83.3%</a:t>
+                  <a:srgbClr val="16A34A"/>
+                </a:solidFill>
+                <a:latin typeface="Calibri"/>
+              </a:defRPr>
+            </a:pPr>
+            <a:r>
+              <a:t>100.0%</a:t>
             </a:r>
           </a:p>
         </p:txBody>
@@ -20232,8 +20232,8 @@
         </p:nvSpPr>
         <p:spPr>
           <a:xfrm>
-            <a:off x="2981960" y="2432304"/>
-            <a:ext cx="1212088" cy="365760"/>
+            <a:off x="2981960" y="2286000"/>
+            <a:ext cx="1212088" cy="329184"/>
           </a:xfrm>
           <a:prstGeom prst="rect">
             <a:avLst/>
@@ -20287,8 +20287,8 @@
         </p:nvSpPr>
         <p:spPr>
           <a:xfrm>
-            <a:off x="4221480" y="2432304"/>
-            <a:ext cx="1212088" cy="365760"/>
+            <a:off x="4221480" y="2286000"/>
+            <a:ext cx="1212088" cy="329184"/>
           </a:xfrm>
           <a:prstGeom prst="rect">
             <a:avLst/>
@@ -20329,7 +20329,7 @@
               </a:defRPr>
             </a:pPr>
             <a:r>
-              <a:t>2/3 AC</a:t>
+              <a:t>16/17 AC in test plan</a:t>
             </a:r>
           </a:p>
         </p:txBody>
@@ -20342,8 +20342,8 @@
         </p:nvSpPr>
         <p:spPr>
           <a:xfrm>
-            <a:off x="5461000" y="2432304"/>
-            <a:ext cx="1212088" cy="365760"/>
+            <a:off x="5461000" y="2286000"/>
+            <a:ext cx="1212088" cy="329184"/>
           </a:xfrm>
           <a:prstGeom prst="rect">
             <a:avLst/>
@@ -20384,7 +20384,7 @@
               </a:defRPr>
             </a:pPr>
             <a:r>
-              <a:t>66.7%</a:t>
+              <a:t>94.1%</a:t>
             </a:r>
           </a:p>
         </p:txBody>
@@ -20397,8 +20397,8 @@
         </p:nvSpPr>
         <p:spPr>
           <a:xfrm>
-            <a:off x="6700520" y="2432304"/>
-            <a:ext cx="1212088" cy="365760"/>
+            <a:off x="6700520" y="2286000"/>
+            <a:ext cx="1212088" cy="329184"/>
           </a:xfrm>
           <a:prstGeom prst="rect">
             <a:avLst/>
@@ -20439,7 +20439,7 @@
               </a:defRPr>
             </a:pPr>
             <a:r>
-              <a:t>3 items</a:t>
+              <a:t>2 items</a:t>
             </a:r>
           </a:p>
         </p:txBody>
@@ -20452,8 +20452,8 @@
         </p:nvSpPr>
         <p:spPr>
           <a:xfrm>
-            <a:off x="7940040" y="2432304"/>
-            <a:ext cx="1212088" cy="365760"/>
+            <a:off x="7940040" y="2286000"/>
+            <a:ext cx="1212088" cy="329184"/>
           </a:xfrm>
           <a:prstGeom prst="rect">
             <a:avLst/>
@@ -20494,7 +20494,7 @@
               </a:defRPr>
             </a:pPr>
             <a:r>
-              <a:t>1 High · 3 Med</a:t>
+              <a:t>2 High · 2 Med</a:t>
             </a:r>
           </a:p>
         </p:txBody>
@@ -20507,8 +20507,8 @@
         </p:nvSpPr>
         <p:spPr>
           <a:xfrm>
-            <a:off x="9179560" y="2432304"/>
-            <a:ext cx="1212088" cy="365760"/>
+            <a:off x="9179560" y="2286000"/>
+            <a:ext cx="1212088" cy="329184"/>
           </a:xfrm>
           <a:prstGeom prst="rect">
             <a:avLst/>
@@ -20562,8 +20562,8 @@
         </p:nvSpPr>
         <p:spPr>
           <a:xfrm>
-            <a:off x="10419080" y="2432304"/>
-            <a:ext cx="1212088" cy="365760"/>
+            <a:off x="10419080" y="2286000"/>
+            <a:ext cx="1212088" cy="329184"/>
           </a:xfrm>
           <a:prstGeom prst="rect">
             <a:avLst/>
@@ -20598,33 +20598,33 @@
             <a:pPr algn="ctr">
               <a:defRPr sz="700" b="0">
                 <a:solidFill>
-                  <a:srgbClr val="D97706"/>
-                </a:solidFill>
-                <a:latin typeface="Calibri"/>
-              </a:defRPr>
-            </a:pPr>
-            <a:r>
-              <a:t>Pass w/ gaps</a:t>
-            </a:r>
-          </a:p>
-        </p:txBody>
-      </p:sp>
-      <p:sp>
-        <p:nvSpPr>
-          <p:cNvPr id="44" name="Rounded Rectangle 43"/>
+                  <a:srgbClr val="334155"/>
+                </a:solidFill>
+                <a:latin typeface="Calibri"/>
+              </a:defRPr>
+            </a:pPr>
+            <a:r>
+              <a:t>Fail</a:t>
+            </a:r>
+          </a:p>
+        </p:txBody>
+      </p:sp>
+      <p:sp>
+        <p:nvSpPr>
+          <p:cNvPr id="44" name="Rectangle 43"/>
           <p:cNvSpPr/>
           <p:nvPr/>
         </p:nvSpPr>
         <p:spPr>
           <a:xfrm>
-            <a:off x="502920" y="2788920"/>
-            <a:ext cx="11155680" cy="320040"/>
-          </a:xfrm>
-          <a:prstGeom prst="roundRect">
-            <a:avLst/>
-          </a:prstGeom>
-          <a:solidFill>
-            <a:srgbClr val="FF5E4F"/>
+            <a:off x="502920" y="2633472"/>
+            <a:ext cx="1212088" cy="329184"/>
+          </a:xfrm>
+          <a:prstGeom prst="rect">
+            <a:avLst/>
+          </a:prstGeom>
+          <a:solidFill>
+            <a:srgbClr val="F2F2F2"/>
           </a:solidFill>
           <a:ln w="6350">
             <a:solidFill>
@@ -20651,15 +20651,15 @@
           <a:lstStyle/>
           <a:p>
             <a:pPr algn="ctr">
-              <a:defRPr sz="1100" b="1">
-                <a:solidFill>
-                  <a:srgbClr val="FFFFFF"/>
-                </a:solidFill>
-                <a:latin typeface="Calibri"/>
-              </a:defRPr>
-            </a:pPr>
-            <a:r>
-              <a:t>Report artifacts (latest)</a:t>
+              <a:defRPr sz="700" b="1">
+                <a:solidFill>
+                  <a:srgbClr val="1A1A1A"/>
+                </a:solidFill>
+                <a:latin typeface="Calibri"/>
+              </a:defRPr>
+            </a:pPr>
+            <a:r>
+              <a:t>MSC-195138</a:t>
             </a:r>
           </a:p>
         </p:txBody>
@@ -20672,8 +20672,8 @@
         </p:nvSpPr>
         <p:spPr>
           <a:xfrm>
-            <a:off x="502920" y="3182112"/>
-            <a:ext cx="11155680" cy="310896"/>
+            <a:off x="1742440" y="2633472"/>
+            <a:ext cx="1212088" cy="329184"/>
           </a:xfrm>
           <a:prstGeom prst="rect">
             <a:avLst/>
@@ -20706,15 +20706,15 @@
           <a:lstStyle/>
           <a:p>
             <a:pPr algn="ctr">
-              <a:defRPr sz="800" b="0">
-                <a:solidFill>
-                  <a:srgbClr val="334155"/>
-                </a:solidFill>
-                <a:latin typeface="Calibri"/>
-              </a:defRPr>
-            </a:pPr>
-            <a:r>
-              <a:t>MSC-205625 · MSC-205625-05-29-2026-12-43-49-IST.html · 05-29-2026 12:43 IST · PR #161 pick-genie · MERGED · CI Passed · Domino · Inc as Fulll · 5/5 GWT · 3/4 AC</a:t>
+              <a:defRPr sz="700" b="0">
+                <a:solidFill>
+                  <a:srgbClr val="D97706"/>
+                </a:solidFill>
+                <a:latin typeface="Calibri"/>
+              </a:defRPr>
+            </a:pPr>
+            <a:r>
+              <a:t>83.3%</a:t>
             </a:r>
           </a:p>
         </p:txBody>
@@ -20727,14 +20727,14 @@
         </p:nvSpPr>
         <p:spPr>
           <a:xfrm>
-            <a:off x="502920" y="3529584"/>
-            <a:ext cx="11155680" cy="310896"/>
-          </a:xfrm>
-          <a:prstGeom prst="rect">
-            <a:avLst/>
-          </a:prstGeom>
-          <a:solidFill>
-            <a:srgbClr val="E8F0FE"/>
+            <a:off x="2981960" y="2633472"/>
+            <a:ext cx="1212088" cy="329184"/>
+          </a:xfrm>
+          <a:prstGeom prst="rect">
+            <a:avLst/>
+          </a:prstGeom>
+          <a:solidFill>
+            <a:srgbClr val="F2F2F2"/>
           </a:solidFill>
           <a:ln w="6350">
             <a:solidFill>
@@ -20761,15 +20761,15 @@
           <a:lstStyle/>
           <a:p>
             <a:pPr algn="ctr">
-              <a:defRPr sz="800" b="0">
-                <a:solidFill>
-                  <a:srgbClr val="04066C"/>
-                </a:solidFill>
-                <a:latin typeface="Calibri"/>
-              </a:defRPr>
-            </a:pPr>
-            <a:r>
-              <a:t>MSC-204417 · MSC-204417-05-31-2026-10-19-28-IST.html · 05-31-2026 10:19 IST · No PR · develop branch · Caption Monitoring · 12/12 GWT · Confluence LADR requirements</a:t>
+              <a:defRPr sz="700" b="0">
+                <a:solidFill>
+                  <a:srgbClr val="D97706"/>
+                </a:solidFill>
+                <a:latin typeface="Calibri"/>
+              </a:defRPr>
+            </a:pPr>
+            <a:r>
+              <a:t>83.3%</a:t>
             </a:r>
           </a:p>
         </p:txBody>
@@ -20782,8 +20782,8 @@
         </p:nvSpPr>
         <p:spPr>
           <a:xfrm>
-            <a:off x="502920" y="3877056"/>
-            <a:ext cx="11155680" cy="310896"/>
+            <a:off x="4221480" y="2633472"/>
+            <a:ext cx="1212088" cy="329184"/>
           </a:xfrm>
           <a:prstGeom prst="rect">
             <a:avLst/>
@@ -20816,7 +20816,7 @@
           <a:lstStyle/>
           <a:p>
             <a:pPr algn="ctr">
-              <a:defRPr sz="800" b="0">
+              <a:defRPr sz="700" b="0">
                 <a:solidFill>
                   <a:srgbClr val="334155"/>
                 </a:solidFill>
@@ -20824,7 +20824,7 @@
               </a:defRPr>
             </a:pPr>
             <a:r>
-              <a:t>MSC-195138 · MSC-195138-05-27-2026-17-57-12-IST.html · 05-27-2026 17:57 IST · PRs #22 + #75 · MERGED · FF Race · 11/11 GWT</a:t>
+              <a:t>2/3 AC in test plan</a:t>
             </a:r>
           </a:p>
         </p:txBody>
@@ -20837,14 +20837,14 @@
         </p:nvSpPr>
         <p:spPr>
           <a:xfrm>
-            <a:off x="502920" y="4343400"/>
-            <a:ext cx="5394960" cy="320040"/>
-          </a:xfrm>
-          <a:prstGeom prst="rect">
-            <a:avLst/>
-          </a:prstGeom>
-          <a:solidFill>
-            <a:srgbClr val="04066C"/>
+            <a:off x="5461000" y="2633472"/>
+            <a:ext cx="1212088" cy="329184"/>
+          </a:xfrm>
+          <a:prstGeom prst="rect">
+            <a:avLst/>
+          </a:prstGeom>
+          <a:solidFill>
+            <a:srgbClr val="F2F2F2"/>
           </a:solidFill>
           <a:ln w="6350">
             <a:solidFill>
@@ -20871,35 +20871,35 @@
           <a:lstStyle/>
           <a:p>
             <a:pPr algn="ctr">
-              <a:defRPr sz="1000" b="1">
-                <a:solidFill>
-                  <a:srgbClr val="FFFFFF"/>
-                </a:solidFill>
-                <a:latin typeface="Calibri"/>
-              </a:defRPr>
-            </a:pPr>
-            <a:r>
-              <a:t>MSC-204417 — sample §1 cards</a:t>
-            </a:r>
-          </a:p>
-        </p:txBody>
-      </p:sp>
-      <p:sp>
-        <p:nvSpPr>
-          <p:cNvPr id="49" name="Rounded Rectangle 48"/>
+              <a:defRPr sz="700" b="0">
+                <a:solidFill>
+                  <a:srgbClr val="D97706"/>
+                </a:solidFill>
+                <a:latin typeface="Calibri"/>
+              </a:defRPr>
+            </a:pPr>
+            <a:r>
+              <a:t>66.7%</a:t>
+            </a:r>
+          </a:p>
+        </p:txBody>
+      </p:sp>
+      <p:sp>
+        <p:nvSpPr>
+          <p:cNvPr id="49" name="Rectangle 48"/>
           <p:cNvSpPr/>
           <p:nvPr/>
         </p:nvSpPr>
         <p:spPr>
           <a:xfrm>
-            <a:off x="502920" y="4709160"/>
-            <a:ext cx="1261872" cy="777240"/>
-          </a:xfrm>
-          <a:prstGeom prst="roundRect">
-            <a:avLst/>
-          </a:prstGeom>
-          <a:solidFill>
-            <a:srgbClr val="E8F0FE"/>
+            <a:off x="6700520" y="2633472"/>
+            <a:ext cx="1212088" cy="329184"/>
+          </a:xfrm>
+          <a:prstGeom prst="rect">
+            <a:avLst/>
+          </a:prstGeom>
+          <a:solidFill>
+            <a:srgbClr val="F2F2F2"/>
           </a:solidFill>
           <a:ln w="6350">
             <a:solidFill>
@@ -20922,101 +20922,39 @@
           </a:fontRef>
         </p:style>
         <p:txBody>
-          <a:bodyPr rtlCol="0" anchor="ctr"/>
-          <a:lstStyle/>
-          <a:p>
-            <a:pPr algn="ctr"/>
-          </a:p>
-        </p:txBody>
-      </p:sp>
-      <p:sp>
-        <p:nvSpPr>
-          <p:cNvPr id="50" name="TextBox 49"/>
-          <p:cNvSpPr txBox="1"/>
-          <p:nvPr/>
-        </p:nvSpPr>
-        <p:spPr>
-          <a:xfrm>
-            <a:off x="594360" y="4846320"/>
-            <a:ext cx="1078992" cy="502920"/>
-          </a:xfrm>
-          <a:prstGeom prst="rect">
-            <a:avLst/>
-          </a:prstGeom>
-          <a:noFill/>
-        </p:spPr>
-        <p:txBody>
-          <a:bodyPr wrap="none">
-            <a:spAutoFit/>
-          </a:bodyPr>
+          <a:bodyPr rtlCol="0" anchor="ctr" wrap="square"/>
           <a:lstStyle/>
           <a:p>
             <a:pPr algn="ctr">
-              <a:defRPr sz="2800" b="1">
-                <a:solidFill>
-                  <a:srgbClr val="04066C"/>
-                </a:solidFill>
-                <a:latin typeface="Calibri"/>
-              </a:defRPr>
-            </a:pPr>
-            <a:r>
-              <a:t>100%</a:t>
-            </a:r>
-          </a:p>
-        </p:txBody>
-      </p:sp>
-      <p:sp>
-        <p:nvSpPr>
-          <p:cNvPr id="51" name="TextBox 50"/>
-          <p:cNvSpPr txBox="1"/>
-          <p:nvPr/>
-        </p:nvSpPr>
-        <p:spPr>
-          <a:xfrm>
-            <a:off x="576072" y="5367528"/>
-            <a:ext cx="1115568" cy="411480"/>
-          </a:xfrm>
-          <a:prstGeom prst="rect">
-            <a:avLst/>
-          </a:prstGeom>
-          <a:noFill/>
-        </p:spPr>
-        <p:txBody>
-          <a:bodyPr wrap="none">
-            <a:spAutoFit/>
-          </a:bodyPr>
-          <a:lstStyle/>
-          <a:p>
-            <a:pPr algn="ctr">
-              <a:defRPr sz="1100" b="1">
-                <a:solidFill>
-                  <a:srgbClr val="04066C"/>
-                </a:solidFill>
-                <a:latin typeface="Calibri"/>
-              </a:defRPr>
-            </a:pPr>
-            <a:r>
-              <a:t>Dev code</a:t>
-            </a:r>
-          </a:p>
-        </p:txBody>
-      </p:sp>
-      <p:sp>
-        <p:nvSpPr>
-          <p:cNvPr id="52" name="Rounded Rectangle 51"/>
+              <a:defRPr sz="700" b="0">
+                <a:solidFill>
+                  <a:srgbClr val="334155"/>
+                </a:solidFill>
+                <a:latin typeface="Calibri"/>
+              </a:defRPr>
+            </a:pPr>
+            <a:r>
+              <a:t>3 items</a:t>
+            </a:r>
+          </a:p>
+        </p:txBody>
+      </p:sp>
+      <p:sp>
+        <p:nvSpPr>
+          <p:cNvPr id="50" name="Rectangle 49"/>
           <p:cNvSpPr/>
           <p:nvPr/>
         </p:nvSpPr>
         <p:spPr>
           <a:xfrm>
-            <a:off x="1856232" y="4709160"/>
-            <a:ext cx="1261872" cy="777240"/>
-          </a:xfrm>
-          <a:prstGeom prst="roundRect">
-            <a:avLst/>
-          </a:prstGeom>
-          <a:solidFill>
-            <a:srgbClr val="E8F0FE"/>
+            <a:off x="7940040" y="2633472"/>
+            <a:ext cx="1212088" cy="329184"/>
+          </a:xfrm>
+          <a:prstGeom prst="rect">
+            <a:avLst/>
+          </a:prstGeom>
+          <a:solidFill>
+            <a:srgbClr val="F2F2F2"/>
           </a:solidFill>
           <a:ln w="6350">
             <a:solidFill>
@@ -21039,101 +20977,39 @@
           </a:fontRef>
         </p:style>
         <p:txBody>
-          <a:bodyPr rtlCol="0" anchor="ctr"/>
-          <a:lstStyle/>
-          <a:p>
-            <a:pPr algn="ctr"/>
-          </a:p>
-        </p:txBody>
-      </p:sp>
-      <p:sp>
-        <p:nvSpPr>
-          <p:cNvPr id="53" name="TextBox 52"/>
-          <p:cNvSpPr txBox="1"/>
-          <p:nvPr/>
-        </p:nvSpPr>
-        <p:spPr>
-          <a:xfrm>
-            <a:off x="1947672" y="4846320"/>
-            <a:ext cx="1078992" cy="502920"/>
-          </a:xfrm>
-          <a:prstGeom prst="rect">
-            <a:avLst/>
-          </a:prstGeom>
-          <a:noFill/>
-        </p:spPr>
-        <p:txBody>
-          <a:bodyPr wrap="none">
-            <a:spAutoFit/>
-          </a:bodyPr>
+          <a:bodyPr rtlCol="0" anchor="ctr" wrap="square"/>
           <a:lstStyle/>
           <a:p>
             <a:pPr algn="ctr">
-              <a:defRPr sz="2800" b="1">
-                <a:solidFill>
-                  <a:srgbClr val="04066C"/>
-                </a:solidFill>
-                <a:latin typeface="Calibri"/>
-              </a:defRPr>
-            </a:pPr>
-            <a:r>
-              <a:t>83.3%</a:t>
-            </a:r>
-          </a:p>
-        </p:txBody>
-      </p:sp>
-      <p:sp>
-        <p:nvSpPr>
-          <p:cNvPr id="54" name="TextBox 53"/>
-          <p:cNvSpPr txBox="1"/>
-          <p:nvPr/>
-        </p:nvSpPr>
-        <p:spPr>
-          <a:xfrm>
-            <a:off x="1929384" y="5367528"/>
-            <a:ext cx="1115568" cy="411480"/>
-          </a:xfrm>
-          <a:prstGeom prst="rect">
-            <a:avLst/>
-          </a:prstGeom>
-          <a:noFill/>
-        </p:spPr>
-        <p:txBody>
-          <a:bodyPr wrap="none">
-            <a:spAutoFit/>
-          </a:bodyPr>
-          <a:lstStyle/>
-          <a:p>
-            <a:pPr algn="ctr">
-              <a:defRPr sz="1100" b="1">
-                <a:solidFill>
-                  <a:srgbClr val="04066C"/>
-                </a:solidFill>
-                <a:latin typeface="Calibri"/>
-              </a:defRPr>
-            </a:pPr>
-            <a:r>
-              <a:t>Dev tests</a:t>
-            </a:r>
-          </a:p>
-        </p:txBody>
-      </p:sp>
-      <p:sp>
-        <p:nvSpPr>
-          <p:cNvPr id="55" name="Rounded Rectangle 54"/>
+              <a:defRPr sz="700" b="0">
+                <a:solidFill>
+                  <a:srgbClr val="334155"/>
+                </a:solidFill>
+                <a:latin typeface="Calibri"/>
+              </a:defRPr>
+            </a:pPr>
+            <a:r>
+              <a:t>1 High · 3 Med</a:t>
+            </a:r>
+          </a:p>
+        </p:txBody>
+      </p:sp>
+      <p:sp>
+        <p:nvSpPr>
+          <p:cNvPr id="51" name="Rectangle 50"/>
           <p:cNvSpPr/>
           <p:nvPr/>
         </p:nvSpPr>
         <p:spPr>
           <a:xfrm>
-            <a:off x="3209544" y="4709160"/>
-            <a:ext cx="1261872" cy="777240"/>
-          </a:xfrm>
-          <a:prstGeom prst="roundRect">
-            <a:avLst/>
-          </a:prstGeom>
-          <a:solidFill>
-            <a:srgbClr val="E8F0FE"/>
+            <a:off x="9179560" y="2633472"/>
+            <a:ext cx="1212088" cy="329184"/>
+          </a:xfrm>
+          <a:prstGeom prst="rect">
+            <a:avLst/>
+          </a:prstGeom>
+          <a:solidFill>
+            <a:srgbClr val="F2F2F2"/>
           </a:solidFill>
           <a:ln w="6350">
             <a:solidFill>
@@ -21156,101 +21032,39 @@
           </a:fontRef>
         </p:style>
         <p:txBody>
-          <a:bodyPr rtlCol="0" anchor="ctr"/>
-          <a:lstStyle/>
-          <a:p>
-            <a:pPr algn="ctr"/>
-          </a:p>
-        </p:txBody>
-      </p:sp>
-      <p:sp>
-        <p:nvSpPr>
-          <p:cNvPr id="56" name="TextBox 55"/>
-          <p:cNvSpPr txBox="1"/>
-          <p:nvPr/>
-        </p:nvSpPr>
-        <p:spPr>
-          <a:xfrm>
-            <a:off x="3300984" y="4846320"/>
-            <a:ext cx="1078992" cy="502920"/>
-          </a:xfrm>
-          <a:prstGeom prst="rect">
-            <a:avLst/>
-          </a:prstGeom>
-          <a:noFill/>
-        </p:spPr>
-        <p:txBody>
-          <a:bodyPr wrap="none">
-            <a:spAutoFit/>
-          </a:bodyPr>
+          <a:bodyPr rtlCol="0" anchor="ctr" wrap="square"/>
           <a:lstStyle/>
           <a:p>
             <a:pPr algn="ctr">
-              <a:defRPr sz="2800" b="1">
-                <a:solidFill>
-                  <a:srgbClr val="04066C"/>
-                </a:solidFill>
-                <a:latin typeface="Calibri"/>
-              </a:defRPr>
-            </a:pPr>
-            <a:r>
-              <a:t>94.1%</a:t>
-            </a:r>
-          </a:p>
-        </p:txBody>
-      </p:sp>
-      <p:sp>
-        <p:nvSpPr>
-          <p:cNvPr id="57" name="TextBox 56"/>
-          <p:cNvSpPr txBox="1"/>
-          <p:nvPr/>
-        </p:nvSpPr>
-        <p:spPr>
-          <a:xfrm>
-            <a:off x="3282696" y="5367528"/>
-            <a:ext cx="1115568" cy="411480"/>
-          </a:xfrm>
-          <a:prstGeom prst="rect">
-            <a:avLst/>
-          </a:prstGeom>
-          <a:noFill/>
-        </p:spPr>
-        <p:txBody>
-          <a:bodyPr wrap="none">
-            <a:spAutoFit/>
-          </a:bodyPr>
-          <a:lstStyle/>
-          <a:p>
-            <a:pPr algn="ctr">
-              <a:defRPr sz="1100" b="1">
-                <a:solidFill>
-                  <a:srgbClr val="04066C"/>
-                </a:solidFill>
-                <a:latin typeface="Calibri"/>
-              </a:defRPr>
-            </a:pPr>
-            <a:r>
-              <a:t>Test plan AC</a:t>
-            </a:r>
-          </a:p>
-        </p:txBody>
-      </p:sp>
-      <p:sp>
-        <p:nvSpPr>
-          <p:cNvPr id="58" name="Rounded Rectangle 57"/>
+              <a:defRPr sz="700" b="0">
+                <a:solidFill>
+                  <a:srgbClr val="334155"/>
+                </a:solidFill>
+                <a:latin typeface="Calibri"/>
+              </a:defRPr>
+            </a:pPr>
+            <a:r>
+              <a:t>77.7%</a:t>
+            </a:r>
+          </a:p>
+        </p:txBody>
+      </p:sp>
+      <p:sp>
+        <p:nvSpPr>
+          <p:cNvPr id="52" name="Rectangle 51"/>
           <p:cNvSpPr/>
           <p:nvPr/>
         </p:nvSpPr>
         <p:spPr>
           <a:xfrm>
-            <a:off x="4562856" y="4709160"/>
-            <a:ext cx="1261872" cy="777240"/>
-          </a:xfrm>
-          <a:prstGeom prst="roundRect">
-            <a:avLst/>
-          </a:prstGeom>
-          <a:solidFill>
-            <a:srgbClr val="FFF8E1"/>
+            <a:off x="10419080" y="2633472"/>
+            <a:ext cx="1212088" cy="329184"/>
+          </a:xfrm>
+          <a:prstGeom prst="rect">
+            <a:avLst/>
+          </a:prstGeom>
+          <a:solidFill>
+            <a:srgbClr val="F2F2F2"/>
           </a:solidFill>
           <a:ln w="6350">
             <a:solidFill>
@@ -21273,101 +21087,39 @@
           </a:fontRef>
         </p:style>
         <p:txBody>
-          <a:bodyPr rtlCol="0" anchor="ctr"/>
-          <a:lstStyle/>
-          <a:p>
-            <a:pPr algn="ctr"/>
-          </a:p>
-        </p:txBody>
-      </p:sp>
-      <p:sp>
-        <p:nvSpPr>
-          <p:cNvPr id="59" name="TextBox 58"/>
-          <p:cNvSpPr txBox="1"/>
-          <p:nvPr/>
-        </p:nvSpPr>
-        <p:spPr>
-          <a:xfrm>
-            <a:off x="4654296" y="4846320"/>
-            <a:ext cx="1078992" cy="502920"/>
-          </a:xfrm>
-          <a:prstGeom prst="rect">
-            <a:avLst/>
-          </a:prstGeom>
-          <a:noFill/>
-        </p:spPr>
-        <p:txBody>
-          <a:bodyPr wrap="none">
-            <a:spAutoFit/>
-          </a:bodyPr>
+          <a:bodyPr rtlCol="0" anchor="ctr" wrap="square"/>
           <a:lstStyle/>
           <a:p>
             <a:pPr algn="ctr">
-              <a:defRPr sz="2800" b="1">
-                <a:solidFill>
-                  <a:srgbClr val="04066C"/>
-                </a:solidFill>
-                <a:latin typeface="Calibri"/>
-              </a:defRPr>
-            </a:pPr>
-            <a:r>
-              <a:t>NA</a:t>
-            </a:r>
-          </a:p>
-        </p:txBody>
-      </p:sp>
-      <p:sp>
-        <p:nvSpPr>
-          <p:cNvPr id="60" name="TextBox 59"/>
-          <p:cNvSpPr txBox="1"/>
-          <p:nvPr/>
-        </p:nvSpPr>
-        <p:spPr>
-          <a:xfrm>
-            <a:off x="4636008" y="5367528"/>
-            <a:ext cx="1115568" cy="411480"/>
-          </a:xfrm>
-          <a:prstGeom prst="rect">
-            <a:avLst/>
-          </a:prstGeom>
-          <a:noFill/>
-        </p:spPr>
-        <p:txBody>
-          <a:bodyPr wrap="none">
-            <a:spAutoFit/>
-          </a:bodyPr>
-          <a:lstStyle/>
-          <a:p>
-            <a:pPr algn="ctr">
-              <a:defRPr sz="1100" b="1">
-                <a:solidFill>
-                  <a:srgbClr val="04066C"/>
-                </a:solidFill>
-                <a:latin typeface="Calibri"/>
-              </a:defRPr>
-            </a:pPr>
-            <a:r>
-              <a:t>CI line</a:t>
-            </a:r>
-          </a:p>
-        </p:txBody>
-      </p:sp>
-      <p:sp>
-        <p:nvSpPr>
-          <p:cNvPr id="61" name="Rectangle 60"/>
+              <a:defRPr sz="700" b="0">
+                <a:solidFill>
+                  <a:srgbClr val="334155"/>
+                </a:solidFill>
+                <a:latin typeface="Calibri"/>
+              </a:defRPr>
+            </a:pPr>
+            <a:r>
+              <a:t>Fail</a:t>
+            </a:r>
+          </a:p>
+        </p:txBody>
+      </p:sp>
+      <p:sp>
+        <p:nvSpPr>
+          <p:cNvPr id="53" name="Rounded Rectangle 52"/>
           <p:cNvSpPr/>
           <p:nvPr/>
         </p:nvSpPr>
         <p:spPr>
           <a:xfrm>
-            <a:off x="6080760" y="4343400"/>
-            <a:ext cx="5577840" cy="320040"/>
-          </a:xfrm>
-          <a:prstGeom prst="rect">
-            <a:avLst/>
-          </a:prstGeom>
-          <a:solidFill>
-            <a:srgbClr val="04066C"/>
+            <a:off x="502920" y="2697480"/>
+            <a:ext cx="11155680" cy="292608"/>
+          </a:xfrm>
+          <a:prstGeom prst="roundRect">
+            <a:avLst/>
+          </a:prstGeom>
+          <a:solidFill>
+            <a:srgbClr val="FF5E4F"/>
           </a:solidFill>
           <a:ln w="6350">
             <a:solidFill>
@@ -21402,27 +21154,27 @@
               </a:defRPr>
             </a:pPr>
             <a:r>
-              <a:t>MSC-205625 — sample §1 cards (PR + CI)</a:t>
-            </a:r>
-          </a:p>
-        </p:txBody>
-      </p:sp>
-      <p:sp>
-        <p:nvSpPr>
-          <p:cNvPr id="62" name="Rounded Rectangle 61"/>
+              <a:t>Report artifacts (latest)</a:t>
+            </a:r>
+          </a:p>
+        </p:txBody>
+      </p:sp>
+      <p:sp>
+        <p:nvSpPr>
+          <p:cNvPr id="54" name="Rectangle 53"/>
           <p:cNvSpPr/>
           <p:nvPr/>
         </p:nvSpPr>
         <p:spPr>
           <a:xfrm>
-            <a:off x="6080760" y="4709160"/>
-            <a:ext cx="1261872" cy="777240"/>
-          </a:xfrm>
-          <a:prstGeom prst="roundRect">
-            <a:avLst/>
-          </a:prstGeom>
-          <a:solidFill>
-            <a:srgbClr val="DCFCE7"/>
+            <a:off x="502920" y="3035808"/>
+            <a:ext cx="11155680" cy="274320"/>
+          </a:xfrm>
+          <a:prstGeom prst="rect">
+            <a:avLst/>
+          </a:prstGeom>
+          <a:solidFill>
+            <a:srgbClr val="FFF8E1"/>
           </a:solidFill>
           <a:ln w="6350">
             <a:solidFill>
@@ -21445,101 +21197,39 @@
           </a:fontRef>
         </p:style>
         <p:txBody>
-          <a:bodyPr rtlCol="0" anchor="ctr"/>
-          <a:lstStyle/>
-          <a:p>
-            <a:pPr algn="ctr"/>
-          </a:p>
-        </p:txBody>
-      </p:sp>
-      <p:sp>
-        <p:nvSpPr>
-          <p:cNvPr id="63" name="TextBox 62"/>
-          <p:cNvSpPr txBox="1"/>
-          <p:nvPr/>
-        </p:nvSpPr>
-        <p:spPr>
-          <a:xfrm>
-            <a:off x="6172200" y="4846320"/>
-            <a:ext cx="1078992" cy="502920"/>
-          </a:xfrm>
-          <a:prstGeom prst="rect">
-            <a:avLst/>
-          </a:prstGeom>
-          <a:noFill/>
-        </p:spPr>
-        <p:txBody>
-          <a:bodyPr wrap="none">
-            <a:spAutoFit/>
-          </a:bodyPr>
+          <a:bodyPr rtlCol="0" anchor="ctr" wrap="square"/>
           <a:lstStyle/>
           <a:p>
             <a:pPr algn="ctr">
-              <a:defRPr sz="2800" b="1">
-                <a:solidFill>
-                  <a:srgbClr val="16A34A"/>
-                </a:solidFill>
-                <a:latin typeface="Calibri"/>
-              </a:defRPr>
-            </a:pPr>
-            <a:r>
-              <a:t>100%</a:t>
-            </a:r>
-          </a:p>
-        </p:txBody>
-      </p:sp>
-      <p:sp>
-        <p:nvSpPr>
-          <p:cNvPr id="64" name="TextBox 63"/>
-          <p:cNvSpPr txBox="1"/>
-          <p:nvPr/>
-        </p:nvSpPr>
-        <p:spPr>
-          <a:xfrm>
-            <a:off x="6153912" y="5367528"/>
-            <a:ext cx="1115568" cy="411480"/>
-          </a:xfrm>
-          <a:prstGeom prst="rect">
-            <a:avLst/>
-          </a:prstGeom>
-          <a:noFill/>
-        </p:spPr>
-        <p:txBody>
-          <a:bodyPr wrap="none">
-            <a:spAutoFit/>
-          </a:bodyPr>
-          <a:lstStyle/>
-          <a:p>
-            <a:pPr algn="ctr">
-              <a:defRPr sz="1100" b="1">
-                <a:solidFill>
-                  <a:srgbClr val="16A34A"/>
-                </a:solidFill>
-                <a:latin typeface="Calibri"/>
-              </a:defRPr>
-            </a:pPr>
-            <a:r>
-              <a:t>Dev code</a:t>
-            </a:r>
-          </a:p>
-        </p:txBody>
-      </p:sp>
-      <p:sp>
-        <p:nvSpPr>
-          <p:cNvPr id="65" name="Rounded Rectangle 64"/>
+              <a:defRPr sz="700" b="0">
+                <a:solidFill>
+                  <a:srgbClr val="04066C"/>
+                </a:solidFill>
+                <a:latin typeface="Calibri"/>
+              </a:defRPr>
+            </a:pPr>
+            <a:r>
+              <a:t>MSC-212571 · MSC-212571-06-02-2026-14-53-07-IST.html · 06-02-2026 14:53 IST · PR #99 partner-config OPEN · #148 transmogrifier MERGED · DirecTV Scenarios · 28/28 GWT · Confluence DirecTV spec</a:t>
+            </a:r>
+          </a:p>
+        </p:txBody>
+      </p:sp>
+      <p:sp>
+        <p:nvSpPr>
+          <p:cNvPr id="55" name="Rectangle 54"/>
           <p:cNvSpPr/>
           <p:nvPr/>
         </p:nvSpPr>
         <p:spPr>
           <a:xfrm>
-            <a:off x="7434072" y="4709160"/>
-            <a:ext cx="1261872" cy="777240"/>
-          </a:xfrm>
-          <a:prstGeom prst="roundRect">
-            <a:avLst/>
-          </a:prstGeom>
-          <a:solidFill>
-            <a:srgbClr val="DCFCE7"/>
+            <a:off x="502920" y="3328416"/>
+            <a:ext cx="11155680" cy="274320"/>
+          </a:xfrm>
+          <a:prstGeom prst="rect">
+            <a:avLst/>
+          </a:prstGeom>
+          <a:solidFill>
+            <a:srgbClr val="F2F2F2"/>
           </a:solidFill>
           <a:ln w="6350">
             <a:solidFill>
@@ -21562,101 +21252,39 @@
           </a:fontRef>
         </p:style>
         <p:txBody>
-          <a:bodyPr rtlCol="0" anchor="ctr"/>
-          <a:lstStyle/>
-          <a:p>
-            <a:pPr algn="ctr"/>
-          </a:p>
-        </p:txBody>
-      </p:sp>
-      <p:sp>
-        <p:nvSpPr>
-          <p:cNvPr id="66" name="TextBox 65"/>
-          <p:cNvSpPr txBox="1"/>
-          <p:nvPr/>
-        </p:nvSpPr>
-        <p:spPr>
-          <a:xfrm>
-            <a:off x="7525512" y="4846320"/>
-            <a:ext cx="1078992" cy="502920"/>
-          </a:xfrm>
-          <a:prstGeom prst="rect">
-            <a:avLst/>
-          </a:prstGeom>
-          <a:noFill/>
-        </p:spPr>
-        <p:txBody>
-          <a:bodyPr wrap="none">
-            <a:spAutoFit/>
-          </a:bodyPr>
+          <a:bodyPr rtlCol="0" anchor="ctr" wrap="square"/>
           <a:lstStyle/>
           <a:p>
             <a:pPr algn="ctr">
-              <a:defRPr sz="2800" b="1">
-                <a:solidFill>
-                  <a:srgbClr val="16A34A"/>
-                </a:solidFill>
-                <a:latin typeface="Calibri"/>
-              </a:defRPr>
-            </a:pPr>
-            <a:r>
-              <a:t>75%</a:t>
-            </a:r>
-          </a:p>
-        </p:txBody>
-      </p:sp>
-      <p:sp>
-        <p:nvSpPr>
-          <p:cNvPr id="67" name="TextBox 66"/>
-          <p:cNvSpPr txBox="1"/>
-          <p:nvPr/>
-        </p:nvSpPr>
-        <p:spPr>
-          <a:xfrm>
-            <a:off x="7507224" y="5367528"/>
-            <a:ext cx="1115568" cy="411480"/>
-          </a:xfrm>
-          <a:prstGeom prst="rect">
-            <a:avLst/>
-          </a:prstGeom>
-          <a:noFill/>
-        </p:spPr>
-        <p:txBody>
-          <a:bodyPr wrap="none">
-            <a:spAutoFit/>
-          </a:bodyPr>
-          <a:lstStyle/>
-          <a:p>
-            <a:pPr algn="ctr">
-              <a:defRPr sz="1100" b="1">
-                <a:solidFill>
-                  <a:srgbClr val="16A34A"/>
-                </a:solidFill>
-                <a:latin typeface="Calibri"/>
-              </a:defRPr>
-            </a:pPr>
-            <a:r>
-              <a:t>Dev tests</a:t>
-            </a:r>
-          </a:p>
-        </p:txBody>
-      </p:sp>
-      <p:sp>
-        <p:nvSpPr>
-          <p:cNvPr id="68" name="Rounded Rectangle 67"/>
+              <a:defRPr sz="700" b="0">
+                <a:solidFill>
+                  <a:srgbClr val="334155"/>
+                </a:solidFill>
+                <a:latin typeface="Calibri"/>
+              </a:defRPr>
+            </a:pPr>
+            <a:r>
+              <a:t>MSC-205625 · MSC-205625-06-02-2026-14-50-05-IST.html · 06-02-2026 14:50 IST · PR #161 pick-genie · #195 encode-monitor MERGED · Domino Inc as full · 5/5 GWT · Passport wiki LADR (5 scenarios)</a:t>
+            </a:r>
+          </a:p>
+        </p:txBody>
+      </p:sp>
+      <p:sp>
+        <p:nvSpPr>
+          <p:cNvPr id="56" name="Rectangle 55"/>
           <p:cNvSpPr/>
           <p:nvPr/>
         </p:nvSpPr>
         <p:spPr>
           <a:xfrm>
-            <a:off x="8787384" y="4709160"/>
-            <a:ext cx="1261872" cy="777240"/>
-          </a:xfrm>
-          <a:prstGeom prst="roundRect">
-            <a:avLst/>
-          </a:prstGeom>
-          <a:solidFill>
-            <a:srgbClr val="DCFCE7"/>
+            <a:off x="502920" y="3621024"/>
+            <a:ext cx="11155680" cy="274320"/>
+          </a:xfrm>
+          <a:prstGeom prst="rect">
+            <a:avLst/>
+          </a:prstGeom>
+          <a:solidFill>
+            <a:srgbClr val="F2F2F2"/>
           </a:solidFill>
           <a:ln w="6350">
             <a:solidFill>
@@ -21679,101 +21307,39 @@
           </a:fontRef>
         </p:style>
         <p:txBody>
-          <a:bodyPr rtlCol="0" anchor="ctr"/>
-          <a:lstStyle/>
-          <a:p>
-            <a:pPr algn="ctr"/>
-          </a:p>
-        </p:txBody>
-      </p:sp>
-      <p:sp>
-        <p:nvSpPr>
-          <p:cNvPr id="69" name="TextBox 68"/>
-          <p:cNvSpPr txBox="1"/>
-          <p:nvPr/>
-        </p:nvSpPr>
-        <p:spPr>
-          <a:xfrm>
-            <a:off x="8878824" y="4846320"/>
-            <a:ext cx="1078992" cy="502920"/>
-          </a:xfrm>
-          <a:prstGeom prst="rect">
-            <a:avLst/>
-          </a:prstGeom>
-          <a:noFill/>
-        </p:spPr>
-        <p:txBody>
-          <a:bodyPr wrap="none">
-            <a:spAutoFit/>
-          </a:bodyPr>
+          <a:bodyPr rtlCol="0" anchor="ctr" wrap="square"/>
           <a:lstStyle/>
           <a:p>
             <a:pPr algn="ctr">
-              <a:defRPr sz="2800" b="1">
-                <a:solidFill>
-                  <a:srgbClr val="16A34A"/>
-                </a:solidFill>
-                <a:latin typeface="Calibri"/>
-              </a:defRPr>
-            </a:pPr>
-            <a:r>
-              <a:t>75%</a:t>
-            </a:r>
-          </a:p>
-        </p:txBody>
-      </p:sp>
-      <p:sp>
-        <p:nvSpPr>
-          <p:cNvPr id="70" name="TextBox 69"/>
-          <p:cNvSpPr txBox="1"/>
-          <p:nvPr/>
-        </p:nvSpPr>
-        <p:spPr>
-          <a:xfrm>
-            <a:off x="8860536" y="5367528"/>
-            <a:ext cx="1115568" cy="411480"/>
-          </a:xfrm>
-          <a:prstGeom prst="rect">
-            <a:avLst/>
-          </a:prstGeom>
-          <a:noFill/>
-        </p:spPr>
-        <p:txBody>
-          <a:bodyPr wrap="none">
-            <a:spAutoFit/>
-          </a:bodyPr>
-          <a:lstStyle/>
-          <a:p>
-            <a:pPr algn="ctr">
-              <a:defRPr sz="1100" b="1">
-                <a:solidFill>
-                  <a:srgbClr val="16A34A"/>
-                </a:solidFill>
-                <a:latin typeface="Calibri"/>
-              </a:defRPr>
-            </a:pPr>
-            <a:r>
-              <a:t>Test plan AC</a:t>
-            </a:r>
-          </a:p>
-        </p:txBody>
-      </p:sp>
-      <p:sp>
-        <p:nvSpPr>
-          <p:cNvPr id="71" name="Rounded Rectangle 70"/>
+              <a:defRPr sz="700" b="0">
+                <a:solidFill>
+                  <a:srgbClr val="334155"/>
+                </a:solidFill>
+                <a:latin typeface="Calibri"/>
+              </a:defRPr>
+            </a:pPr>
+            <a:r>
+              <a:t>MSC-204417 · MSC-204417-06-02-2026-14-43-39-IST.html · 06-02-2026 14:43 IST · No PR · develop branch (pegasus-ess) · Caption Monitoring · 12/12 GWT · ESS + caption LADR</a:t>
+            </a:r>
+          </a:p>
+        </p:txBody>
+      </p:sp>
+      <p:sp>
+        <p:nvSpPr>
+          <p:cNvPr id="57" name="Rectangle 56"/>
           <p:cNvSpPr/>
           <p:nvPr/>
         </p:nvSpPr>
         <p:spPr>
           <a:xfrm>
-            <a:off x="10140696" y="4709160"/>
-            <a:ext cx="1261872" cy="777240"/>
-          </a:xfrm>
-          <a:prstGeom prst="roundRect">
-            <a:avLst/>
-          </a:prstGeom>
-          <a:solidFill>
-            <a:srgbClr val="DCFCE7"/>
+            <a:off x="502920" y="3913632"/>
+            <a:ext cx="11155680" cy="274320"/>
+          </a:xfrm>
+          <a:prstGeom prst="rect">
+            <a:avLst/>
+          </a:prstGeom>
+          <a:solidFill>
+            <a:srgbClr val="F2F2F2"/>
           </a:solidFill>
           <a:ln w="6350">
             <a:solidFill>
@@ -21796,6 +21362,116 @@
           </a:fontRef>
         </p:style>
         <p:txBody>
+          <a:bodyPr rtlCol="0" anchor="ctr" wrap="square"/>
+          <a:lstStyle/>
+          <a:p>
+            <a:pPr algn="ctr">
+              <a:defRPr sz="700" b="0">
+                <a:solidFill>
+                  <a:srgbClr val="334155"/>
+                </a:solidFill>
+                <a:latin typeface="Calibri"/>
+              </a:defRPr>
+            </a:pPr>
+            <a:r>
+              <a:t>MSC-195138 · MSC-195138-06-02-2026-14-39-24-IST.html · 06-02-2026 14:39 IST · PRs #22 reps · #75 texttransform MERGED · FF Race · 11/11 GWT</a:t>
+            </a:r>
+          </a:p>
+        </p:txBody>
+      </p:sp>
+      <p:sp>
+        <p:nvSpPr>
+          <p:cNvPr id="58" name="Rectangle 57"/>
+          <p:cNvSpPr/>
+          <p:nvPr/>
+        </p:nvSpPr>
+        <p:spPr>
+          <a:xfrm>
+            <a:off x="502920" y="4160520"/>
+            <a:ext cx="5394960" cy="292608"/>
+          </a:xfrm>
+          <a:prstGeom prst="rect">
+            <a:avLst/>
+          </a:prstGeom>
+          <a:solidFill>
+            <a:srgbClr val="04066C"/>
+          </a:solidFill>
+          <a:ln w="6350">
+            <a:solidFill>
+              <a:srgbClr val="E2E8F0"/>
+            </a:solidFill>
+          </a:ln>
+        </p:spPr>
+        <p:style>
+          <a:lnRef idx="1">
+            <a:schemeClr val="accent1"/>
+          </a:lnRef>
+          <a:fillRef idx="3">
+            <a:schemeClr val="accent1"/>
+          </a:fillRef>
+          <a:effectRef idx="2">
+            <a:schemeClr val="accent1"/>
+          </a:effectRef>
+          <a:fontRef idx="minor">
+            <a:schemeClr val="lt1"/>
+          </a:fontRef>
+        </p:style>
+        <p:txBody>
+          <a:bodyPr rtlCol="0" anchor="ctr" wrap="square"/>
+          <a:lstStyle/>
+          <a:p>
+            <a:pPr algn="ctr">
+              <a:defRPr sz="900" b="1">
+                <a:solidFill>
+                  <a:srgbClr val="FFFFFF"/>
+                </a:solidFill>
+                <a:latin typeface="Calibri"/>
+              </a:defRPr>
+            </a:pPr>
+            <a:r>
+              <a:t>MSC-212571 — newest §1 cards</a:t>
+            </a:r>
+          </a:p>
+        </p:txBody>
+      </p:sp>
+      <p:sp>
+        <p:nvSpPr>
+          <p:cNvPr id="59" name="Rounded Rectangle 58"/>
+          <p:cNvSpPr/>
+          <p:nvPr/>
+        </p:nvSpPr>
+        <p:spPr>
+          <a:xfrm>
+            <a:off x="502920" y="4498848"/>
+            <a:ext cx="1261872" cy="749808"/>
+          </a:xfrm>
+          <a:prstGeom prst="roundRect">
+            <a:avLst/>
+          </a:prstGeom>
+          <a:solidFill>
+            <a:srgbClr val="E8F0FE"/>
+          </a:solidFill>
+          <a:ln w="6350">
+            <a:solidFill>
+              <a:srgbClr val="E2E8F0"/>
+            </a:solidFill>
+          </a:ln>
+        </p:spPr>
+        <p:style>
+          <a:lnRef idx="1">
+            <a:schemeClr val="accent1"/>
+          </a:lnRef>
+          <a:fillRef idx="3">
+            <a:schemeClr val="accent1"/>
+          </a:fillRef>
+          <a:effectRef idx="2">
+            <a:schemeClr val="accent1"/>
+          </a:effectRef>
+          <a:fontRef idx="minor">
+            <a:schemeClr val="lt1"/>
+          </a:fontRef>
+        </p:style>
+        <p:txBody>
           <a:bodyPr rtlCol="0" anchor="ctr"/>
           <a:lstStyle/>
           <a:p>
@@ -21805,13 +21481,13 @@
       </p:sp>
       <p:sp>
         <p:nvSpPr>
-          <p:cNvPr id="72" name="TextBox 71"/>
-          <p:cNvSpPr txBox="1"/>
-          <p:nvPr/>
-        </p:nvSpPr>
-        <p:spPr>
-          <a:xfrm>
-            <a:off x="10232136" y="4846320"/>
+          <p:cNvPr id="60" name="TextBox 59"/>
+          <p:cNvSpPr txBox="1"/>
+          <p:nvPr/>
+        </p:nvSpPr>
+        <p:spPr>
+          <a:xfrm>
+            <a:off x="594360" y="4636008"/>
             <a:ext cx="1078992" cy="502920"/>
           </a:xfrm>
           <a:prstGeom prst="rect">
@@ -21828,12 +21504,1409 @@
             <a:pPr algn="ctr">
               <a:defRPr sz="2800" b="1">
                 <a:solidFill>
+                  <a:srgbClr val="04066C"/>
+                </a:solidFill>
+                <a:latin typeface="Calibri"/>
+              </a:defRPr>
+            </a:pPr>
+            <a:r>
+              <a:t>100.0%</a:t>
+            </a:r>
+          </a:p>
+        </p:txBody>
+      </p:sp>
+      <p:sp>
+        <p:nvSpPr>
+          <p:cNvPr id="61" name="TextBox 60"/>
+          <p:cNvSpPr txBox="1"/>
+          <p:nvPr/>
+        </p:nvSpPr>
+        <p:spPr>
+          <a:xfrm>
+            <a:off x="576072" y="5157216"/>
+            <a:ext cx="1115568" cy="411480"/>
+          </a:xfrm>
+          <a:prstGeom prst="rect">
+            <a:avLst/>
+          </a:prstGeom>
+          <a:noFill/>
+        </p:spPr>
+        <p:txBody>
+          <a:bodyPr wrap="none">
+            <a:spAutoFit/>
+          </a:bodyPr>
+          <a:lstStyle/>
+          <a:p>
+            <a:pPr algn="ctr">
+              <a:defRPr sz="1100" b="1">
+                <a:solidFill>
+                  <a:srgbClr val="04066C"/>
+                </a:solidFill>
+                <a:latin typeface="Calibri"/>
+              </a:defRPr>
+            </a:pPr>
+            <a:r>
+              <a:t>Dev code</a:t>
+            </a:r>
+          </a:p>
+        </p:txBody>
+      </p:sp>
+      <p:sp>
+        <p:nvSpPr>
+          <p:cNvPr id="62" name="Rounded Rectangle 61"/>
+          <p:cNvSpPr/>
+          <p:nvPr/>
+        </p:nvSpPr>
+        <p:spPr>
+          <a:xfrm>
+            <a:off x="1856232" y="4498848"/>
+            <a:ext cx="1261872" cy="749808"/>
+          </a:xfrm>
+          <a:prstGeom prst="roundRect">
+            <a:avLst/>
+          </a:prstGeom>
+          <a:solidFill>
+            <a:srgbClr val="E8F0FE"/>
+          </a:solidFill>
+          <a:ln w="6350">
+            <a:solidFill>
+              <a:srgbClr val="E2E8F0"/>
+            </a:solidFill>
+          </a:ln>
+        </p:spPr>
+        <p:style>
+          <a:lnRef idx="1">
+            <a:schemeClr val="accent1"/>
+          </a:lnRef>
+          <a:fillRef idx="3">
+            <a:schemeClr val="accent1"/>
+          </a:fillRef>
+          <a:effectRef idx="2">
+            <a:schemeClr val="accent1"/>
+          </a:effectRef>
+          <a:fontRef idx="minor">
+            <a:schemeClr val="lt1"/>
+          </a:fontRef>
+        </p:style>
+        <p:txBody>
+          <a:bodyPr rtlCol="0" anchor="ctr"/>
+          <a:lstStyle/>
+          <a:p>
+            <a:pPr algn="ctr"/>
+          </a:p>
+        </p:txBody>
+      </p:sp>
+      <p:sp>
+        <p:nvSpPr>
+          <p:cNvPr id="63" name="TextBox 62"/>
+          <p:cNvSpPr txBox="1"/>
+          <p:nvPr/>
+        </p:nvSpPr>
+        <p:spPr>
+          <a:xfrm>
+            <a:off x="1947672" y="4636008"/>
+            <a:ext cx="1078992" cy="502920"/>
+          </a:xfrm>
+          <a:prstGeom prst="rect">
+            <a:avLst/>
+          </a:prstGeom>
+          <a:noFill/>
+        </p:spPr>
+        <p:txBody>
+          <a:bodyPr wrap="none">
+            <a:spAutoFit/>
+          </a:bodyPr>
+          <a:lstStyle/>
+          <a:p>
+            <a:pPr algn="ctr">
+              <a:defRPr sz="2800" b="1">
+                <a:solidFill>
+                  <a:srgbClr val="04066C"/>
+                </a:solidFill>
+                <a:latin typeface="Calibri"/>
+              </a:defRPr>
+            </a:pPr>
+            <a:r>
+              <a:t>5.6%</a:t>
+            </a:r>
+          </a:p>
+        </p:txBody>
+      </p:sp>
+      <p:sp>
+        <p:nvSpPr>
+          <p:cNvPr id="64" name="TextBox 63"/>
+          <p:cNvSpPr txBox="1"/>
+          <p:nvPr/>
+        </p:nvSpPr>
+        <p:spPr>
+          <a:xfrm>
+            <a:off x="1929384" y="5157216"/>
+            <a:ext cx="1115568" cy="411480"/>
+          </a:xfrm>
+          <a:prstGeom prst="rect">
+            <a:avLst/>
+          </a:prstGeom>
+          <a:noFill/>
+        </p:spPr>
+        <p:txBody>
+          <a:bodyPr wrap="none">
+            <a:spAutoFit/>
+          </a:bodyPr>
+          <a:lstStyle/>
+          <a:p>
+            <a:pPr algn="ctr">
+              <a:defRPr sz="1100" b="1">
+                <a:solidFill>
+                  <a:srgbClr val="04066C"/>
+                </a:solidFill>
+                <a:latin typeface="Calibri"/>
+              </a:defRPr>
+            </a:pPr>
+            <a:r>
+              <a:t>Dev tests</a:t>
+            </a:r>
+          </a:p>
+        </p:txBody>
+      </p:sp>
+      <p:sp>
+        <p:nvSpPr>
+          <p:cNvPr id="65" name="Rounded Rectangle 64"/>
+          <p:cNvSpPr/>
+          <p:nvPr/>
+        </p:nvSpPr>
+        <p:spPr>
+          <a:xfrm>
+            <a:off x="3209544" y="4498848"/>
+            <a:ext cx="1261872" cy="749808"/>
+          </a:xfrm>
+          <a:prstGeom prst="roundRect">
+            <a:avLst/>
+          </a:prstGeom>
+          <a:solidFill>
+            <a:srgbClr val="E8F0FE"/>
+          </a:solidFill>
+          <a:ln w="6350">
+            <a:solidFill>
+              <a:srgbClr val="E2E8F0"/>
+            </a:solidFill>
+          </a:ln>
+        </p:spPr>
+        <p:style>
+          <a:lnRef idx="1">
+            <a:schemeClr val="accent1"/>
+          </a:lnRef>
+          <a:fillRef idx="3">
+            <a:schemeClr val="accent1"/>
+          </a:fillRef>
+          <a:effectRef idx="2">
+            <a:schemeClr val="accent1"/>
+          </a:effectRef>
+          <a:fontRef idx="minor">
+            <a:schemeClr val="lt1"/>
+          </a:fontRef>
+        </p:style>
+        <p:txBody>
+          <a:bodyPr rtlCol="0" anchor="ctr"/>
+          <a:lstStyle/>
+          <a:p>
+            <a:pPr algn="ctr"/>
+          </a:p>
+        </p:txBody>
+      </p:sp>
+      <p:sp>
+        <p:nvSpPr>
+          <p:cNvPr id="66" name="TextBox 65"/>
+          <p:cNvSpPr txBox="1"/>
+          <p:nvPr/>
+        </p:nvSpPr>
+        <p:spPr>
+          <a:xfrm>
+            <a:off x="3300984" y="4636008"/>
+            <a:ext cx="1078992" cy="502920"/>
+          </a:xfrm>
+          <a:prstGeom prst="rect">
+            <a:avLst/>
+          </a:prstGeom>
+          <a:noFill/>
+        </p:spPr>
+        <p:txBody>
+          <a:bodyPr wrap="none">
+            <a:spAutoFit/>
+          </a:bodyPr>
+          <a:lstStyle/>
+          <a:p>
+            <a:pPr algn="ctr">
+              <a:defRPr sz="2800" b="1">
+                <a:solidFill>
+                  <a:srgbClr val="04066C"/>
+                </a:solidFill>
+                <a:latin typeface="Calibri"/>
+              </a:defRPr>
+            </a:pPr>
+            <a:r>
+              <a:t>66.7%</a:t>
+            </a:r>
+          </a:p>
+        </p:txBody>
+      </p:sp>
+      <p:sp>
+        <p:nvSpPr>
+          <p:cNvPr id="67" name="TextBox 66"/>
+          <p:cNvSpPr txBox="1"/>
+          <p:nvPr/>
+        </p:nvSpPr>
+        <p:spPr>
+          <a:xfrm>
+            <a:off x="3282696" y="5157216"/>
+            <a:ext cx="1115568" cy="411480"/>
+          </a:xfrm>
+          <a:prstGeom prst="rect">
+            <a:avLst/>
+          </a:prstGeom>
+          <a:noFill/>
+        </p:spPr>
+        <p:txBody>
+          <a:bodyPr wrap="none">
+            <a:spAutoFit/>
+          </a:bodyPr>
+          <a:lstStyle/>
+          <a:p>
+            <a:pPr algn="ctr">
+              <a:defRPr sz="1100" b="1">
+                <a:solidFill>
+                  <a:srgbClr val="04066C"/>
+                </a:solidFill>
+                <a:latin typeface="Calibri"/>
+              </a:defRPr>
+            </a:pPr>
+            <a:r>
+              <a:t>Test plan AC</a:t>
+            </a:r>
+          </a:p>
+        </p:txBody>
+      </p:sp>
+      <p:sp>
+        <p:nvSpPr>
+          <p:cNvPr id="68" name="Rounded Rectangle 67"/>
+          <p:cNvSpPr/>
+          <p:nvPr/>
+        </p:nvSpPr>
+        <p:spPr>
+          <a:xfrm>
+            <a:off x="4562856" y="4498848"/>
+            <a:ext cx="1261872" cy="749808"/>
+          </a:xfrm>
+          <a:prstGeom prst="roundRect">
+            <a:avLst/>
+          </a:prstGeom>
+          <a:solidFill>
+            <a:srgbClr val="E8F0FE"/>
+          </a:solidFill>
+          <a:ln w="6350">
+            <a:solidFill>
+              <a:srgbClr val="E2E8F0"/>
+            </a:solidFill>
+          </a:ln>
+        </p:spPr>
+        <p:style>
+          <a:lnRef idx="1">
+            <a:schemeClr val="accent1"/>
+          </a:lnRef>
+          <a:fillRef idx="3">
+            <a:schemeClr val="accent1"/>
+          </a:fillRef>
+          <a:effectRef idx="2">
+            <a:schemeClr val="accent1"/>
+          </a:effectRef>
+          <a:fontRef idx="minor">
+            <a:schemeClr val="lt1"/>
+          </a:fontRef>
+        </p:style>
+        <p:txBody>
+          <a:bodyPr rtlCol="0" anchor="ctr"/>
+          <a:lstStyle/>
+          <a:p>
+            <a:pPr algn="ctr"/>
+          </a:p>
+        </p:txBody>
+      </p:sp>
+      <p:sp>
+        <p:nvSpPr>
+          <p:cNvPr id="69" name="TextBox 68"/>
+          <p:cNvSpPr txBox="1"/>
+          <p:nvPr/>
+        </p:nvSpPr>
+        <p:spPr>
+          <a:xfrm>
+            <a:off x="4654296" y="4636008"/>
+            <a:ext cx="1078992" cy="502920"/>
+          </a:xfrm>
+          <a:prstGeom prst="rect">
+            <a:avLst/>
+          </a:prstGeom>
+          <a:noFill/>
+        </p:spPr>
+        <p:txBody>
+          <a:bodyPr wrap="none">
+            <a:spAutoFit/>
+          </a:bodyPr>
+          <a:lstStyle/>
+          <a:p>
+            <a:pPr algn="ctr">
+              <a:defRPr sz="2800" b="1">
+                <a:solidFill>
+                  <a:srgbClr val="04066C"/>
+                </a:solidFill>
+                <a:latin typeface="Calibri"/>
+              </a:defRPr>
+            </a:pPr>
+            <a:r>
+              <a:t>99.2%</a:t>
+            </a:r>
+          </a:p>
+        </p:txBody>
+      </p:sp>
+      <p:sp>
+        <p:nvSpPr>
+          <p:cNvPr id="70" name="TextBox 69"/>
+          <p:cNvSpPr txBox="1"/>
+          <p:nvPr/>
+        </p:nvSpPr>
+        <p:spPr>
+          <a:xfrm>
+            <a:off x="4636008" y="5157216"/>
+            <a:ext cx="1115568" cy="411480"/>
+          </a:xfrm>
+          <a:prstGeom prst="rect">
+            <a:avLst/>
+          </a:prstGeom>
+          <a:noFill/>
+        </p:spPr>
+        <p:txBody>
+          <a:bodyPr wrap="none">
+            <a:spAutoFit/>
+          </a:bodyPr>
+          <a:lstStyle/>
+          <a:p>
+            <a:pPr algn="ctr">
+              <a:defRPr sz="1100" b="1">
+                <a:solidFill>
+                  <a:srgbClr val="04066C"/>
+                </a:solidFill>
+                <a:latin typeface="Calibri"/>
+              </a:defRPr>
+            </a:pPr>
+            <a:r>
+              <a:t>CI line</a:t>
+            </a:r>
+          </a:p>
+        </p:txBody>
+      </p:sp>
+      <p:sp>
+        <p:nvSpPr>
+          <p:cNvPr id="71" name="Rectangle 70"/>
+          <p:cNvSpPr/>
+          <p:nvPr/>
+        </p:nvSpPr>
+        <p:spPr>
+          <a:xfrm>
+            <a:off x="6080760" y="4160520"/>
+            <a:ext cx="5577840" cy="292608"/>
+          </a:xfrm>
+          <a:prstGeom prst="rect">
+            <a:avLst/>
+          </a:prstGeom>
+          <a:solidFill>
+            <a:srgbClr val="04066C"/>
+          </a:solidFill>
+          <a:ln w="6350">
+            <a:solidFill>
+              <a:srgbClr val="E2E8F0"/>
+            </a:solidFill>
+          </a:ln>
+        </p:spPr>
+        <p:style>
+          <a:lnRef idx="1">
+            <a:schemeClr val="accent1"/>
+          </a:lnRef>
+          <a:fillRef idx="3">
+            <a:schemeClr val="accent1"/>
+          </a:fillRef>
+          <a:effectRef idx="2">
+            <a:schemeClr val="accent1"/>
+          </a:effectRef>
+          <a:fontRef idx="minor">
+            <a:schemeClr val="lt1"/>
+          </a:fontRef>
+        </p:style>
+        <p:txBody>
+          <a:bodyPr rtlCol="0" anchor="ctr" wrap="square"/>
+          <a:lstStyle/>
+          <a:p>
+            <a:pPr algn="ctr">
+              <a:defRPr sz="900" b="1">
+                <a:solidFill>
+                  <a:srgbClr val="FFFFFF"/>
+                </a:solidFill>
+                <a:latin typeface="Calibri"/>
+              </a:defRPr>
+            </a:pPr>
+            <a:r>
+              <a:t>MSC-204417 — branch-only (no PR)</a:t>
+            </a:r>
+          </a:p>
+        </p:txBody>
+      </p:sp>
+      <p:sp>
+        <p:nvSpPr>
+          <p:cNvPr id="72" name="Rounded Rectangle 71"/>
+          <p:cNvSpPr/>
+          <p:nvPr/>
+        </p:nvSpPr>
+        <p:spPr>
+          <a:xfrm>
+            <a:off x="6080760" y="4498848"/>
+            <a:ext cx="1261872" cy="749808"/>
+          </a:xfrm>
+          <a:prstGeom prst="roundRect">
+            <a:avLst/>
+          </a:prstGeom>
+          <a:solidFill>
+            <a:srgbClr val="E8F0FE"/>
+          </a:solidFill>
+          <a:ln w="6350">
+            <a:solidFill>
+              <a:srgbClr val="E2E8F0"/>
+            </a:solidFill>
+          </a:ln>
+        </p:spPr>
+        <p:style>
+          <a:lnRef idx="1">
+            <a:schemeClr val="accent1"/>
+          </a:lnRef>
+          <a:fillRef idx="3">
+            <a:schemeClr val="accent1"/>
+          </a:fillRef>
+          <a:effectRef idx="2">
+            <a:schemeClr val="accent1"/>
+          </a:effectRef>
+          <a:fontRef idx="minor">
+            <a:schemeClr val="lt1"/>
+          </a:fontRef>
+        </p:style>
+        <p:txBody>
+          <a:bodyPr rtlCol="0" anchor="ctr"/>
+          <a:lstStyle/>
+          <a:p>
+            <a:pPr algn="ctr"/>
+          </a:p>
+        </p:txBody>
+      </p:sp>
+      <p:sp>
+        <p:nvSpPr>
+          <p:cNvPr id="73" name="TextBox 72"/>
+          <p:cNvSpPr txBox="1"/>
+          <p:nvPr/>
+        </p:nvSpPr>
+        <p:spPr>
+          <a:xfrm>
+            <a:off x="6172200" y="4636008"/>
+            <a:ext cx="1078992" cy="502920"/>
+          </a:xfrm>
+          <a:prstGeom prst="rect">
+            <a:avLst/>
+          </a:prstGeom>
+          <a:noFill/>
+        </p:spPr>
+        <p:txBody>
+          <a:bodyPr wrap="none">
+            <a:spAutoFit/>
+          </a:bodyPr>
+          <a:lstStyle/>
+          <a:p>
+            <a:pPr algn="ctr">
+              <a:defRPr sz="2800" b="1">
+                <a:solidFill>
+                  <a:srgbClr val="04066C"/>
+                </a:solidFill>
+                <a:latin typeface="Calibri"/>
+              </a:defRPr>
+            </a:pPr>
+            <a:r>
+              <a:t>100.0%</a:t>
+            </a:r>
+          </a:p>
+        </p:txBody>
+      </p:sp>
+      <p:sp>
+        <p:nvSpPr>
+          <p:cNvPr id="74" name="TextBox 73"/>
+          <p:cNvSpPr txBox="1"/>
+          <p:nvPr/>
+        </p:nvSpPr>
+        <p:spPr>
+          <a:xfrm>
+            <a:off x="6153912" y="5157216"/>
+            <a:ext cx="1115568" cy="411480"/>
+          </a:xfrm>
+          <a:prstGeom prst="rect">
+            <a:avLst/>
+          </a:prstGeom>
+          <a:noFill/>
+        </p:spPr>
+        <p:txBody>
+          <a:bodyPr wrap="none">
+            <a:spAutoFit/>
+          </a:bodyPr>
+          <a:lstStyle/>
+          <a:p>
+            <a:pPr algn="ctr">
+              <a:defRPr sz="1100" b="1">
+                <a:solidFill>
+                  <a:srgbClr val="04066C"/>
+                </a:solidFill>
+                <a:latin typeface="Calibri"/>
+              </a:defRPr>
+            </a:pPr>
+            <a:r>
+              <a:t>Dev code</a:t>
+            </a:r>
+          </a:p>
+        </p:txBody>
+      </p:sp>
+      <p:sp>
+        <p:nvSpPr>
+          <p:cNvPr id="75" name="Rounded Rectangle 74"/>
+          <p:cNvSpPr/>
+          <p:nvPr/>
+        </p:nvSpPr>
+        <p:spPr>
+          <a:xfrm>
+            <a:off x="7434072" y="4498848"/>
+            <a:ext cx="1261872" cy="749808"/>
+          </a:xfrm>
+          <a:prstGeom prst="roundRect">
+            <a:avLst/>
+          </a:prstGeom>
+          <a:solidFill>
+            <a:srgbClr val="E8F0FE"/>
+          </a:solidFill>
+          <a:ln w="6350">
+            <a:solidFill>
+              <a:srgbClr val="E2E8F0"/>
+            </a:solidFill>
+          </a:ln>
+        </p:spPr>
+        <p:style>
+          <a:lnRef idx="1">
+            <a:schemeClr val="accent1"/>
+          </a:lnRef>
+          <a:fillRef idx="3">
+            <a:schemeClr val="accent1"/>
+          </a:fillRef>
+          <a:effectRef idx="2">
+            <a:schemeClr val="accent1"/>
+          </a:effectRef>
+          <a:fontRef idx="minor">
+            <a:schemeClr val="lt1"/>
+          </a:fontRef>
+        </p:style>
+        <p:txBody>
+          <a:bodyPr rtlCol="0" anchor="ctr"/>
+          <a:lstStyle/>
+          <a:p>
+            <a:pPr algn="ctr"/>
+          </a:p>
+        </p:txBody>
+      </p:sp>
+      <p:sp>
+        <p:nvSpPr>
+          <p:cNvPr id="76" name="TextBox 75"/>
+          <p:cNvSpPr txBox="1"/>
+          <p:nvPr/>
+        </p:nvSpPr>
+        <p:spPr>
+          <a:xfrm>
+            <a:off x="7525512" y="4636008"/>
+            <a:ext cx="1078992" cy="502920"/>
+          </a:xfrm>
+          <a:prstGeom prst="rect">
+            <a:avLst/>
+          </a:prstGeom>
+          <a:noFill/>
+        </p:spPr>
+        <p:txBody>
+          <a:bodyPr wrap="none">
+            <a:spAutoFit/>
+          </a:bodyPr>
+          <a:lstStyle/>
+          <a:p>
+            <a:pPr algn="ctr">
+              <a:defRPr sz="2800" b="1">
+                <a:solidFill>
+                  <a:srgbClr val="04066C"/>
+                </a:solidFill>
+                <a:latin typeface="Calibri"/>
+              </a:defRPr>
+            </a:pPr>
+            <a:r>
+              <a:t>83.3%</a:t>
+            </a:r>
+          </a:p>
+        </p:txBody>
+      </p:sp>
+      <p:sp>
+        <p:nvSpPr>
+          <p:cNvPr id="77" name="TextBox 76"/>
+          <p:cNvSpPr txBox="1"/>
+          <p:nvPr/>
+        </p:nvSpPr>
+        <p:spPr>
+          <a:xfrm>
+            <a:off x="7507224" y="5157216"/>
+            <a:ext cx="1115568" cy="411480"/>
+          </a:xfrm>
+          <a:prstGeom prst="rect">
+            <a:avLst/>
+          </a:prstGeom>
+          <a:noFill/>
+        </p:spPr>
+        <p:txBody>
+          <a:bodyPr wrap="none">
+            <a:spAutoFit/>
+          </a:bodyPr>
+          <a:lstStyle/>
+          <a:p>
+            <a:pPr algn="ctr">
+              <a:defRPr sz="1100" b="1">
+                <a:solidFill>
+                  <a:srgbClr val="04066C"/>
+                </a:solidFill>
+                <a:latin typeface="Calibri"/>
+              </a:defRPr>
+            </a:pPr>
+            <a:r>
+              <a:t>Dev tests</a:t>
+            </a:r>
+          </a:p>
+        </p:txBody>
+      </p:sp>
+      <p:sp>
+        <p:nvSpPr>
+          <p:cNvPr id="78" name="Rounded Rectangle 77"/>
+          <p:cNvSpPr/>
+          <p:nvPr/>
+        </p:nvSpPr>
+        <p:spPr>
+          <a:xfrm>
+            <a:off x="8787384" y="4498848"/>
+            <a:ext cx="1261872" cy="749808"/>
+          </a:xfrm>
+          <a:prstGeom prst="roundRect">
+            <a:avLst/>
+          </a:prstGeom>
+          <a:solidFill>
+            <a:srgbClr val="E8F0FE"/>
+          </a:solidFill>
+          <a:ln w="6350">
+            <a:solidFill>
+              <a:srgbClr val="E2E8F0"/>
+            </a:solidFill>
+          </a:ln>
+        </p:spPr>
+        <p:style>
+          <a:lnRef idx="1">
+            <a:schemeClr val="accent1"/>
+          </a:lnRef>
+          <a:fillRef idx="3">
+            <a:schemeClr val="accent1"/>
+          </a:fillRef>
+          <a:effectRef idx="2">
+            <a:schemeClr val="accent1"/>
+          </a:effectRef>
+          <a:fontRef idx="minor">
+            <a:schemeClr val="lt1"/>
+          </a:fontRef>
+        </p:style>
+        <p:txBody>
+          <a:bodyPr rtlCol="0" anchor="ctr"/>
+          <a:lstStyle/>
+          <a:p>
+            <a:pPr algn="ctr"/>
+          </a:p>
+        </p:txBody>
+      </p:sp>
+      <p:sp>
+        <p:nvSpPr>
+          <p:cNvPr id="79" name="TextBox 78"/>
+          <p:cNvSpPr txBox="1"/>
+          <p:nvPr/>
+        </p:nvSpPr>
+        <p:spPr>
+          <a:xfrm>
+            <a:off x="8878824" y="4636008"/>
+            <a:ext cx="1078992" cy="502920"/>
+          </a:xfrm>
+          <a:prstGeom prst="rect">
+            <a:avLst/>
+          </a:prstGeom>
+          <a:noFill/>
+        </p:spPr>
+        <p:txBody>
+          <a:bodyPr wrap="none">
+            <a:spAutoFit/>
+          </a:bodyPr>
+          <a:lstStyle/>
+          <a:p>
+            <a:pPr algn="ctr">
+              <a:defRPr sz="2800" b="1">
+                <a:solidFill>
+                  <a:srgbClr val="04066C"/>
+                </a:solidFill>
+                <a:latin typeface="Calibri"/>
+              </a:defRPr>
+            </a:pPr>
+            <a:r>
+              <a:t>94.1%</a:t>
+            </a:r>
+          </a:p>
+        </p:txBody>
+      </p:sp>
+      <p:sp>
+        <p:nvSpPr>
+          <p:cNvPr id="80" name="TextBox 79"/>
+          <p:cNvSpPr txBox="1"/>
+          <p:nvPr/>
+        </p:nvSpPr>
+        <p:spPr>
+          <a:xfrm>
+            <a:off x="8860536" y="5157216"/>
+            <a:ext cx="1115568" cy="411480"/>
+          </a:xfrm>
+          <a:prstGeom prst="rect">
+            <a:avLst/>
+          </a:prstGeom>
+          <a:noFill/>
+        </p:spPr>
+        <p:txBody>
+          <a:bodyPr wrap="none">
+            <a:spAutoFit/>
+          </a:bodyPr>
+          <a:lstStyle/>
+          <a:p>
+            <a:pPr algn="ctr">
+              <a:defRPr sz="1100" b="1">
+                <a:solidFill>
+                  <a:srgbClr val="04066C"/>
+                </a:solidFill>
+                <a:latin typeface="Calibri"/>
+              </a:defRPr>
+            </a:pPr>
+            <a:r>
+              <a:t>Test plan AC</a:t>
+            </a:r>
+          </a:p>
+        </p:txBody>
+      </p:sp>
+      <p:sp>
+        <p:nvSpPr>
+          <p:cNvPr id="81" name="Rounded Rectangle 80"/>
+          <p:cNvSpPr/>
+          <p:nvPr/>
+        </p:nvSpPr>
+        <p:spPr>
+          <a:xfrm>
+            <a:off x="10140696" y="4498848"/>
+            <a:ext cx="1261872" cy="749808"/>
+          </a:xfrm>
+          <a:prstGeom prst="roundRect">
+            <a:avLst/>
+          </a:prstGeom>
+          <a:solidFill>
+            <a:srgbClr val="FFF8E1"/>
+          </a:solidFill>
+          <a:ln w="6350">
+            <a:solidFill>
+              <a:srgbClr val="E2E8F0"/>
+            </a:solidFill>
+          </a:ln>
+        </p:spPr>
+        <p:style>
+          <a:lnRef idx="1">
+            <a:schemeClr val="accent1"/>
+          </a:lnRef>
+          <a:fillRef idx="3">
+            <a:schemeClr val="accent1"/>
+          </a:fillRef>
+          <a:effectRef idx="2">
+            <a:schemeClr val="accent1"/>
+          </a:effectRef>
+          <a:fontRef idx="minor">
+            <a:schemeClr val="lt1"/>
+          </a:fontRef>
+        </p:style>
+        <p:txBody>
+          <a:bodyPr rtlCol="0" anchor="ctr"/>
+          <a:lstStyle/>
+          <a:p>
+            <a:pPr algn="ctr"/>
+          </a:p>
+        </p:txBody>
+      </p:sp>
+      <p:sp>
+        <p:nvSpPr>
+          <p:cNvPr id="82" name="TextBox 81"/>
+          <p:cNvSpPr txBox="1"/>
+          <p:nvPr/>
+        </p:nvSpPr>
+        <p:spPr>
+          <a:xfrm>
+            <a:off x="10232136" y="4636008"/>
+            <a:ext cx="1078992" cy="502920"/>
+          </a:xfrm>
+          <a:prstGeom prst="rect">
+            <a:avLst/>
+          </a:prstGeom>
+          <a:noFill/>
+        </p:spPr>
+        <p:txBody>
+          <a:bodyPr wrap="none">
+            <a:spAutoFit/>
+          </a:bodyPr>
+          <a:lstStyle/>
+          <a:p>
+            <a:pPr algn="ctr">
+              <a:defRPr sz="2800" b="1">
+                <a:solidFill>
+                  <a:srgbClr val="04066C"/>
+                </a:solidFill>
+                <a:latin typeface="Calibri"/>
+              </a:defRPr>
+            </a:pPr>
+            <a:r>
+              <a:t>NA</a:t>
+            </a:r>
+          </a:p>
+        </p:txBody>
+      </p:sp>
+      <p:sp>
+        <p:nvSpPr>
+          <p:cNvPr id="83" name="TextBox 82"/>
+          <p:cNvSpPr txBox="1"/>
+          <p:nvPr/>
+        </p:nvSpPr>
+        <p:spPr>
+          <a:xfrm>
+            <a:off x="10213848" y="5157216"/>
+            <a:ext cx="1115568" cy="411480"/>
+          </a:xfrm>
+          <a:prstGeom prst="rect">
+            <a:avLst/>
+          </a:prstGeom>
+          <a:noFill/>
+        </p:spPr>
+        <p:txBody>
+          <a:bodyPr wrap="none">
+            <a:spAutoFit/>
+          </a:bodyPr>
+          <a:lstStyle/>
+          <a:p>
+            <a:pPr algn="ctr">
+              <a:defRPr sz="1100" b="1">
+                <a:solidFill>
+                  <a:srgbClr val="04066C"/>
+                </a:solidFill>
+                <a:latin typeface="Calibri"/>
+              </a:defRPr>
+            </a:pPr>
+            <a:r>
+              <a:t>CI line</a:t>
+            </a:r>
+          </a:p>
+        </p:txBody>
+      </p:sp>
+      <p:sp>
+        <p:nvSpPr>
+          <p:cNvPr id="84" name="Rounded Rectangle 83"/>
+          <p:cNvSpPr/>
+          <p:nvPr/>
+        </p:nvSpPr>
+        <p:spPr>
+          <a:xfrm>
+            <a:off x="502920" y="5349240"/>
+            <a:ext cx="11155680" cy="292608"/>
+          </a:xfrm>
+          <a:prstGeom prst="roundRect">
+            <a:avLst/>
+          </a:prstGeom>
+          <a:solidFill>
+            <a:srgbClr val="F2F2F2"/>
+          </a:solidFill>
+          <a:ln w="6350">
+            <a:solidFill>
+              <a:srgbClr val="E2E8F0"/>
+            </a:solidFill>
+          </a:ln>
+        </p:spPr>
+        <p:style>
+          <a:lnRef idx="1">
+            <a:schemeClr val="accent1"/>
+          </a:lnRef>
+          <a:fillRef idx="3">
+            <a:schemeClr val="accent1"/>
+          </a:fillRef>
+          <a:effectRef idx="2">
+            <a:schemeClr val="accent1"/>
+          </a:effectRef>
+          <a:fontRef idx="minor">
+            <a:schemeClr val="lt1"/>
+          </a:fontRef>
+        </p:style>
+        <p:txBody>
+          <a:bodyPr rtlCol="0" anchor="ctr" wrap="square"/>
+          <a:lstStyle/>
+          <a:p>
+            <a:pPr algn="ctr">
+              <a:defRPr sz="800" b="0">
+                <a:solidFill>
+                  <a:srgbClr val="04066C"/>
+                </a:solidFill>
+                <a:latin typeface="Calibri"/>
+              </a:defRPr>
+            </a:pPr>
+            <a:r>
+              <a:t>MSC-205625 — dual PR + passport Confluence LADR · CI 95%+</a:t>
+            </a:r>
+          </a:p>
+        </p:txBody>
+      </p:sp>
+      <p:sp>
+        <p:nvSpPr>
+          <p:cNvPr id="85" name="Rounded Rectangle 84"/>
+          <p:cNvSpPr/>
+          <p:nvPr/>
+        </p:nvSpPr>
+        <p:spPr>
+          <a:xfrm>
+            <a:off x="502920" y="5687568"/>
+            <a:ext cx="1261872" cy="685800"/>
+          </a:xfrm>
+          <a:prstGeom prst="roundRect">
+            <a:avLst/>
+          </a:prstGeom>
+          <a:solidFill>
+            <a:srgbClr val="DCFCE7"/>
+          </a:solidFill>
+          <a:ln w="6350">
+            <a:solidFill>
+              <a:srgbClr val="E2E8F0"/>
+            </a:solidFill>
+          </a:ln>
+        </p:spPr>
+        <p:style>
+          <a:lnRef idx="1">
+            <a:schemeClr val="accent1"/>
+          </a:lnRef>
+          <a:fillRef idx="3">
+            <a:schemeClr val="accent1"/>
+          </a:fillRef>
+          <a:effectRef idx="2">
+            <a:schemeClr val="accent1"/>
+          </a:effectRef>
+          <a:fontRef idx="minor">
+            <a:schemeClr val="lt1"/>
+          </a:fontRef>
+        </p:style>
+        <p:txBody>
+          <a:bodyPr rtlCol="0" anchor="ctr"/>
+          <a:lstStyle/>
+          <a:p>
+            <a:pPr algn="ctr"/>
+          </a:p>
+        </p:txBody>
+      </p:sp>
+      <p:sp>
+        <p:nvSpPr>
+          <p:cNvPr id="86" name="TextBox 85"/>
+          <p:cNvSpPr txBox="1"/>
+          <p:nvPr/>
+        </p:nvSpPr>
+        <p:spPr>
+          <a:xfrm>
+            <a:off x="594360" y="5824728"/>
+            <a:ext cx="1078992" cy="502920"/>
+          </a:xfrm>
+          <a:prstGeom prst="rect">
+            <a:avLst/>
+          </a:prstGeom>
+          <a:noFill/>
+        </p:spPr>
+        <p:txBody>
+          <a:bodyPr wrap="none">
+            <a:spAutoFit/>
+          </a:bodyPr>
+          <a:lstStyle/>
+          <a:p>
+            <a:pPr algn="ctr">
+              <a:defRPr sz="2800" b="1">
+                <a:solidFill>
                   <a:srgbClr val="16A34A"/>
                 </a:solidFill>
                 <a:latin typeface="Calibri"/>
               </a:defRPr>
             </a:pPr>
             <a:r>
+              <a:t>87.5%</a:t>
+            </a:r>
+          </a:p>
+        </p:txBody>
+      </p:sp>
+      <p:sp>
+        <p:nvSpPr>
+          <p:cNvPr id="87" name="TextBox 86"/>
+          <p:cNvSpPr txBox="1"/>
+          <p:nvPr/>
+        </p:nvSpPr>
+        <p:spPr>
+          <a:xfrm>
+            <a:off x="576072" y="6345936"/>
+            <a:ext cx="1115568" cy="411480"/>
+          </a:xfrm>
+          <a:prstGeom prst="rect">
+            <a:avLst/>
+          </a:prstGeom>
+          <a:noFill/>
+        </p:spPr>
+        <p:txBody>
+          <a:bodyPr wrap="none">
+            <a:spAutoFit/>
+          </a:bodyPr>
+          <a:lstStyle/>
+          <a:p>
+            <a:pPr algn="ctr">
+              <a:defRPr sz="1100" b="1">
+                <a:solidFill>
+                  <a:srgbClr val="16A34A"/>
+                </a:solidFill>
+                <a:latin typeface="Calibri"/>
+              </a:defRPr>
+            </a:pPr>
+            <a:r>
+              <a:t>Dev code</a:t>
+            </a:r>
+          </a:p>
+        </p:txBody>
+      </p:sp>
+      <p:sp>
+        <p:nvSpPr>
+          <p:cNvPr id="88" name="Rounded Rectangle 87"/>
+          <p:cNvSpPr/>
+          <p:nvPr/>
+        </p:nvSpPr>
+        <p:spPr>
+          <a:xfrm>
+            <a:off x="1856232" y="5687568"/>
+            <a:ext cx="1261872" cy="685800"/>
+          </a:xfrm>
+          <a:prstGeom prst="roundRect">
+            <a:avLst/>
+          </a:prstGeom>
+          <a:solidFill>
+            <a:srgbClr val="DCFCE7"/>
+          </a:solidFill>
+          <a:ln w="6350">
+            <a:solidFill>
+              <a:srgbClr val="E2E8F0"/>
+            </a:solidFill>
+          </a:ln>
+        </p:spPr>
+        <p:style>
+          <a:lnRef idx="1">
+            <a:schemeClr val="accent1"/>
+          </a:lnRef>
+          <a:fillRef idx="3">
+            <a:schemeClr val="accent1"/>
+          </a:fillRef>
+          <a:effectRef idx="2">
+            <a:schemeClr val="accent1"/>
+          </a:effectRef>
+          <a:fontRef idx="minor">
+            <a:schemeClr val="lt1"/>
+          </a:fontRef>
+        </p:style>
+        <p:txBody>
+          <a:bodyPr rtlCol="0" anchor="ctr"/>
+          <a:lstStyle/>
+          <a:p>
+            <a:pPr algn="ctr"/>
+          </a:p>
+        </p:txBody>
+      </p:sp>
+      <p:sp>
+        <p:nvSpPr>
+          <p:cNvPr id="89" name="TextBox 88"/>
+          <p:cNvSpPr txBox="1"/>
+          <p:nvPr/>
+        </p:nvSpPr>
+        <p:spPr>
+          <a:xfrm>
+            <a:off x="1947672" y="5824728"/>
+            <a:ext cx="1078992" cy="502920"/>
+          </a:xfrm>
+          <a:prstGeom prst="rect">
+            <a:avLst/>
+          </a:prstGeom>
+          <a:noFill/>
+        </p:spPr>
+        <p:txBody>
+          <a:bodyPr wrap="none">
+            <a:spAutoFit/>
+          </a:bodyPr>
+          <a:lstStyle/>
+          <a:p>
+            <a:pPr algn="ctr">
+              <a:defRPr sz="2800" b="1">
+                <a:solidFill>
+                  <a:srgbClr val="16A34A"/>
+                </a:solidFill>
+                <a:latin typeface="Calibri"/>
+              </a:defRPr>
+            </a:pPr>
+            <a:r>
+              <a:t>83.3%</a:t>
+            </a:r>
+          </a:p>
+        </p:txBody>
+      </p:sp>
+      <p:sp>
+        <p:nvSpPr>
+          <p:cNvPr id="90" name="TextBox 89"/>
+          <p:cNvSpPr txBox="1"/>
+          <p:nvPr/>
+        </p:nvSpPr>
+        <p:spPr>
+          <a:xfrm>
+            <a:off x="1929384" y="6345936"/>
+            <a:ext cx="1115568" cy="411480"/>
+          </a:xfrm>
+          <a:prstGeom prst="rect">
+            <a:avLst/>
+          </a:prstGeom>
+          <a:noFill/>
+        </p:spPr>
+        <p:txBody>
+          <a:bodyPr wrap="none">
+            <a:spAutoFit/>
+          </a:bodyPr>
+          <a:lstStyle/>
+          <a:p>
+            <a:pPr algn="ctr">
+              <a:defRPr sz="1100" b="1">
+                <a:solidFill>
+                  <a:srgbClr val="16A34A"/>
+                </a:solidFill>
+                <a:latin typeface="Calibri"/>
+              </a:defRPr>
+            </a:pPr>
+            <a:r>
+              <a:t>Dev tests</a:t>
+            </a:r>
+          </a:p>
+        </p:txBody>
+      </p:sp>
+      <p:sp>
+        <p:nvSpPr>
+          <p:cNvPr id="91" name="Rounded Rectangle 90"/>
+          <p:cNvSpPr/>
+          <p:nvPr/>
+        </p:nvSpPr>
+        <p:spPr>
+          <a:xfrm>
+            <a:off x="3209544" y="5687568"/>
+            <a:ext cx="1261872" cy="685800"/>
+          </a:xfrm>
+          <a:prstGeom prst="roundRect">
+            <a:avLst/>
+          </a:prstGeom>
+          <a:solidFill>
+            <a:srgbClr val="DCFCE7"/>
+          </a:solidFill>
+          <a:ln w="6350">
+            <a:solidFill>
+              <a:srgbClr val="E2E8F0"/>
+            </a:solidFill>
+          </a:ln>
+        </p:spPr>
+        <p:style>
+          <a:lnRef idx="1">
+            <a:schemeClr val="accent1"/>
+          </a:lnRef>
+          <a:fillRef idx="3">
+            <a:schemeClr val="accent1"/>
+          </a:fillRef>
+          <a:effectRef idx="2">
+            <a:schemeClr val="accent1"/>
+          </a:effectRef>
+          <a:fontRef idx="minor">
+            <a:schemeClr val="lt1"/>
+          </a:fontRef>
+        </p:style>
+        <p:txBody>
+          <a:bodyPr rtlCol="0" anchor="ctr"/>
+          <a:lstStyle/>
+          <a:p>
+            <a:pPr algn="ctr"/>
+          </a:p>
+        </p:txBody>
+      </p:sp>
+      <p:sp>
+        <p:nvSpPr>
+          <p:cNvPr id="92" name="TextBox 91"/>
+          <p:cNvSpPr txBox="1"/>
+          <p:nvPr/>
+        </p:nvSpPr>
+        <p:spPr>
+          <a:xfrm>
+            <a:off x="3300984" y="5824728"/>
+            <a:ext cx="1078992" cy="502920"/>
+          </a:xfrm>
+          <a:prstGeom prst="rect">
+            <a:avLst/>
+          </a:prstGeom>
+          <a:noFill/>
+        </p:spPr>
+        <p:txBody>
+          <a:bodyPr wrap="none">
+            <a:spAutoFit/>
+          </a:bodyPr>
+          <a:lstStyle/>
+          <a:p>
+            <a:pPr algn="ctr">
+              <a:defRPr sz="2800" b="1">
+                <a:solidFill>
+                  <a:srgbClr val="16A34A"/>
+                </a:solidFill>
+                <a:latin typeface="Calibri"/>
+              </a:defRPr>
+            </a:pPr>
+            <a:r>
+              <a:t>77.8%</a:t>
+            </a:r>
+          </a:p>
+        </p:txBody>
+      </p:sp>
+      <p:sp>
+        <p:nvSpPr>
+          <p:cNvPr id="93" name="TextBox 92"/>
+          <p:cNvSpPr txBox="1"/>
+          <p:nvPr/>
+        </p:nvSpPr>
+        <p:spPr>
+          <a:xfrm>
+            <a:off x="3282696" y="6345936"/>
+            <a:ext cx="1115568" cy="411480"/>
+          </a:xfrm>
+          <a:prstGeom prst="rect">
+            <a:avLst/>
+          </a:prstGeom>
+          <a:noFill/>
+        </p:spPr>
+        <p:txBody>
+          <a:bodyPr wrap="none">
+            <a:spAutoFit/>
+          </a:bodyPr>
+          <a:lstStyle/>
+          <a:p>
+            <a:pPr algn="ctr">
+              <a:defRPr sz="1100" b="1">
+                <a:solidFill>
+                  <a:srgbClr val="16A34A"/>
+                </a:solidFill>
+                <a:latin typeface="Calibri"/>
+              </a:defRPr>
+            </a:pPr>
+            <a:r>
+              <a:t>Test plan AC</a:t>
+            </a:r>
+          </a:p>
+        </p:txBody>
+      </p:sp>
+      <p:sp>
+        <p:nvSpPr>
+          <p:cNvPr id="94" name="Rounded Rectangle 93"/>
+          <p:cNvSpPr/>
+          <p:nvPr/>
+        </p:nvSpPr>
+        <p:spPr>
+          <a:xfrm>
+            <a:off x="4562856" y="5687568"/>
+            <a:ext cx="1261872" cy="685800"/>
+          </a:xfrm>
+          <a:prstGeom prst="roundRect">
+            <a:avLst/>
+          </a:prstGeom>
+          <a:solidFill>
+            <a:srgbClr val="DCFCE7"/>
+          </a:solidFill>
+          <a:ln w="6350">
+            <a:solidFill>
+              <a:srgbClr val="E2E8F0"/>
+            </a:solidFill>
+          </a:ln>
+        </p:spPr>
+        <p:style>
+          <a:lnRef idx="1">
+            <a:schemeClr val="accent1"/>
+          </a:lnRef>
+          <a:fillRef idx="3">
+            <a:schemeClr val="accent1"/>
+          </a:fillRef>
+          <a:effectRef idx="2">
+            <a:schemeClr val="accent1"/>
+          </a:effectRef>
+          <a:fontRef idx="minor">
+            <a:schemeClr val="lt1"/>
+          </a:fontRef>
+        </p:style>
+        <p:txBody>
+          <a:bodyPr rtlCol="0" anchor="ctr"/>
+          <a:lstStyle/>
+          <a:p>
+            <a:pPr algn="ctr"/>
+          </a:p>
+        </p:txBody>
+      </p:sp>
+      <p:sp>
+        <p:nvSpPr>
+          <p:cNvPr id="95" name="TextBox 94"/>
+          <p:cNvSpPr txBox="1"/>
+          <p:nvPr/>
+        </p:nvSpPr>
+        <p:spPr>
+          <a:xfrm>
+            <a:off x="4654296" y="5824728"/>
+            <a:ext cx="1078992" cy="502920"/>
+          </a:xfrm>
+          <a:prstGeom prst="rect">
+            <a:avLst/>
+          </a:prstGeom>
+          <a:noFill/>
+        </p:spPr>
+        <p:txBody>
+          <a:bodyPr wrap="none">
+            <a:spAutoFit/>
+          </a:bodyPr>
+          <a:lstStyle/>
+          <a:p>
+            <a:pPr algn="ctr">
+              <a:defRPr sz="2800" b="1">
+                <a:solidFill>
+                  <a:srgbClr val="16A34A"/>
+                </a:solidFill>
+                <a:latin typeface="Calibri"/>
+              </a:defRPr>
+            </a:pPr>
+            <a:r>
               <a:t>95.3%</a:t>
             </a:r>
           </a:p>
@@ -21841,13 +22914,13 @@
       </p:sp>
       <p:sp>
         <p:nvSpPr>
-          <p:cNvPr id="73" name="TextBox 72"/>
-          <p:cNvSpPr txBox="1"/>
-          <p:nvPr/>
-        </p:nvSpPr>
-        <p:spPr>
-          <a:xfrm>
-            <a:off x="10213848" y="5367528"/>
+          <p:cNvPr id="96" name="TextBox 95"/>
+          <p:cNvSpPr txBox="1"/>
+          <p:nvPr/>
+        </p:nvSpPr>
+        <p:spPr>
+          <a:xfrm>
+            <a:off x="4636008" y="6345936"/>
             <a:ext cx="1115568" cy="411480"/>
           </a:xfrm>
           <a:prstGeom prst="rect">
@@ -22566,7 +23639,7 @@
               </a:defRPr>
             </a:pPr>
             <a:r>
-              <a:t>MSC-205625</a:t>
+              <a:t>MSC-212571</a:t>
             </a:r>
           </a:p>
         </p:txBody>
@@ -22621,7 +23694,7 @@
               </a:defRPr>
             </a:pPr>
             <a:r>
-              <a:t>Bug · Ready for Release</a:t>
+              <a:t>Story · In QA</a:t>
             </a:r>
           </a:p>
         </p:txBody>
@@ -22676,7 +23749,7 @@
               </a:defRPr>
             </a:pPr>
             <a:r>
-              <a:t>100%</a:t>
+              <a:t>100.0%</a:t>
             </a:r>
           </a:p>
         </p:txBody>
@@ -22731,7 +23804,7 @@
               </a:defRPr>
             </a:pPr>
             <a:r>
-              <a:t>75%</a:t>
+              <a:t>5.6%</a:t>
             </a:r>
           </a:p>
         </p:txBody>
@@ -22786,7 +23859,7 @@
               </a:defRPr>
             </a:pPr>
             <a:r>
-              <a:t>75%</a:t>
+              <a:t>66.7%</a:t>
             </a:r>
           </a:p>
         </p:txBody>
@@ -22841,7 +23914,7 @@
               </a:defRPr>
             </a:pPr>
             <a:r>
-              <a:t>Pass w/ gaps</a:t>
+              <a:t>Fail</a:t>
             </a:r>
           </a:p>
         </p:txBody>
@@ -22896,7 +23969,7 @@
               </a:defRPr>
             </a:pPr>
             <a:r>
-              <a:t>PR #161 pick-genie · MERGED · CI Passed · …</a:t>
+              <a:t>Confluence DirecTV spec · PR #99 partner-c…</a:t>
             </a:r>
           </a:p>
         </p:txBody>
@@ -22951,7 +24024,7 @@
               </a:defRPr>
             </a:pPr>
             <a:r>
-              <a:t>MSC-204417</a:t>
+              <a:t>MSC-205625</a:t>
             </a:r>
           </a:p>
         </p:txBody>
@@ -23006,7 +24079,7 @@
               </a:defRPr>
             </a:pPr>
             <a:r>
-              <a:t>Story · In QA</a:t>
+              <a:t>Bug · Ready for Release</a:t>
             </a:r>
           </a:p>
         </p:txBody>
@@ -23055,13 +24128,13 @@
             <a:pPr algn="ctr">
               <a:defRPr sz="800" b="0">
                 <a:solidFill>
-                  <a:srgbClr val="16A34A"/>
-                </a:solidFill>
-                <a:latin typeface="Calibri"/>
-              </a:defRPr>
-            </a:pPr>
-            <a:r>
-              <a:t>100%</a:t>
+                  <a:srgbClr val="D97706"/>
+                </a:solidFill>
+                <a:latin typeface="Calibri"/>
+              </a:defRPr>
+            </a:pPr>
+            <a:r>
+              <a:t>87.5%</a:t>
             </a:r>
           </a:p>
         </p:txBody>
@@ -23171,7 +24244,7 @@
               </a:defRPr>
             </a:pPr>
             <a:r>
-              <a:t>94.1%</a:t>
+              <a:t>77.8%</a:t>
             </a:r>
           </a:p>
         </p:txBody>
@@ -23226,7 +24299,7 @@
               </a:defRPr>
             </a:pPr>
             <a:r>
-              <a:t>Pass w/ gaps</a:t>
+              <a:t>Fail</a:t>
             </a:r>
           </a:p>
         </p:txBody>
@@ -23281,7 +24354,7 @@
               </a:defRPr>
             </a:pPr>
             <a:r>
-              <a:t>Confluence LADR requirements · No PR · dev…</a:t>
+              <a:t>Passport wiki LADR (5 scenarios) · PR #161…</a:t>
             </a:r>
           </a:p>
         </p:txBody>
@@ -23336,7 +24409,7 @@
               </a:defRPr>
             </a:pPr>
             <a:r>
-              <a:t>MSC-195138</a:t>
+              <a:t>MSC-204417</a:t>
             </a:r>
           </a:p>
         </p:txBody>
@@ -23391,7 +24464,7 @@
               </a:defRPr>
             </a:pPr>
             <a:r>
-              <a:t>Story · Done</a:t>
+              <a:t>Story · In QA</a:t>
             </a:r>
           </a:p>
         </p:txBody>
@@ -23440,13 +24513,13 @@
             <a:pPr algn="ctr">
               <a:defRPr sz="800" b="0">
                 <a:solidFill>
-                  <a:srgbClr val="D97706"/>
-                </a:solidFill>
-                <a:latin typeface="Calibri"/>
-              </a:defRPr>
-            </a:pPr>
-            <a:r>
-              <a:t>83.3%</a:t>
+                  <a:srgbClr val="16A34A"/>
+                </a:solidFill>
+                <a:latin typeface="Calibri"/>
+              </a:defRPr>
+            </a:pPr>
+            <a:r>
+              <a:t>100.0%</a:t>
             </a:r>
           </a:p>
         </p:txBody>
@@ -23556,7 +24629,7 @@
               </a:defRPr>
             </a:pPr>
             <a:r>
-              <a:t>66.7%</a:t>
+              <a:t>94.1%</a:t>
             </a:r>
           </a:p>
         </p:txBody>
@@ -23611,7 +24684,7 @@
               </a:defRPr>
             </a:pPr>
             <a:r>
-              <a:t>Pass w/ gaps</a:t>
+              <a:t>Fail</a:t>
             </a:r>
           </a:p>
         </p:txBody>
@@ -23666,7 +24739,392 @@
               </a:defRPr>
             </a:pPr>
             <a:r>
-              <a:t>PRs #22 + #75 · MERGED · FF Race · 11/11 G…</a:t>
+              <a:t>ESS + caption LADR · No PR · develop branc…</a:t>
+            </a:r>
+          </a:p>
+        </p:txBody>
+      </p:sp>
+      <p:sp>
+        <p:nvSpPr>
+          <p:cNvPr id="36" name="Rectangle 35"/>
+          <p:cNvSpPr/>
+          <p:nvPr/>
+        </p:nvSpPr>
+        <p:spPr>
+          <a:xfrm>
+            <a:off x="502920" y="3118104"/>
+            <a:ext cx="1508760" cy="438912"/>
+          </a:xfrm>
+          <a:prstGeom prst="rect">
+            <a:avLst/>
+          </a:prstGeom>
+          <a:solidFill>
+            <a:srgbClr val="F2F2F2"/>
+          </a:solidFill>
+          <a:ln w="6350">
+            <a:solidFill>
+              <a:srgbClr val="E2E8F0"/>
+            </a:solidFill>
+          </a:ln>
+        </p:spPr>
+        <p:style>
+          <a:lnRef idx="1">
+            <a:schemeClr val="accent1"/>
+          </a:lnRef>
+          <a:fillRef idx="3">
+            <a:schemeClr val="accent1"/>
+          </a:fillRef>
+          <a:effectRef idx="2">
+            <a:schemeClr val="accent1"/>
+          </a:effectRef>
+          <a:fontRef idx="minor">
+            <a:schemeClr val="lt1"/>
+          </a:fontRef>
+        </p:style>
+        <p:txBody>
+          <a:bodyPr rtlCol="0" anchor="ctr" wrap="square"/>
+          <a:lstStyle/>
+          <a:p>
+            <a:pPr algn="ctr">
+              <a:defRPr sz="800" b="1">
+                <a:solidFill>
+                  <a:srgbClr val="1A1A1A"/>
+                </a:solidFill>
+                <a:latin typeface="Calibri"/>
+              </a:defRPr>
+            </a:pPr>
+            <a:r>
+              <a:t>MSC-195138</a:t>
+            </a:r>
+          </a:p>
+        </p:txBody>
+      </p:sp>
+      <p:sp>
+        <p:nvSpPr>
+          <p:cNvPr id="37" name="Rectangle 36"/>
+          <p:cNvSpPr/>
+          <p:nvPr/>
+        </p:nvSpPr>
+        <p:spPr>
+          <a:xfrm>
+            <a:off x="2103120" y="3118104"/>
+            <a:ext cx="1508760" cy="438912"/>
+          </a:xfrm>
+          <a:prstGeom prst="rect">
+            <a:avLst/>
+          </a:prstGeom>
+          <a:solidFill>
+            <a:srgbClr val="F2F2F2"/>
+          </a:solidFill>
+          <a:ln w="6350">
+            <a:solidFill>
+              <a:srgbClr val="E2E8F0"/>
+            </a:solidFill>
+          </a:ln>
+        </p:spPr>
+        <p:style>
+          <a:lnRef idx="1">
+            <a:schemeClr val="accent1"/>
+          </a:lnRef>
+          <a:fillRef idx="3">
+            <a:schemeClr val="accent1"/>
+          </a:fillRef>
+          <a:effectRef idx="2">
+            <a:schemeClr val="accent1"/>
+          </a:effectRef>
+          <a:fontRef idx="minor">
+            <a:schemeClr val="lt1"/>
+          </a:fontRef>
+        </p:style>
+        <p:txBody>
+          <a:bodyPr rtlCol="0" anchor="ctr" wrap="square"/>
+          <a:lstStyle/>
+          <a:p>
+            <a:pPr algn="ctr">
+              <a:defRPr sz="800" b="0">
+                <a:solidFill>
+                  <a:srgbClr val="1A1A1A"/>
+                </a:solidFill>
+                <a:latin typeface="Calibri"/>
+              </a:defRPr>
+            </a:pPr>
+            <a:r>
+              <a:t>Story · Done</a:t>
+            </a:r>
+          </a:p>
+        </p:txBody>
+      </p:sp>
+      <p:sp>
+        <p:nvSpPr>
+          <p:cNvPr id="38" name="Rectangle 37"/>
+          <p:cNvSpPr/>
+          <p:nvPr/>
+        </p:nvSpPr>
+        <p:spPr>
+          <a:xfrm>
+            <a:off x="3703320" y="3118104"/>
+            <a:ext cx="1508760" cy="438912"/>
+          </a:xfrm>
+          <a:prstGeom prst="rect">
+            <a:avLst/>
+          </a:prstGeom>
+          <a:solidFill>
+            <a:srgbClr val="F2F2F2"/>
+          </a:solidFill>
+          <a:ln w="6350">
+            <a:solidFill>
+              <a:srgbClr val="E2E8F0"/>
+            </a:solidFill>
+          </a:ln>
+        </p:spPr>
+        <p:style>
+          <a:lnRef idx="1">
+            <a:schemeClr val="accent1"/>
+          </a:lnRef>
+          <a:fillRef idx="3">
+            <a:schemeClr val="accent1"/>
+          </a:fillRef>
+          <a:effectRef idx="2">
+            <a:schemeClr val="accent1"/>
+          </a:effectRef>
+          <a:fontRef idx="minor">
+            <a:schemeClr val="lt1"/>
+          </a:fontRef>
+        </p:style>
+        <p:txBody>
+          <a:bodyPr rtlCol="0" anchor="ctr" wrap="square"/>
+          <a:lstStyle/>
+          <a:p>
+            <a:pPr algn="ctr">
+              <a:defRPr sz="800" b="0">
+                <a:solidFill>
+                  <a:srgbClr val="D97706"/>
+                </a:solidFill>
+                <a:latin typeface="Calibri"/>
+              </a:defRPr>
+            </a:pPr>
+            <a:r>
+              <a:t>83.3%</a:t>
+            </a:r>
+          </a:p>
+        </p:txBody>
+      </p:sp>
+      <p:sp>
+        <p:nvSpPr>
+          <p:cNvPr id="39" name="Rectangle 38"/>
+          <p:cNvSpPr/>
+          <p:nvPr/>
+        </p:nvSpPr>
+        <p:spPr>
+          <a:xfrm>
+            <a:off x="5303520" y="3118104"/>
+            <a:ext cx="1508760" cy="438912"/>
+          </a:xfrm>
+          <a:prstGeom prst="rect">
+            <a:avLst/>
+          </a:prstGeom>
+          <a:solidFill>
+            <a:srgbClr val="F2F2F2"/>
+          </a:solidFill>
+          <a:ln w="6350">
+            <a:solidFill>
+              <a:srgbClr val="E2E8F0"/>
+            </a:solidFill>
+          </a:ln>
+        </p:spPr>
+        <p:style>
+          <a:lnRef idx="1">
+            <a:schemeClr val="accent1"/>
+          </a:lnRef>
+          <a:fillRef idx="3">
+            <a:schemeClr val="accent1"/>
+          </a:fillRef>
+          <a:effectRef idx="2">
+            <a:schemeClr val="accent1"/>
+          </a:effectRef>
+          <a:fontRef idx="minor">
+            <a:schemeClr val="lt1"/>
+          </a:fontRef>
+        </p:style>
+        <p:txBody>
+          <a:bodyPr rtlCol="0" anchor="ctr" wrap="square"/>
+          <a:lstStyle/>
+          <a:p>
+            <a:pPr algn="ctr">
+              <a:defRPr sz="800" b="0">
+                <a:solidFill>
+                  <a:srgbClr val="D97706"/>
+                </a:solidFill>
+                <a:latin typeface="Calibri"/>
+              </a:defRPr>
+            </a:pPr>
+            <a:r>
+              <a:t>83.3%</a:t>
+            </a:r>
+          </a:p>
+        </p:txBody>
+      </p:sp>
+      <p:sp>
+        <p:nvSpPr>
+          <p:cNvPr id="40" name="Rectangle 39"/>
+          <p:cNvSpPr/>
+          <p:nvPr/>
+        </p:nvSpPr>
+        <p:spPr>
+          <a:xfrm>
+            <a:off x="6903720" y="3118104"/>
+            <a:ext cx="1508760" cy="438912"/>
+          </a:xfrm>
+          <a:prstGeom prst="rect">
+            <a:avLst/>
+          </a:prstGeom>
+          <a:solidFill>
+            <a:srgbClr val="F2F2F2"/>
+          </a:solidFill>
+          <a:ln w="6350">
+            <a:solidFill>
+              <a:srgbClr val="E2E8F0"/>
+            </a:solidFill>
+          </a:ln>
+        </p:spPr>
+        <p:style>
+          <a:lnRef idx="1">
+            <a:schemeClr val="accent1"/>
+          </a:lnRef>
+          <a:fillRef idx="3">
+            <a:schemeClr val="accent1"/>
+          </a:fillRef>
+          <a:effectRef idx="2">
+            <a:schemeClr val="accent1"/>
+          </a:effectRef>
+          <a:fontRef idx="minor">
+            <a:schemeClr val="lt1"/>
+          </a:fontRef>
+        </p:style>
+        <p:txBody>
+          <a:bodyPr rtlCol="0" anchor="ctr" wrap="square"/>
+          <a:lstStyle/>
+          <a:p>
+            <a:pPr algn="ctr">
+              <a:defRPr sz="800" b="0">
+                <a:solidFill>
+                  <a:srgbClr val="D97706"/>
+                </a:solidFill>
+                <a:latin typeface="Calibri"/>
+              </a:defRPr>
+            </a:pPr>
+            <a:r>
+              <a:t>66.7%</a:t>
+            </a:r>
+          </a:p>
+        </p:txBody>
+      </p:sp>
+      <p:sp>
+        <p:nvSpPr>
+          <p:cNvPr id="41" name="Rectangle 40"/>
+          <p:cNvSpPr/>
+          <p:nvPr/>
+        </p:nvSpPr>
+        <p:spPr>
+          <a:xfrm>
+            <a:off x="8503920" y="3118104"/>
+            <a:ext cx="1508760" cy="438912"/>
+          </a:xfrm>
+          <a:prstGeom prst="rect">
+            <a:avLst/>
+          </a:prstGeom>
+          <a:solidFill>
+            <a:srgbClr val="F2F2F2"/>
+          </a:solidFill>
+          <a:ln w="6350">
+            <a:solidFill>
+              <a:srgbClr val="E2E8F0"/>
+            </a:solidFill>
+          </a:ln>
+        </p:spPr>
+        <p:style>
+          <a:lnRef idx="1">
+            <a:schemeClr val="accent1"/>
+          </a:lnRef>
+          <a:fillRef idx="3">
+            <a:schemeClr val="accent1"/>
+          </a:fillRef>
+          <a:effectRef idx="2">
+            <a:schemeClr val="accent1"/>
+          </a:effectRef>
+          <a:fontRef idx="minor">
+            <a:schemeClr val="lt1"/>
+          </a:fontRef>
+        </p:style>
+        <p:txBody>
+          <a:bodyPr rtlCol="0" anchor="ctr" wrap="square"/>
+          <a:lstStyle/>
+          <a:p>
+            <a:pPr algn="ctr">
+              <a:defRPr sz="800" b="0">
+                <a:solidFill>
+                  <a:srgbClr val="D97706"/>
+                </a:solidFill>
+                <a:latin typeface="Calibri"/>
+              </a:defRPr>
+            </a:pPr>
+            <a:r>
+              <a:t>Fail</a:t>
+            </a:r>
+          </a:p>
+        </p:txBody>
+      </p:sp>
+      <p:sp>
+        <p:nvSpPr>
+          <p:cNvPr id="42" name="Rectangle 41"/>
+          <p:cNvSpPr/>
+          <p:nvPr/>
+        </p:nvSpPr>
+        <p:spPr>
+          <a:xfrm>
+            <a:off x="10104120" y="3118104"/>
+            <a:ext cx="1508760" cy="438912"/>
+          </a:xfrm>
+          <a:prstGeom prst="rect">
+            <a:avLst/>
+          </a:prstGeom>
+          <a:solidFill>
+            <a:srgbClr val="F2F2F2"/>
+          </a:solidFill>
+          <a:ln w="6350">
+            <a:solidFill>
+              <a:srgbClr val="E2E8F0"/>
+            </a:solidFill>
+          </a:ln>
+        </p:spPr>
+        <p:style>
+          <a:lnRef idx="1">
+            <a:schemeClr val="accent1"/>
+          </a:lnRef>
+          <a:fillRef idx="3">
+            <a:schemeClr val="accent1"/>
+          </a:fillRef>
+          <a:effectRef idx="2">
+            <a:schemeClr val="accent1"/>
+          </a:effectRef>
+          <a:fontRef idx="minor">
+            <a:schemeClr val="lt1"/>
+          </a:fontRef>
+        </p:style>
+        <p:txBody>
+          <a:bodyPr rtlCol="0" anchor="ctr" wrap="square"/>
+          <a:lstStyle/>
+          <a:p>
+            <a:pPr algn="ctr">
+              <a:defRPr sz="800" b="0">
+                <a:solidFill>
+                  <a:srgbClr val="334155"/>
+                </a:solidFill>
+                <a:latin typeface="Calibri"/>
+              </a:defRPr>
+            </a:pPr>
+            <a:r>
+              <a:t>PRs #22 reps · #75 texttransform MERGED · …</a:t>
             </a:r>
           </a:p>
         </p:txBody>
@@ -29827,7 +31285,7 @@
               </a:defRPr>
             </a:pPr>
             <a:r>
-              <a:t>/msc-dev-code-and-qa-test-coverage-validator MSC-205625   ·   --from-cache --auto</a:t>
+              <a:t>/msc-dev-code-and-qa-test-coverage-validator MSC-212571   ·   --auto --write</a:t>
             </a:r>
           </a:p>
         </p:txBody>
@@ -30083,7 +31541,7 @@
               </a:defRPr>
             </a:pPr>
             <a:r>
-              <a:t>End-to-end in ~2–5 minutes · Jira MCP + Confluence LADR + cached GitHub prefetch</a:t>
+              <a:t>Slash command --auto --write · ~2–5 min · one MCP turn + batched shells</a:t>
             </a:r>
           </a:p>
         </p:txBody>
@@ -30236,12 +31694,12 @@
               </a:defRPr>
             </a:pPr>
             <a:r>
-              <a:t>Story, AC,</a:t>
-            </a:r>
-          </a:p>
-          <a:p>
-            <a:r>
-              <a:t>attachments, LADR</a:t>
+              <a:t>Parallel MCP:</a:t>
+            </a:r>
+          </a:p>
+          <a:p>
+            <a:r>
+              <a:t>issue + remote</a:t>
             </a:r>
           </a:p>
           <a:p>
@@ -30442,17 +31900,12 @@
               </a:defRPr>
             </a:pPr>
             <a:r>
-              <a:t>getConfluencePage</a:t>
-            </a:r>
-          </a:p>
-          <a:p>
-            <a:r>
-              <a:t>LADR requirements</a:t>
-            </a:r>
-          </a:p>
-          <a:p>
-            <a:r>
-              <a:t>L1…Ln</a:t>
+              <a:t>LADR ESS or</a:t>
+            </a:r>
+          </a:p>
+          <a:p>
+            <a:r>
+              <a:t>passport scenarios</a:t>
             </a:r>
           </a:p>
         </p:txBody>
@@ -30648,17 +32101,12 @@
               </a:defRPr>
             </a:pPr>
             <a:r>
-              <a:t>Excel xlsx,</a:t>
-            </a:r>
-          </a:p>
-          <a:p>
-            <a:r>
-              <a:t>Given/When/Then,</a:t>
-            </a:r>
-          </a:p>
-          <a:p>
-            <a:r>
-              <a:t>semantic map</a:t>
+              <a:t>Excel attach,</a:t>
+            </a:r>
+          </a:p>
+          <a:p>
+            <a:r>
+              <a:t>GWT, Evidence</a:t>
             </a:r>
           </a:p>
         </p:txBody>
@@ -30854,12 +32302,12 @@
               </a:defRPr>
             </a:pPr>
             <a:r>
-              <a:t>PR diff,</a:t>
-            </a:r>
-          </a:p>
-          <a:p>
-            <a:r>
-              <a:t>checks, CI</a:t>
+              <a:t>prefetch PR(s)</a:t>
+            </a:r>
+          </a:p>
+          <a:p>
+            <a:r>
+              <a:t>or branch compare</a:t>
             </a:r>
           </a:p>
         </p:txBody>
@@ -31055,12 +32503,12 @@
               </a:defRPr>
             </a:pPr>
             <a:r>
-              <a:t>R1…Rn +</a:t>
-            </a:r>
-          </a:p>
-          <a:p>
-            <a:r>
-              <a:t>LADR → TCs</a:t>
+              <a:t>map_requirements_</a:t>
+            </a:r>
+          </a:p>
+          <a:p>
+            <a:r>
+              <a:t>to_diff.py</a:t>
             </a:r>
           </a:p>
         </p:txBody>
@@ -31256,12 +32704,12 @@
               </a:defRPr>
             </a:pPr>
             <a:r>
-              <a:t>HTML + tooltips</a:t>
-            </a:r>
-          </a:p>
-          <a:p>
-            <a:r>
-              <a:t>+ footer credit</a:t>
+              <a:t>build_coverage_</a:t>
+            </a:r>
+          </a:p>
+          <a:p>
+            <a:r>
+              <a:t>report.py + tooltips</a:t>
             </a:r>
           </a:p>
         </p:txBody>
@@ -31342,7 +32790,7 @@
               </a:defRPr>
             </a:pPr>
             <a:r>
-              <a:t>Performance: reports/.cache/ stores Jira, Confluence LADR, test plan, and GitHub prefetch — reuse with --from-cache --auto. When Jira comments reference LADR or wiki URLs, fetch_confluence_requirements.py (or getConfluencePage MCP) merges Confluence LADR requirements with Jira AC before test plan scoring.</a:t>
+              <a:t>Cache: reports/.cache/{KEY}-jira|confluence|testplan|prefetch|mapping.json — reuse --from-cache. No linked PR? fetch_coverage_github.py --compare develop + branchCompare mapping. Verdict: Fail only when gap_summary has ≥1 High (not “0 High · N Med”). build_coverage_report.py fills CI {{CI_*}} and Dev tests columns automatically.</a:t>
             </a:r>
           </a:p>
         </p:txBody>

</xml_diff>

<commit_message>
Sync agents, skills, docs: coverage-validator testcase writer pipeline updates
Co-authored-by: Cursor <cursoragent@cursor.com>
</commit_message>
<xml_diff>
--- a/docs/MSC-Dev-Code-and-QA-Test-Coverage-Validator-Guide.pptx
+++ b/docs/MSC-Dev-Code-and-QA-Test-Coverage-Validator-Guide.pptx
@@ -6626,7 +6626,7 @@
               </a:defRPr>
             </a:pPr>
             <a:r>
-              <a:t>©LTM  |  Privileged and Confidential  |  MSC Dev Code and QA Test Coverage Validator  |  Developed by Mayur Gunjal</a:t>
+              <a:t>Â©LTM  |  Privileged and Confidential  |  MSC Dev Code and QA Test Coverage Validator  |  Developed by Mayur Gunjal</a:t>
             </a:r>
           </a:p>
         </p:txBody>
@@ -6741,7 +6741,7 @@
               </a:defRPr>
             </a:pPr>
             <a:r>
-              <a:t>Enablement — one-time setup (~10 min)</a:t>
+              <a:t>Enablement â€” one-time setup (~10 min)</a:t>
             </a:r>
           </a:p>
         </p:txBody>
@@ -6777,7 +6777,7 @@
               </a:defRPr>
             </a:pPr>
             <a:r>
-              <a:t>Clone lab → MCP → gh → permissions → optional .env</a:t>
+              <a:t>Clone lab â†’ MCP â†’ gh â†’ permissions â†’ optional .env</a:t>
             </a:r>
           </a:p>
         </p:txBody>
@@ -6874,7 +6874,7 @@
               </a:defRPr>
             </a:pPr>
             <a:r>
-              <a:t>✓</a:t>
+              <a:t>âœ“</a:t>
             </a:r>
           </a:p>
         </p:txBody>
@@ -7043,7 +7043,7 @@
               </a:defRPr>
             </a:pPr>
             <a:r>
-              <a:t>✓</a:t>
+              <a:t>âœ“</a:t>
             </a:r>
           </a:p>
         </p:txBody>
@@ -7212,7 +7212,7 @@
               </a:defRPr>
             </a:pPr>
             <a:r>
-              <a:t>✓</a:t>
+              <a:t>âœ“</a:t>
             </a:r>
           </a:p>
         </p:txBody>
@@ -7381,7 +7381,7 @@
               </a:defRPr>
             </a:pPr>
             <a:r>
-              <a:t>✓</a:t>
+              <a:t>âœ“</a:t>
             </a:r>
           </a:p>
         </p:txBody>
@@ -7550,7 +7550,7 @@
               </a:defRPr>
             </a:pPr>
             <a:r>
-              <a:t>✓</a:t>
+              <a:t>âœ“</a:t>
             </a:r>
           </a:p>
         </p:txBody>
@@ -7719,7 +7719,7 @@
               </a:defRPr>
             </a:pPr>
             <a:r>
-              <a:t>✓</a:t>
+              <a:t>âœ“</a:t>
             </a:r>
           </a:p>
         </p:txBody>
@@ -7827,7 +7827,7 @@
               </a:defRPr>
             </a:pPr>
             <a:r>
-              <a:t>Scripts (batched — no manual gh per run):</a:t>
+              <a:t>Scripts (batched â€” no manual gh per run):</a:t>
             </a:r>
           </a:p>
           <a:p>
@@ -7840,7 +7840,7 @@
               </a:defRPr>
             </a:pPr>
             <a:r>
-              <a:t>fetch_confluence_requirements.py  ·  fetch_jira_testplan.py  ·  prefetch_coverage_inputs.py</a:t>
+              <a:t>fetch_confluence_requirements.py  Â·  fetch_jira_testplan.py  Â·  prefetch_coverage_inputs.py</a:t>
             </a:r>
           </a:p>
           <a:p>
@@ -7853,7 +7853,7 @@
               </a:defRPr>
             </a:pPr>
             <a:r>
-              <a:t>map_requirements_to_diff.py  ·  build_coverage_report.py  ·  apply_report_ui_enhancements()</a:t>
+              <a:t>map_requirements_to_diff.py  Â·  build_coverage_report.py  Â·  apply_report_ui_enhancements()</a:t>
             </a:r>
           </a:p>
           <a:p>
@@ -7866,7 +7866,7 @@
               </a:defRPr>
             </a:pPr>
             <a:r>
-              <a:t>sync_pegasus_qa_agents_lab.py → push to github.com/mgunjal11/pegasus-qa-agents-lab</a:t>
+              <a:t>sync_pegasus_qa_agents_lab.py â†’ push to github.com/mgunjal11/pegasus-qa-agents-lab</a:t>
             </a:r>
           </a:p>
         </p:txBody>
@@ -7971,7 +7971,7 @@
               </a:defRPr>
             </a:pPr>
             <a:r>
-              <a:t>©LTM  |  Privileged and Confidential  |  MSC Dev Code and QA Test Coverage Validator  |  Developed by Mayur Gunjal</a:t>
+              <a:t>Â©LTM  |  Privileged and Confidential  |  MSC Dev Code and QA Test Coverage Validator  |  Developed by Mayur Gunjal</a:t>
             </a:r>
           </a:p>
         </p:txBody>
@@ -8086,7 +8086,7 @@
               </a:defRPr>
             </a:pPr>
             <a:r>
-              <a:t>MSC-205625 — Live coverage validation report</a:t>
+              <a:t>MSC-205625 â€” Live coverage validation report</a:t>
             </a:r>
           </a:p>
         </p:txBody>
@@ -8122,7 +8122,7 @@
               </a:defRPr>
             </a:pPr>
             <a:r>
-              <a:t>[PFT Clear] Content passport dropped from cumulative output manif…</a:t>
+              <a:t>[PFT Clear] Content passport dropped from cumulative output manifâ€¦</a:t>
             </a:r>
           </a:p>
         </p:txBody>
@@ -8697,7 +8697,7 @@
               </a:defRPr>
             </a:pPr>
             <a:r>
-              <a:t>Report walkthrough — 8 sections</a:t>
+              <a:t>Report walkthrough â€” 8 sections</a:t>
             </a:r>
           </a:p>
         </p:txBody>
@@ -9048,7 +9048,7 @@
               </a:defRPr>
             </a:pPr>
             <a:r>
-              <a:t>Attached test plan validatio…</a:t>
+              <a:t>Attached test plan validatioâ€¦</a:t>
             </a:r>
           </a:p>
         </p:txBody>
@@ -9516,7 +9516,7 @@
               </a:defRPr>
             </a:pPr>
             <a:r>
-              <a:t>Assumptions and open questio…</a:t>
+              <a:t>Assumptions and open questioâ€¦</a:t>
             </a:r>
           </a:p>
         </p:txBody>
@@ -9696,7 +9696,7 @@
               </a:defRPr>
             </a:pPr>
             <a:r>
-              <a:t>✓ Jira readiness</a:t>
+              <a:t>âœ“ Jira readiness</a:t>
             </a:r>
           </a:p>
           <a:p>
@@ -9712,7 +9712,7 @@
               </a:defRPr>
             </a:pPr>
             <a:r>
-              <a:t>  ✓ ✓Acceptance criteriaiAbout Acceptance criteriaNumbered requirements (R1, R2, …) extracted </a:t>
+              <a:t>  âœ“ ✓Acceptance criteriaiAbout Acceptance criteriaNumbered requirements (R1, R2, …) extracted </a:t>
             </a:r>
           </a:p>
           <a:p>
@@ -9728,7 +9728,7 @@
               </a:defRPr>
             </a:pPr>
             <a:r>
-              <a:t>  ✓ ✓GitHub PRiAbout GitHub PRPull requests linked in Jira or discovered during prefetch — sou</a:t>
+              <a:t>  âœ“ ✓GitHub PRiAbout GitHub PRPull requests linked in Jira or discovered during prefetch — sou</a:t>
             </a:r>
           </a:p>
           <a:p>
@@ -9744,7 +9744,7 @@
               </a:defRPr>
             </a:pPr>
             <a:r>
-              <a:t>  ✓ ✓Test planiAbout Test planQMetry Excel attachment parsed for scenarios, Given/When/Then st</a:t>
+              <a:t>  âœ“ ✓Test planiAbout Test planQMetry Excel attachment parsed for scenarios, Given/When/Then st</a:t>
             </a:r>
           </a:p>
           <a:p>
@@ -9760,7 +9760,7 @@
               </a:defRPr>
             </a:pPr>
             <a:r>
-              <a:t>  ✓ ✓Confluence / LADRiAbout Confluence / LADROptional Confluence design page for LADR (L1, L2</a:t>
+              <a:t>  âœ“ ✓Confluence / LADRiAbout Confluence / LADROptional Confluence design page for LADR (L1, L2</a:t>
             </a:r>
           </a:p>
         </p:txBody>
@@ -9796,7 +9796,7 @@
               </a:defRPr>
             </a:pPr>
             <a:r>
-              <a:t>Source: MSC-205625-06-09-2026-14-05-59-IST.html</a:t>
+              <a:t>Source: MSC-205625-06-09-2026-19-17-40-IST.html</a:t>
             </a:r>
           </a:p>
           <a:p>
@@ -10016,7 +10016,7 @@
               </a:defRPr>
             </a:pPr>
             <a:r>
-              <a:t>MSC-205625 · live HTML report section</a:t>
+              <a:t>MSC-205625 Â· live HTML report section</a:t>
             </a:r>
           </a:p>
         </p:txBody>
@@ -10095,7 +10095,7 @@
               </a:defRPr>
             </a:pPr>
             <a:r>
-              <a:t>©LTM  |  Privileged and Confidential  |  MSC Dev Code and QA Test Coverage Validator  |  Developed by Mayur Gunjal</a:t>
+              <a:t>Â©LTM  |  Privileged and Confidential  |  MSC Dev Code and QA Test Coverage Validator  |  Developed by Mayur Gunjal</a:t>
             </a:r>
           </a:p>
         </p:txBody>
@@ -10212,7 +10212,7 @@
               </a:defRPr>
             </a:pPr>
             <a:r>
-              <a:t>81%</a:t>
+              <a:t>81% — Weighted: dev code, dev tests, test plan, gaps</a:t>
             </a:r>
           </a:p>
         </p:txBody>
@@ -10255,43 +10255,7 @@
       </p:sp>
       <p:sp>
         <p:nvSpPr>
-          <p:cNvPr id="12" name="TextBox 11"/>
-          <p:cNvSpPr txBox="1"/>
-          <p:nvPr/>
-        </p:nvSpPr>
-        <p:spPr>
-          <a:xfrm>
-            <a:off x="2697480" y="1737360"/>
-            <a:ext cx="7772400" cy="365760"/>
-          </a:xfrm>
-          <a:prstGeom prst="rect">
-            <a:avLst/>
-          </a:prstGeom>
-          <a:noFill/>
-        </p:spPr>
-        <p:txBody>
-          <a:bodyPr wrap="none">
-            <a:spAutoFit/>
-          </a:bodyPr>
-          <a:lstStyle/>
-          <a:p>
-            <a:pPr>
-              <a:defRPr sz="900">
-                <a:solidFill>
-                  <a:srgbClr val="94A3B8"/>
-                </a:solidFill>
-                <a:latin typeface="Calibri"/>
-              </a:defRPr>
-            </a:pPr>
-            <a:r>
-              <a:t>Weighted: dev code, dev tests, test plan, gaps</a:t>
-            </a:r>
-          </a:p>
-        </p:txBody>
-      </p:sp>
-      <p:sp>
-        <p:nvSpPr>
-          <p:cNvPr id="13" name="Rounded Rectangle 12"/>
+          <p:cNvPr id="12" name="Rounded Rectangle 11"/>
           <p:cNvSpPr/>
           <p:nvPr/>
         </p:nvSpPr>
@@ -10346,7 +10310,7 @@
       </p:sp>
       <p:sp>
         <p:nvSpPr>
-          <p:cNvPr id="14" name="Rounded Rectangle 13"/>
+          <p:cNvPr id="13" name="Rounded Rectangle 12"/>
           <p:cNvSpPr/>
           <p:nvPr/>
         </p:nvSpPr>
@@ -10389,7 +10353,7 @@
       </p:sp>
       <p:sp>
         <p:nvSpPr>
-          <p:cNvPr id="15" name="TextBox 14"/>
+          <p:cNvPr id="14" name="TextBox 13"/>
           <p:cNvSpPr txBox="1"/>
           <p:nvPr/>
         </p:nvSpPr>
@@ -10418,14 +10382,14 @@
               </a:defRPr>
             </a:pPr>
             <a:r>
-              <a:t>87.5%</a:t>
-            </a:r>
-          </a:p>
-        </p:txBody>
-      </p:sp>
-      <p:sp>
-        <p:nvSpPr>
-          <p:cNvPr id="16" name="TextBox 15"/>
+              <a:t>87.5% — 4 scored f</a:t>
+            </a:r>
+          </a:p>
+        </p:txBody>
+      </p:sp>
+      <p:sp>
+        <p:nvSpPr>
+          <p:cNvPr id="15" name="TextBox 14"/>
           <p:cNvSpPr txBox="1"/>
           <p:nvPr/>
         </p:nvSpPr>
@@ -10461,43 +10425,7 @@
       </p:sp>
       <p:sp>
         <p:nvSpPr>
-          <p:cNvPr id="17" name="TextBox 16"/>
-          <p:cNvSpPr txBox="1"/>
-          <p:nvPr/>
-        </p:nvSpPr>
-        <p:spPr>
-          <a:xfrm>
-            <a:off x="557784" y="3364992"/>
-            <a:ext cx="1581912" cy="256032"/>
-          </a:xfrm>
-          <a:prstGeom prst="rect">
-            <a:avLst/>
-          </a:prstGeom>
-          <a:noFill/>
-        </p:spPr>
-        <p:txBody>
-          <a:bodyPr wrap="square">
-            <a:spAutoFit/>
-          </a:bodyPr>
-          <a:lstStyle/>
-          <a:p>
-            <a:pPr algn="ctr">
-              <a:defRPr sz="700">
-                <a:solidFill>
-                  <a:srgbClr val="94A3B8"/>
-                </a:solidFill>
-                <a:latin typeface="Calibri"/>
-              </a:defRPr>
-            </a:pPr>
-            <a:r>
-              <a:t>4 scored from PR diff mapping — Jira acceptance criteri</a:t>
-            </a:r>
-          </a:p>
-        </p:txBody>
-      </p:sp>
-      <p:sp>
-        <p:nvSpPr>
-          <p:cNvPr id="18" name="Rounded Rectangle 17"/>
+          <p:cNvPr id="16" name="Rounded Rectangle 15"/>
           <p:cNvSpPr/>
           <p:nvPr/>
         </p:nvSpPr>
@@ -10540,7 +10468,7 @@
       </p:sp>
       <p:sp>
         <p:nvSpPr>
-          <p:cNvPr id="19" name="TextBox 18"/>
+          <p:cNvPr id="17" name="TextBox 16"/>
           <p:cNvSpPr txBox="1"/>
           <p:nvPr/>
         </p:nvSpPr>
@@ -10569,14 +10497,14 @@
               </a:defRPr>
             </a:pPr>
             <a:r>
-              <a:t>83.3%</a:t>
-            </a:r>
-          </a:p>
-        </p:txBody>
-      </p:sp>
-      <p:sp>
-        <p:nvSpPr>
-          <p:cNvPr id="20" name="TextBox 19"/>
+              <a:t>83.3% — auto-mappe</a:t>
+            </a:r>
+          </a:p>
+        </p:txBody>
+      </p:sp>
+      <p:sp>
+        <p:nvSpPr>
+          <p:cNvPr id="18" name="TextBox 17"/>
           <p:cNvSpPr txBox="1"/>
           <p:nvPr/>
         </p:nvSpPr>
@@ -10612,43 +10540,7 @@
       </p:sp>
       <p:sp>
         <p:nvSpPr>
-          <p:cNvPr id="21" name="TextBox 20"/>
-          <p:cNvSpPr txBox="1"/>
-          <p:nvPr/>
-        </p:nvSpPr>
-        <p:spPr>
-          <a:xfrm>
-            <a:off x="2340864" y="3364992"/>
-            <a:ext cx="1581912" cy="256032"/>
-          </a:xfrm>
-          <a:prstGeom prst="rect">
-            <a:avLst/>
-          </a:prstGeom>
-          <a:noFill/>
-        </p:spPr>
-        <p:txBody>
-          <a:bodyPr wrap="square">
-            <a:spAutoFit/>
-          </a:bodyPr>
-          <a:lstStyle/>
-          <a:p>
-            <a:pPr algn="ctr">
-              <a:defRPr sz="700">
-                <a:solidFill>
-                  <a:srgbClr val="94A3B8"/>
-                </a:solidFill>
-                <a:latin typeface="Calibri"/>
-              </a:defRPr>
-            </a:pPr>
-            <a:r>
-              <a:t>auto-mapped from PR test files — unit &amp; integration tes</a:t>
-            </a:r>
-          </a:p>
-        </p:txBody>
-      </p:sp>
-      <p:sp>
-        <p:nvSpPr>
-          <p:cNvPr id="22" name="Rounded Rectangle 21"/>
+          <p:cNvPr id="19" name="Rounded Rectangle 18"/>
           <p:cNvSpPr/>
           <p:nvPr/>
         </p:nvSpPr>
@@ -10691,7 +10583,7 @@
       </p:sp>
       <p:sp>
         <p:nvSpPr>
-          <p:cNvPr id="23" name="TextBox 22"/>
+          <p:cNvPr id="20" name="TextBox 19"/>
           <p:cNvSpPr txBox="1"/>
           <p:nvPr/>
         </p:nvSpPr>
@@ -10727,7 +10619,7 @@
       </p:sp>
       <p:sp>
         <p:nvSpPr>
-          <p:cNvPr id="24" name="TextBox 23"/>
+          <p:cNvPr id="21" name="TextBox 20"/>
           <p:cNvSpPr txBox="1"/>
           <p:nvPr/>
         </p:nvSpPr>
@@ -10763,43 +10655,7 @@
       </p:sp>
       <p:sp>
         <p:nvSpPr>
-          <p:cNvPr id="25" name="TextBox 24"/>
-          <p:cNvSpPr txBox="1"/>
-          <p:nvPr/>
-        </p:nvSpPr>
-        <p:spPr>
-          <a:xfrm>
-            <a:off x="4123944" y="3364992"/>
-            <a:ext cx="1581912" cy="256032"/>
-          </a:xfrm>
-          <a:prstGeom prst="rect">
-            <a:avLst/>
-          </a:prstGeom>
-          <a:noFill/>
-        </p:spPr>
-        <p:txBody>
-          <a:bodyPr wrap="square">
-            <a:spAutoFit/>
-          </a:bodyPr>
-          <a:lstStyle/>
-          <a:p>
-            <a:pPr algn="ctr">
-              <a:defRPr sz="700">
-                <a:solidFill>
-                  <a:srgbClr val="94A3B8"/>
-                </a:solidFill>
-                <a:latin typeface="Calibri"/>
-              </a:defRPr>
-            </a:pPr>
-            <a:r>
-              <a:t>Jira + LADR from test plan cache — acceptance criteria </a:t>
-            </a:r>
-          </a:p>
-        </p:txBody>
-      </p:sp>
-      <p:sp>
-        <p:nvSpPr>
-          <p:cNvPr id="26" name="Rounded Rectangle 25"/>
+          <p:cNvPr id="22" name="Rounded Rectangle 21"/>
           <p:cNvSpPr/>
           <p:nvPr/>
         </p:nvSpPr>
@@ -10854,7 +10710,7 @@
       </p:sp>
       <p:sp>
         <p:nvSpPr>
-          <p:cNvPr id="27" name="Rounded Rectangle 26"/>
+          <p:cNvPr id="23" name="Rounded Rectangle 22"/>
           <p:cNvSpPr/>
           <p:nvPr/>
         </p:nvSpPr>
@@ -10867,7 +10723,7 @@
             <a:avLst/>
           </a:prstGeom>
           <a:solidFill>
-            <a:srgbClr val="FFEDD5"/>
+            <a:srgbClr val="DCFCE7"/>
           </a:solidFill>
           <a:ln w="6350">
             <a:noFill/>
@@ -10897,7 +10753,7 @@
       </p:sp>
       <p:sp>
         <p:nvSpPr>
-          <p:cNvPr id="28" name="TextBox 27"/>
+          <p:cNvPr id="24" name="TextBox 23"/>
           <p:cNvSpPr txBox="1"/>
           <p:nvPr/>
         </p:nvSpPr>
@@ -10920,20 +10776,20 @@
             <a:pPr algn="ctr">
               <a:defRPr sz="2000" b="1">
                 <a:solidFill>
-                  <a:srgbClr val="D97706"/>
-                </a:solidFill>
-                <a:latin typeface="Calibri"/>
-              </a:defRPr>
-            </a:pPr>
-            <a:r>
-              <a:t>77.8%</a:t>
-            </a:r>
-          </a:p>
-        </p:txBody>
-      </p:sp>
-      <p:sp>
-        <p:nvSpPr>
-          <p:cNvPr id="29" name="TextBox 28"/>
+                  <a:srgbClr val="16A34A"/>
+                </a:solidFill>
+                <a:latin typeface="Calibri"/>
+              </a:defRPr>
+            </a:pPr>
+            <a:r>
+              <a:t>77.8% — 5 test cas</a:t>
+            </a:r>
+          </a:p>
+        </p:txBody>
+      </p:sp>
+      <p:sp>
+        <p:nvSpPr>
+          <p:cNvPr id="25" name="TextBox 24"/>
           <p:cNvSpPr txBox="1"/>
           <p:nvPr/>
         </p:nvSpPr>
@@ -10969,43 +10825,7 @@
       </p:sp>
       <p:sp>
         <p:nvSpPr>
-          <p:cNvPr id="30" name="TextBox 29"/>
-          <p:cNvSpPr txBox="1"/>
-          <p:nvPr/>
-        </p:nvSpPr>
-        <p:spPr>
-          <a:xfrm>
-            <a:off x="6272784" y="3364992"/>
-            <a:ext cx="1581912" cy="256032"/>
-          </a:xfrm>
-          <a:prstGeom prst="rect">
-            <a:avLst/>
-          </a:prstGeom>
-          <a:noFill/>
-        </p:spPr>
-        <p:txBody>
-          <a:bodyPr wrap="square">
-            <a:spAutoFit/>
-          </a:bodyPr>
-          <a:lstStyle/>
-          <a:p>
-            <a:pPr algn="ctr">
-              <a:defRPr sz="700">
-                <a:solidFill>
-                  <a:srgbClr val="94A3B8"/>
-                </a:solidFill>
-                <a:latin typeface="Calibri"/>
-              </a:defRPr>
-            </a:pPr>
-            <a:r>
-              <a:t>5 test cases · 5/5 full Given When Then · 4/5 LADR scen</a:t>
-            </a:r>
-          </a:p>
-        </p:txBody>
-      </p:sp>
-      <p:sp>
-        <p:nvSpPr>
-          <p:cNvPr id="31" name="Rounded Rectangle 30"/>
+          <p:cNvPr id="26" name="Rounded Rectangle 25"/>
           <p:cNvSpPr/>
           <p:nvPr/>
         </p:nvSpPr>
@@ -11018,7 +10838,7 @@
             <a:avLst/>
           </a:prstGeom>
           <a:solidFill>
-            <a:srgbClr val="FFFFFF"/>
+            <a:srgbClr val="FFEDEA"/>
           </a:solidFill>
           <a:ln w="6350">
             <a:noFill/>
@@ -11048,7 +10868,7 @@
       </p:sp>
       <p:sp>
         <p:nvSpPr>
-          <p:cNvPr id="32" name="TextBox 31"/>
+          <p:cNvPr id="27" name="TextBox 26"/>
           <p:cNvSpPr txBox="1"/>
           <p:nvPr/>
         </p:nvSpPr>
@@ -11071,20 +10891,20 @@
             <a:pPr algn="ctr">
               <a:defRPr sz="2000" b="1">
                 <a:solidFill>
-                  <a:srgbClr val="1A1A1A"/>
-                </a:solidFill>
-                <a:latin typeface="Calibri"/>
-              </a:defRPr>
-            </a:pPr>
-            <a:r>
-              <a:t>2 item(s)</a:t>
-            </a:r>
-          </a:p>
-        </p:txBody>
-      </p:sp>
-      <p:sp>
-        <p:nvSpPr>
-          <p:cNvPr id="33" name="TextBox 32"/>
+                  <a:srgbClr val="FF5E4F"/>
+                </a:solidFill>
+                <a:latin typeface="Calibri"/>
+              </a:defRPr>
+            </a:pPr>
+            <a:r>
+              <a:t>2 item(s) — E2E, m</a:t>
+            </a:r>
+          </a:p>
+        </p:txBody>
+      </p:sp>
+      <p:sp>
+        <p:nvSpPr>
+          <p:cNvPr id="28" name="TextBox 27"/>
           <p:cNvSpPr txBox="1"/>
           <p:nvPr/>
         </p:nvSpPr>
@@ -11120,43 +10940,7 @@
       </p:sp>
       <p:sp>
         <p:nvSpPr>
-          <p:cNvPr id="34" name="TextBox 33"/>
-          <p:cNvSpPr txBox="1"/>
-          <p:nvPr/>
-        </p:nvSpPr>
-        <p:spPr>
-          <a:xfrm>
-            <a:off x="8055864" y="3364992"/>
-            <a:ext cx="1581912" cy="256032"/>
-          </a:xfrm>
-          <a:prstGeom prst="rect">
-            <a:avLst/>
-          </a:prstGeom>
-          <a:noFill/>
-        </p:spPr>
-        <p:txBody>
-          <a:bodyPr wrap="square">
-            <a:spAutoFit/>
-          </a:bodyPr>
-          <a:lstStyle/>
-          <a:p>
-            <a:pPr algn="ctr">
-              <a:defRPr sz="700">
-                <a:solidFill>
-                  <a:srgbClr val="94A3B8"/>
-                </a:solidFill>
-                <a:latin typeface="Calibri"/>
-              </a:defRPr>
-            </a:pPr>
-            <a:r>
-              <a:t>E2E, manual, or regression still required</a:t>
-            </a:r>
-          </a:p>
-        </p:txBody>
-      </p:sp>
-      <p:sp>
-        <p:nvSpPr>
-          <p:cNvPr id="35" name="Rounded Rectangle 34"/>
+          <p:cNvPr id="29" name="Rounded Rectangle 28"/>
           <p:cNvSpPr/>
           <p:nvPr/>
         </p:nvSpPr>
@@ -11199,7 +10983,7 @@
       </p:sp>
       <p:sp>
         <p:nvSpPr>
-          <p:cNvPr id="36" name="TextBox 35"/>
+          <p:cNvPr id="30" name="TextBox 29"/>
           <p:cNvSpPr txBox="1"/>
           <p:nvPr/>
         </p:nvSpPr>
@@ -11228,14 +11012,14 @@
               </a:defRPr>
             </a:pPr>
             <a:r>
-              <a:t>0 High · 1 Med</a:t>
-            </a:r>
-          </a:p>
-        </p:txBody>
-      </p:sp>
-      <p:sp>
-        <p:nvSpPr>
-          <p:cNvPr id="37" name="TextBox 36"/>
+              <a:t>0 High · 1 Med — a</a:t>
+            </a:r>
+          </a:p>
+        </p:txBody>
+      </p:sp>
+      <p:sp>
+        <p:nvSpPr>
+          <p:cNvPr id="31" name="TextBox 30"/>
           <p:cNvSpPr txBox="1"/>
           <p:nvPr/>
         </p:nvSpPr>
@@ -11271,43 +11055,7 @@
       </p:sp>
       <p:sp>
         <p:nvSpPr>
-          <p:cNvPr id="38" name="TextBox 37"/>
-          <p:cNvSpPr txBox="1"/>
-          <p:nvPr/>
-        </p:nvSpPr>
-        <p:spPr>
-          <a:xfrm>
-            <a:off x="9838944" y="3364992"/>
-            <a:ext cx="1581912" cy="256032"/>
-          </a:xfrm>
-          <a:prstGeom prst="rect">
-            <a:avLst/>
-          </a:prstGeom>
-          <a:noFill/>
-        </p:spPr>
-        <p:txBody>
-          <a:bodyPr wrap="square">
-            <a:spAutoFit/>
-          </a:bodyPr>
-          <a:lstStyle/>
-          <a:p>
-            <a:pPr algn="ctr">
-              <a:defRPr sz="700">
-                <a:solidFill>
-                  <a:srgbClr val="94A3B8"/>
-                </a:solidFill>
-                <a:latin typeface="Calibri"/>
-              </a:defRPr>
-            </a:pPr>
-            <a:r>
-              <a:t>auto-detected from mapping and test plan — from impleme</a:t>
-            </a:r>
-          </a:p>
-        </p:txBody>
-      </p:sp>
-      <p:sp>
-        <p:nvSpPr>
-          <p:cNvPr id="39" name="Rounded Rectangle 38"/>
+          <p:cNvPr id="32" name="Rounded Rectangle 31"/>
           <p:cNvSpPr/>
           <p:nvPr/>
         </p:nvSpPr>
@@ -11362,7 +11110,7 @@
       </p:sp>
       <p:sp>
         <p:nvSpPr>
-          <p:cNvPr id="40" name="Rounded Rectangle 39"/>
+          <p:cNvPr id="33" name="Rounded Rectangle 32"/>
           <p:cNvSpPr/>
           <p:nvPr/>
         </p:nvSpPr>
@@ -11405,7 +11153,7 @@
       </p:sp>
       <p:sp>
         <p:nvSpPr>
-          <p:cNvPr id="41" name="TextBox 40"/>
+          <p:cNvPr id="34" name="TextBox 33"/>
           <p:cNvSpPr txBox="1"/>
           <p:nvPr/>
         </p:nvSpPr>
@@ -11434,14 +11182,14 @@
               </a:defRPr>
             </a:pPr>
             <a:r>
-              <a:t>95.3%</a:t>
-            </a:r>
-          </a:p>
-        </p:txBody>
-      </p:sp>
-      <p:sp>
-        <p:nvSpPr>
-          <p:cNvPr id="42" name="TextBox 41"/>
+              <a:t>95.3% — SonarQube </a:t>
+            </a:r>
+          </a:p>
+        </p:txBody>
+      </p:sp>
+      <p:sp>
+        <p:nvSpPr>
+          <p:cNvPr id="35" name="TextBox 34"/>
           <p:cNvSpPr txBox="1"/>
           <p:nvPr/>
         </p:nvSpPr>
@@ -11477,43 +11225,7 @@
       </p:sp>
       <p:sp>
         <p:nvSpPr>
-          <p:cNvPr id="43" name="TextBox 42"/>
-          <p:cNvSpPr txBox="1"/>
-          <p:nvPr/>
-        </p:nvSpPr>
-        <p:spPr>
-          <a:xfrm>
-            <a:off x="4398264" y="4828032"/>
-            <a:ext cx="1581912" cy="256032"/>
-          </a:xfrm>
-          <a:prstGeom prst="rect">
-            <a:avLst/>
-          </a:prstGeom>
-          <a:noFill/>
-        </p:spPr>
-        <p:txBody>
-          <a:bodyPr wrap="square">
-            <a:spAutoFit/>
-          </a:bodyPr>
-          <a:lstStyle/>
-          <a:p>
-            <a:pPr algn="ctr">
-              <a:defRPr sz="700">
-                <a:solidFill>
-                  <a:srgbClr val="94A3B8"/>
-                </a:solidFill>
-                <a:latin typeface="Calibri"/>
-              </a:defRPr>
-            </a:pPr>
-            <a:r>
-              <a:t>SonarQube new code line coverage (PR)</a:t>
-            </a:r>
-          </a:p>
-        </p:txBody>
-      </p:sp>
-      <p:sp>
-        <p:nvSpPr>
-          <p:cNvPr id="44" name="Rounded Rectangle 43"/>
+          <p:cNvPr id="36" name="Rounded Rectangle 35"/>
           <p:cNvSpPr/>
           <p:nvPr/>
         </p:nvSpPr>
@@ -11556,7 +11268,7 @@
       </p:sp>
       <p:sp>
         <p:nvSpPr>
-          <p:cNvPr id="45" name="TextBox 44"/>
+          <p:cNvPr id="37" name="TextBox 36"/>
           <p:cNvSpPr txBox="1"/>
           <p:nvPr/>
         </p:nvSpPr>
@@ -11585,14 +11297,14 @@
               </a:defRPr>
             </a:pPr>
             <a:r>
-              <a:t>94.5%</a:t>
-            </a:r>
-          </a:p>
-        </p:txBody>
-      </p:sp>
-      <p:sp>
-        <p:nvSpPr>
-          <p:cNvPr id="46" name="TextBox 45"/>
+              <a:t>94.5% — SonarQube </a:t>
+            </a:r>
+          </a:p>
+        </p:txBody>
+      </p:sp>
+      <p:sp>
+        <p:nvSpPr>
+          <p:cNvPr id="38" name="TextBox 37"/>
           <p:cNvSpPr txBox="1"/>
           <p:nvPr/>
         </p:nvSpPr>
@@ -11622,42 +11334,6 @@
             </a:pPr>
             <a:r>
               <a:t>CI branch</a:t>
-            </a:r>
-          </a:p>
-        </p:txBody>
-      </p:sp>
-      <p:sp>
-        <p:nvSpPr>
-          <p:cNvPr id="47" name="TextBox 46"/>
-          <p:cNvSpPr txBox="1"/>
-          <p:nvPr/>
-        </p:nvSpPr>
-        <p:spPr>
-          <a:xfrm>
-            <a:off x="6181344" y="4828032"/>
-            <a:ext cx="1581912" cy="256032"/>
-          </a:xfrm>
-          <a:prstGeom prst="rect">
-            <a:avLst/>
-          </a:prstGeom>
-          <a:noFill/>
-        </p:spPr>
-        <p:txBody>
-          <a:bodyPr wrap="square">
-            <a:spAutoFit/>
-          </a:bodyPr>
-          <a:lstStyle/>
-          <a:p>
-            <a:pPr algn="ctr">
-              <a:defRPr sz="700">
-                <a:solidFill>
-                  <a:srgbClr val="94A3B8"/>
-                </a:solidFill>
-                <a:latin typeface="Calibri"/>
-              </a:defRPr>
-            </a:pPr>
-            <a:r>
-              <a:t>SonarQube overall line coverage</a:t>
             </a:r>
           </a:p>
         </p:txBody>
@@ -11851,7 +11527,7 @@
               </a:defRPr>
             </a:pPr>
             <a:r>
-              <a:t>MSC-205625 · live HTML report section</a:t>
+              <a:t>MSC-205625 Â· live HTML report section</a:t>
             </a:r>
           </a:p>
         </p:txBody>
@@ -11930,7 +11606,7 @@
               </a:defRPr>
             </a:pPr>
             <a:r>
-              <a:t>©LTM  |  Privileged and Confidential  |  MSC Dev Code and QA Test Coverage Validator  |  Developed by Mayur Gunjal</a:t>
+              <a:t>Â©LTM  |  Privileged and Confidential  |  MSC Dev Code and QA Test Coverage Validator  |  Developed by Mayur Gunjal</a:t>
             </a:r>
           </a:p>
         </p:txBody>
@@ -12047,7 +11723,7 @@
               </a:defRPr>
             </a:pPr>
             <a:r>
-              <a:t>#161  ·  wbd-msc/pegasus-pick-genie  ·  MERGED</a:t>
+              <a:t>#161  Â·  wbd-msc/pegasus-pick-genie  Â·  MERGED</a:t>
             </a:r>
           </a:p>
         </p:txBody>
@@ -12200,7 +11876,7 @@
               </a:defRPr>
             </a:pPr>
             <a:r>
-              <a:t>#195  ·  wbd-msc/pegasus-encode-monitor  ·  MERGED</a:t>
+              <a:t>#195  Â·  wbd-msc/pegasus-encode-monitor  Â·  MERGED</a:t>
             </a:r>
           </a:p>
         </p:txBody>
@@ -12466,7 +12142,7 @@
               </a:defRPr>
             </a:pPr>
             <a:r>
-              <a:t>MSC-205625 · live HTML report section</a:t>
+              <a:t>MSC-205625 Â· live HTML report section</a:t>
             </a:r>
           </a:p>
         </p:txBody>
@@ -12545,7 +12221,7 @@
               </a:defRPr>
             </a:pPr>
             <a:r>
-              <a:t>©LTM  |  Privileged and Confidential  |  MSC Dev Code and QA Test Coverage Validator  |  Developed by Mayur Gunjal</a:t>
+              <a:t>Â©LTM  |  Privileged and Confidential  |  MSC Dev Code and QA Test Coverage Validator  |  Developed by Mayur Gunjal</a:t>
             </a:r>
           </a:p>
         </p:txBody>
@@ -14602,7 +14278,7 @@
               </a:defRPr>
             </a:pPr>
             <a:r>
-              <a:t>©LTM  |  Privileged and Confidential  |  MSC Dev Code and QA Test Coverage Validator  |  Developed by Mayur Gunjal</a:t>
+              <a:t>Â©LTM  |  Privileged and Confidential  |  MSC Dev Code and QA Test Coverage Validator  |  Developed by Mayur Gunjal</a:t>
             </a:r>
           </a:p>
         </p:txBody>
@@ -15120,7 +14796,7 @@
               </a:defRPr>
             </a:pPr>
             <a:r>
-              <a:t>MSC-205625 · live HTML report section</a:t>
+              <a:t>MSC-205625 Â· live HTML report section</a:t>
             </a:r>
           </a:p>
         </p:txBody>
@@ -15199,7 +14875,7 @@
               </a:defRPr>
             </a:pPr>
             <a:r>
-              <a:t>©LTM  |  Privileged and Confidential  |  MSC Dev Code and QA Test Coverage Validator  |  Developed by Mayur Gunjal</a:t>
+              <a:t>Â©LTM  |  Privileged and Confidential  |  MSC Dev Code and QA Test Coverage Validator  |  Developed by Mayur Gunjal</a:t>
             </a:r>
           </a:p>
         </p:txBody>
@@ -17079,7 +16755,7 @@
               </a:defRPr>
             </a:pPr>
             <a:r>
-              <a:t>MSC-205625 · live HTML report section</a:t>
+              <a:t>MSC-205625 Â· live HTML report section</a:t>
             </a:r>
           </a:p>
         </p:txBody>
@@ -17158,7 +16834,7 @@
               </a:defRPr>
             </a:pPr>
             <a:r>
-              <a:t>©LTM  |  Privileged and Confidential  |  MSC Dev Code and QA Test Coverage Validator  |  Developed by Mayur Gunjal</a:t>
+              <a:t>Â©LTM  |  Privileged and Confidential  |  MSC Dev Code and QA Test Coverage Validator  |  Developed by Mayur Gunjal</a:t>
             </a:r>
           </a:p>
         </p:txBody>
@@ -17278,7 +16954,7 @@
               </a:defRPr>
             </a:pPr>
             <a:r>
-              <a:t>✓ Strengths</a:t>
+              <a:t>âœ“ Strengths</a:t>
             </a:r>
           </a:p>
           <a:p>
@@ -17378,7 +17054,7 @@
               </a:defRPr>
             </a:pPr>
             <a:r>
-              <a:t>⚠ Gaps</a:t>
+              <a:t>âš  Gaps</a:t>
             </a:r>
           </a:p>
           <a:p>
@@ -17588,7 +17264,7 @@
               </a:defRPr>
             </a:pPr>
             <a:r>
-              <a:t>MSC-205625 · live HTML report section</a:t>
+              <a:t>MSC-205625 Â· live HTML report section</a:t>
             </a:r>
           </a:p>
         </p:txBody>
@@ -17667,7 +17343,7 @@
               </a:defRPr>
             </a:pPr>
             <a:r>
-              <a:t>©LTM  |  Privileged and Confidential  |  MSC Dev Code and QA Test Coverage Validator  |  Developed by Mayur Gunjal</a:t>
+              <a:t>Â©LTM  |  Privileged and Confidential  |  MSC Dev Code and QA Test Coverage Validator  |  Developed by Mayur Gunjal</a:t>
             </a:r>
           </a:p>
         </p:txBody>
@@ -20149,7 +19825,7 @@
               </a:defRPr>
             </a:pPr>
             <a:r>
-              <a:t>MSC-205625 · live HTML report section</a:t>
+              <a:t>MSC-205625 Â· live HTML report section</a:t>
             </a:r>
           </a:p>
         </p:txBody>
@@ -20228,7 +19904,7 @@
               </a:defRPr>
             </a:pPr>
             <a:r>
-              <a:t>©LTM  |  Privileged and Confidential  |  MSC Dev Code and QA Test Coverage Validator  |  Developed by Mayur Gunjal</a:t>
+              <a:t>Â©LTM  |  Privileged and Confidential  |  MSC Dev Code and QA Test Coverage Validator  |  Developed by Mayur Gunjal</a:t>
             </a:r>
           </a:p>
         </p:txBody>
@@ -20265,139 +19941,6 @@
             </a:pPr>
             <a:r>
               <a:t>20</a:t>
-            </a:r>
-          </a:p>
-        </p:txBody>
-      </p:sp>
-      <p:sp>
-        <p:nvSpPr>
-          <p:cNvPr id="9" name="Rounded Rectangle 8"/>
-          <p:cNvSpPr/>
-          <p:nvPr/>
-        </p:nvSpPr>
-        <p:spPr>
-          <a:xfrm>
-            <a:off x="502920" y="1261872"/>
-            <a:ext cx="11155680" cy="658368"/>
-          </a:xfrm>
-          <a:prstGeom prst="roundRect">
-            <a:avLst/>
-          </a:prstGeom>
-          <a:solidFill>
-            <a:srgbClr val="F2F2F2"/>
-          </a:solidFill>
-          <a:ln w="6350">
-            <a:solidFill>
-              <a:srgbClr val="E2E8F0"/>
-            </a:solidFill>
-          </a:ln>
-        </p:spPr>
-        <p:style>
-          <a:lnRef idx="1">
-            <a:schemeClr val="accent1"/>
-          </a:lnRef>
-          <a:fillRef idx="3">
-            <a:schemeClr val="accent1"/>
-          </a:fillRef>
-          <a:effectRef idx="2">
-            <a:schemeClr val="accent1"/>
-          </a:effectRef>
-          <a:fontRef idx="minor">
-            <a:schemeClr val="lt1"/>
-          </a:fontRef>
-        </p:style>
-        <p:txBody>
-          <a:bodyPr rtlCol="0" anchor="ctr"/>
-          <a:lstStyle/>
-          <a:p>
-            <a:pPr algn="ctr"/>
-          </a:p>
-        </p:txBody>
-      </p:sp>
-      <p:sp>
-        <p:nvSpPr>
-          <p:cNvPr id="10" name="Oval 9"/>
-          <p:cNvSpPr/>
-          <p:nvPr/>
-        </p:nvSpPr>
-        <p:spPr>
-          <a:xfrm>
-            <a:off x="640080" y="1389888"/>
-            <a:ext cx="384048" cy="384048"/>
-          </a:xfrm>
-          <a:prstGeom prst="ellipse">
-            <a:avLst/>
-          </a:prstGeom>
-          <a:solidFill>
-            <a:srgbClr val="FFC000"/>
-          </a:solidFill>
-          <a:ln>
-            <a:noFill/>
-          </a:ln>
-        </p:spPr>
-        <p:style>
-          <a:lnRef idx="1">
-            <a:schemeClr val="accent1"/>
-          </a:lnRef>
-          <a:fillRef idx="3">
-            <a:schemeClr val="accent1"/>
-          </a:fillRef>
-          <a:effectRef idx="2">
-            <a:schemeClr val="accent1"/>
-          </a:effectRef>
-          <a:fontRef idx="minor">
-            <a:schemeClr val="lt1"/>
-          </a:fontRef>
-        </p:style>
-        <p:txBody>
-          <a:bodyPr rtlCol="0" anchor="ctr"/>
-          <a:lstStyle/>
-          <a:p>
-            <a:pPr algn="ctr">
-              <a:defRPr sz="1200" b="1">
-                <a:solidFill>
-                  <a:srgbClr val="04066C"/>
-                </a:solidFill>
-              </a:defRPr>
-            </a:pPr>
-            <a:r>
-              <a:t>1</a:t>
-            </a:r>
-          </a:p>
-        </p:txBody>
-      </p:sp>
-      <p:sp>
-        <p:nvSpPr>
-          <p:cNvPr id="11" name="TextBox 10"/>
-          <p:cNvSpPr txBox="1"/>
-          <p:nvPr/>
-        </p:nvSpPr>
-        <p:spPr>
-          <a:xfrm>
-            <a:off x="1143000" y="1371600"/>
-            <a:ext cx="10241280" cy="457200"/>
-          </a:xfrm>
-          <a:prstGeom prst="rect">
-            <a:avLst/>
-          </a:prstGeom>
-          <a:noFill/>
-        </p:spPr>
-        <p:txBody>
-          <a:bodyPr wrap="none">
-            <a:spAutoFit/>
-          </a:bodyPr>
-          <a:lstStyle/>
-          <a:p>
-            <a:pPr>
-              <a:defRPr sz="1200">
-                <a:solidFill>
-                  <a:srgbClr val="04066C"/>
-                </a:solidFill>
-                <a:latin typeface="Calibri"/>
-              </a:defRPr>
-            </a:pPr>
-            <a:r>
-              <a:t>Review §5 traceability and run QA-scoped test plan cases only (see §4).</a:t>
             </a:r>
           </a:p>
         </p:txBody>
@@ -20502,7 +20045,7 @@
               </a:defRPr>
             </a:pPr>
             <a:r>
-              <a:t>©LTM  |  Privileged and Confidential  |  MSC Dev Code and QA Test Coverage Validator  |  Developed by Mayur Gunjal</a:t>
+              <a:t>Â©LTM  |  Privileged and Confidential  |  MSC Dev Code and QA Test Coverage Validator  |  Developed by Mayur Gunjal</a:t>
             </a:r>
           </a:p>
         </p:txBody>
@@ -20653,7 +20196,7 @@
               </a:defRPr>
             </a:pPr>
             <a:r>
-              <a:t>Four production runs · featured story MSC-205625 (this deck)</a:t>
+              <a:t>Four production runs Â· featured story MSC-205625 (this deck)</a:t>
             </a:r>
           </a:p>
         </p:txBody>
@@ -21323,7 +20866,7 @@
               </a:defRPr>
             </a:pPr>
             <a:r>
-              <a:t>Story · In QA</a:t>
+              <a:t>Story Â· In QA</a:t>
             </a:r>
           </a:p>
         </p:txBody>
@@ -21543,7 +21086,7 @@
               </a:defRPr>
             </a:pPr>
             <a:r>
-              <a:t>LADR requirements in cache · PR #99 pegasus-part</a:t>
+              <a:t>PR #99 pegasus-partner-config-service Â· #148 pe</a:t>
             </a:r>
           </a:p>
         </p:txBody>
@@ -21598,7 +21141,7 @@
               </a:defRPr>
             </a:pPr>
             <a:r>
-              <a:t>★ MSC-205625</a:t>
+              <a:t>â˜… MSC-205625</a:t>
             </a:r>
           </a:p>
         </p:txBody>
@@ -21653,7 +21196,7 @@
               </a:defRPr>
             </a:pPr>
             <a:r>
-              <a:t>Bug · Ready for Rele</a:t>
+              <a:t>Bug Â· Ready for Rel</a:t>
             </a:r>
           </a:p>
         </p:txBody>
@@ -21873,7 +21416,7 @@
               </a:defRPr>
             </a:pPr>
             <a:r>
-              <a:t>LADR requirements in cache · PR #161 pegasus-pic</a:t>
+              <a:t>LADR quick link only (no grooming wiki) Â· PR #1</a:t>
             </a:r>
           </a:p>
         </p:txBody>
@@ -21908,7 +21451,7 @@
               </a:defRPr>
             </a:pPr>
             <a:r>
-              <a:t>★</a:t>
+              <a:t>â˜…</a:t>
             </a:r>
           </a:p>
         </p:txBody>
@@ -22018,7 +21561,7 @@
               </a:defRPr>
             </a:pPr>
             <a:r>
-              <a:t>Story · Ready for Re</a:t>
+              <a:t>Story Â· Ready for R</a:t>
             </a:r>
           </a:p>
         </p:txBody>
@@ -22238,7 +21781,7 @@
               </a:defRPr>
             </a:pPr>
             <a:r>
-              <a:t>LADR Confluence in quick links only · No PR · de</a:t>
+              <a:t>LADR Confluence in quick links only Â· No PR Â· </a:t>
             </a:r>
           </a:p>
         </p:txBody>
@@ -22348,7 +21891,7 @@
               </a:defRPr>
             </a:pPr>
             <a:r>
-              <a:t>Story · Done</a:t>
+              <a:t>Story Â· Done</a:t>
             </a:r>
           </a:p>
         </p:txBody>
@@ -22568,7 +22111,7 @@
               </a:defRPr>
             </a:pPr>
             <a:r>
-              <a:t>LADR requirements in cache · PR #22 pegasus-reps</a:t>
+              <a:t>PR #22 pegasus-reps Â· #75 pegasus-texttransform</a:t>
             </a:r>
           </a:p>
         </p:txBody>
@@ -22780,7 +22323,7 @@
               </a:defRPr>
             </a:pPr>
             <a:r>
-              <a:t>/msc-dev-code-and-qa-test-coverage-validator {YOUR-MSC-KEY}  ·  Developed by Mayur Gunjal</a:t>
+              <a:t>/msc-dev-code-and-qa-test-coverage-validator {YOUR-MSC-KEY}  Â·  Developed by Mayur Gunjal</a:t>
             </a:r>
           </a:p>
         </p:txBody>

</xml_diff>